<commit_message>
Add current-process flow diagram to the eCMRs plan deck
New slide: PIR Email -> Triage -> Create Change Request -> Change
Request Management -> CMR Form -> Notify & Close, as native editable
boxes/arrows matching the deck's existing visual style.
</commit_message>
<xml_diff>
--- a/docs/presentations/eCMRs_plan.pptx
+++ b/docs/presentations/eCMRs_plan.pptx
@@ -12,6 +12,7 @@
     <p:sldId id="257" r:id="rId3"/>
     <p:sldId id="258" r:id="rId4"/>
     <p:sldId id="266" r:id="rId17"/>
+    <p:sldId id="267" r:id="rId18"/>
     <p:sldId id="259" r:id="rId5"/>
     <p:sldId id="260" r:id="rId6"/>
     <p:sldId id="261" r:id="rId7"/>
@@ -2580,6 +2581,1026 @@
               <a:t>Save, notify engineering (follow up after 24 hrs), then send the CMR Number back to the requester.</a:t>
             </a:r>
             <a:endParaRPr lang="en-US" sz="1500" dirty="0"/>
+          </a:p>
+        </p:txBody>
+      </p:sp>
+    </p:spTree>
+  </p:cSld>
+  <p:clrMapOvr>
+    <a:masterClrMapping/>
+  </p:clrMapOvr>
+</p:sld>
+</file>
+
+<file path=ppt/slides/slide12.xml><?xml version="1.0" encoding="utf-8"?>
+<p:sld xmlns:a="http://schemas.openxmlformats.org/drawingml/2006/main" xmlns:r="http://schemas.openxmlformats.org/officeDocument/2006/relationships" xmlns:p="http://schemas.openxmlformats.org/presentationml/2006/main">
+  <p:cSld name="Slide 3">
+    <p:bg>
+      <p:bgPr>
+        <a:solidFill>
+          <a:srgbClr val="F8FAFC"/>
+        </a:solidFill>
+        <a:effectLst/>
+      </p:bgPr>
+    </p:bg>
+    <p:spTree>
+      <p:nvGrpSpPr>
+        <p:cNvPr id="1" name=""/>
+        <p:cNvGrpSpPr/>
+        <p:nvPr/>
+      </p:nvGrpSpPr>
+      <p:grpSpPr>
+        <a:xfrm>
+          <a:off x="0" y="0"/>
+          <a:ext cx="0" cy="0"/>
+          <a:chOff x="0" y="0"/>
+          <a:chExt cx="0" cy="0"/>
+        </a:xfrm>
+      </p:grpSpPr>
+      <p:sp>
+        <p:nvSpPr>
+          <p:cNvPr id="2" name="Shape 0"/>
+          <p:cNvSpPr/>
+          <p:nvPr/>
+        </p:nvSpPr>
+        <p:spPr>
+          <a:xfrm>
+            <a:off x="457200" y="502920"/>
+            <a:ext cx="1371600" cy="1371600"/>
+          </a:xfrm>
+          <a:prstGeom prst="roundRect">
+            <a:avLst>
+              <a:gd name="adj" fmla="val 8000"/>
+            </a:avLst>
+          </a:prstGeom>
+          <a:solidFill>
+            <a:srgbClr val="ECFDF5"/>
+          </a:solidFill>
+          <a:ln w="12700">
+            <a:solidFill>
+              <a:srgbClr val="E2E8F0"/>
+            </a:solidFill>
+            <a:prstDash val="solid"/>
+          </a:ln>
+        </p:spPr>
+        <p:txBody>
+          <a:bodyPr/>
+          <a:lstStyle/>
+          <a:p>
+            <a:endParaRPr lang="en-US"/>
+          </a:p>
+        </p:txBody>
+      </p:sp>
+      <p:pic>
+        <p:nvPicPr>
+          <p:cNvPr id="3" name="Image 0" descr="icons/flow.png"/>
+          <p:cNvPicPr>
+            <a:picLocks noChangeAspect="1"/>
+          </p:cNvPicPr>
+          <p:nvPr/>
+        </p:nvPicPr>
+        <p:blipFill>
+          <a:blip r:embed="rId4"/>
+          <a:stretch>
+            <a:fillRect/>
+          </a:stretch>
+        </p:blipFill>
+        <p:spPr>
+          <a:xfrm>
+            <a:off x="800100" y="845820"/>
+            <a:ext cx="685800" cy="685800"/>
+          </a:xfrm>
+          <a:prstGeom prst="rect">
+            <a:avLst/>
+          </a:prstGeom>
+        </p:spPr>
+      </p:pic>
+      <p:sp>
+        <p:nvSpPr>
+          <p:cNvPr id="4" name="Text 1"/>
+          <p:cNvSpPr/>
+          <p:nvPr/>
+        </p:nvSpPr>
+        <p:spPr>
+          <a:xfrm>
+            <a:off x="2194560" y="502920"/>
+            <a:ext cx="9539935" cy="685800"/>
+          </a:xfrm>
+          <a:prstGeom prst="rect">
+            <a:avLst/>
+          </a:prstGeom>
+          <a:noFill/>
+          <a:ln/>
+        </p:spPr>
+        <p:txBody>
+          <a:bodyPr wrap="square" lIns="0" tIns="0" rIns="0" bIns="0" rtlCol="0" anchor="t"/>
+          <a:lstStyle/>
+          <a:p>
+            <a:pPr marL="0" indent="0" algn="l">
+              <a:buNone/>
+            </a:pPr>
+            <a:r>
+              <a:rPr lang="en-US" sz="3400" b="1" dirty="0">
+                <a:solidFill>
+                  <a:srgbClr val="0F172A"/>
+                </a:solidFill>
+                <a:latin typeface="Cambria" pitchFamily="34" charset="0"/>
+                <a:ea typeface="Cambria" pitchFamily="34" charset="-122"/>
+                <a:cs typeface="Cambria" pitchFamily="34" charset="-120"/>
+              </a:rPr>
+              <a:t>Today’s process flow</a:t>
+            </a:r>
+            <a:endParaRPr lang="en-US" sz="3400" dirty="0"/>
+          </a:p>
+        </p:txBody>
+      </p:sp>
+      <p:sp>
+        <p:nvSpPr>
+          <p:cNvPr id="5" name="Text 2"/>
+          <p:cNvSpPr/>
+          <p:nvPr/>
+        </p:nvSpPr>
+        <p:spPr>
+          <a:xfrm>
+            <a:off x="2194560" y="1216152"/>
+            <a:ext cx="9539935" cy="640080"/>
+          </a:xfrm>
+          <a:prstGeom prst="rect">
+            <a:avLst/>
+          </a:prstGeom>
+          <a:noFill/>
+          <a:ln/>
+        </p:spPr>
+        <p:txBody>
+          <a:bodyPr wrap="square" lIns="0" tIns="0" rIns="0" bIns="0" rtlCol="0" anchor="t"/>
+          <a:lstStyle/>
+          <a:p>
+            <a:pPr marL="0" indent="0" algn="l">
+              <a:buNone/>
+            </a:pPr>
+            <a:r>
+              <a:rPr lang="en-US" sz="1600" dirty="0">
+                <a:solidFill>
+                  <a:srgbClr val="64748B"/>
+                </a:solidFill>
+                <a:latin typeface="Calibri" pitchFamily="34" charset="0"/>
+                <a:ea typeface="Calibri" pitchFamily="34" charset="-122"/>
+                <a:cs typeface="Calibri" pitchFamily="34" charset="-120"/>
+              </a:rPr>
+              <a:t>How a CMR moves through the current three-form process, start to finish.</a:t>
+            </a:r>
+            <a:endParaRPr lang="en-US" sz="1600" dirty="0"/>
+          </a:p>
+        </p:txBody>
+      </p:sp>
+      <p:sp>
+        <p:nvSpPr>
+          <p:cNvPr id="6" name="Shape 3"/>
+          <p:cNvSpPr/>
+          <p:nvPr/>
+        </p:nvSpPr>
+        <p:spPr>
+          <a:xfrm>
+            <a:off x="457200" y="2148840"/>
+            <a:ext cx="11277295" cy="4251960"/>
+          </a:xfrm>
+          <a:prstGeom prst="roundRect">
+            <a:avLst>
+              <a:gd name="adj" fmla="val 2581"/>
+            </a:avLst>
+          </a:prstGeom>
+          <a:solidFill>
+            <a:srgbClr val="FFFFFF"/>
+          </a:solidFill>
+          <a:ln w="12700">
+            <a:solidFill>
+              <a:srgbClr val="E2E8F0"/>
+            </a:solidFill>
+            <a:prstDash val="solid"/>
+          </a:ln>
+          <a:effectLst>
+            <a:outerShdw blurRad="152400" dist="38100" dir="5400000" algn="bl" rotWithShape="0">
+              <a:srgbClr val="1E293B">
+                <a:alpha val="8000"/>
+              </a:srgbClr>
+            </a:outerShdw>
+          </a:effectLst>
+        </p:spPr>
+        <p:txBody>
+          <a:bodyPr/>
+          <a:lstStyle/>
+          <a:p>
+            <a:endParaRPr lang="en-US"/>
+          </a:p>
+        </p:txBody>
+      </p:sp>
+      <p:sp>
+        <p:nvSpPr>
+          <p:cNvPr id="7" name="Text 4"/>
+          <p:cNvSpPr/>
+          <p:nvPr/>
+        </p:nvSpPr>
+        <p:spPr>
+          <a:xfrm>
+            <a:off x="822960" y="2514600"/>
+            <a:ext cx="9144000" cy="365760"/>
+          </a:xfrm>
+          <a:prstGeom prst="rect">
+            <a:avLst/>
+          </a:prstGeom>
+          <a:noFill/>
+          <a:ln/>
+        </p:spPr>
+        <p:txBody>
+          <a:bodyPr wrap="square" lIns="0" tIns="0" rIns="0" bIns="0" rtlCol="0" anchor="t"/>
+          <a:lstStyle/>
+          <a:p>
+            <a:pPr marL="0" indent="0" algn="l">
+              <a:buNone/>
+            </a:pPr>
+            <a:r>
+              <a:rPr lang="en-US" sz="1500" b="1" dirty="0">
+                <a:solidFill>
+                  <a:srgbClr val="059669"/>
+                </a:solidFill>
+                <a:latin typeface="Calibri" pitchFamily="34" charset="0"/>
+                <a:ea typeface="Calibri" pitchFamily="34" charset="-122"/>
+                <a:cs typeface="Calibri" pitchFamily="34" charset="-120"/>
+              </a:rPr>
+              <a:t>Actual process flow</a:t>
+            </a:r>
+            <a:endParaRPr lang="en-US" sz="1500" dirty="0"/>
+          </a:p>
+        </p:txBody>
+      </p:sp>
+      <p:sp>
+        <p:nvSpPr>
+          <p:cNvPr id="100" name="Shape 100"/>
+          <p:cNvSpPr/>
+          <p:nvPr/>
+        </p:nvSpPr>
+        <p:spPr>
+          <a:xfrm>
+            <a:off x="822960" y="2926080"/>
+            <a:ext cx="1490929" cy="1828800"/>
+          </a:xfrm>
+          <a:prstGeom prst="roundRect">
+            <a:avLst>
+              <a:gd name="adj" fmla="val 4438"/>
+            </a:avLst>
+          </a:prstGeom>
+          <a:solidFill>
+            <a:srgbClr val="F8FAFC"/>
+          </a:solidFill>
+          <a:ln w="12700">
+            <a:solidFill>
+              <a:srgbClr val="E2E8F0"/>
+            </a:solidFill>
+            <a:prstDash val="solid"/>
+          </a:ln>
+        </p:spPr>
+        <p:txBody>
+          <a:bodyPr/>
+          <a:lstStyle/>
+          <a:p>
+            <a:endParaRPr lang="en-US"/>
+          </a:p>
+        </p:txBody>
+      </p:sp>
+      <p:sp>
+        <p:nvSpPr>
+          <p:cNvPr id="101" name="Text 101"/>
+          <p:cNvSpPr/>
+          <p:nvPr/>
+        </p:nvSpPr>
+        <p:spPr>
+          <a:xfrm>
+            <a:off x="987552" y="3090672"/>
+            <a:ext cx="1161745" cy="1554480"/>
+          </a:xfrm>
+          <a:prstGeom prst="rect">
+            <a:avLst/>
+          </a:prstGeom>
+          <a:noFill/>
+          <a:ln/>
+        </p:spPr>
+        <p:txBody>
+          <a:bodyPr wrap="square" lIns="0" tIns="0" rIns="0" bIns="0" rtlCol="0" anchor="t"/>
+          <a:lstStyle/>
+          <a:p>
+            <a:pPr marL="0" indent="0">
+              <a:lnSpc>
+                <a:spcPts val="1600"/>
+              </a:lnSpc>
+              <a:buNone/>
+            </a:pPr>
+            <a:r>
+              <a:rPr lang="en-US" sz="1400" b="1" dirty="0">
+                <a:solidFill>
+                  <a:srgbClr val="059669"/>
+                </a:solidFill>
+                <a:latin typeface="Calibri" pitchFamily="34" charset="0"/>
+                <a:ea typeface="Calibri" pitchFamily="34" charset="-122"/>
+                <a:cs typeface="Calibri" pitchFamily="34" charset="-120"/>
+              </a:rPr>
+              <a:t>PIR Email</a:t>
+            </a:r>
+            <a:endParaRPr lang="en-US" sz="1400" dirty="0"/>
+          </a:p>
+          <a:p>
+            <a:pPr marL="0" indent="0">
+              <a:lnSpc>
+                <a:spcPts val="1600"/>
+              </a:lnSpc>
+              <a:buNone/>
+            </a:pPr>
+            <a:r>
+              <a:rPr lang="en-US" sz="1250" dirty="0">
+                <a:solidFill>
+                  <a:srgbClr val="0F172A"/>
+                </a:solidFill>
+                <a:latin typeface="Calibri" pitchFamily="34" charset="0"/>
+                <a:ea typeface="Calibri" pitchFamily="34" charset="-122"/>
+                <a:cs typeface="Calibri" pitchFamily="34" charset="-120"/>
+              </a:rPr>
+              <a:t>Job, Serial #, PN, Part, Issue from Production</a:t>
+            </a:r>
+            <a:endParaRPr lang="en-US" sz="1400" dirty="0"/>
+          </a:p>
+        </p:txBody>
+      </p:sp>
+      <p:sp>
+        <p:nvSpPr>
+          <p:cNvPr id="102" name="Text 102"/>
+          <p:cNvSpPr/>
+          <p:nvPr/>
+        </p:nvSpPr>
+        <p:spPr>
+          <a:xfrm>
+            <a:off x="2313889" y="2926080"/>
+            <a:ext cx="320040" cy="1828800"/>
+          </a:xfrm>
+          <a:prstGeom prst="rect">
+            <a:avLst/>
+          </a:prstGeom>
+          <a:noFill/>
+          <a:ln/>
+        </p:spPr>
+        <p:txBody>
+          <a:bodyPr wrap="square" lIns="0" tIns="0" rIns="0" bIns="0" rtlCol="0" anchor="ctr"/>
+          <a:lstStyle/>
+          <a:p>
+            <a:pPr marL="0" indent="0" algn="ctr">
+              <a:buNone/>
+            </a:pPr>
+            <a:r>
+              <a:rPr lang="en-US" sz="1800" dirty="0">
+                <a:solidFill>
+                  <a:srgbClr val="059669"/>
+                </a:solidFill>
+                <a:latin typeface="Calibri" pitchFamily="34" charset="0"/>
+                <a:ea typeface="Calibri" pitchFamily="34" charset="-122"/>
+                <a:cs typeface="Calibri" pitchFamily="34" charset="-120"/>
+              </a:rPr>
+              <a:t>→</a:t>
+            </a:r>
+            <a:endParaRPr lang="en-US" sz="1800" dirty="0"/>
+          </a:p>
+        </p:txBody>
+      </p:sp>
+      <p:sp>
+        <p:nvSpPr>
+          <p:cNvPr id="103" name="Shape 103"/>
+          <p:cNvSpPr/>
+          <p:nvPr/>
+        </p:nvSpPr>
+        <p:spPr>
+          <a:xfrm>
+            <a:off x="2633929" y="2926080"/>
+            <a:ext cx="1490929" cy="1828800"/>
+          </a:xfrm>
+          <a:prstGeom prst="roundRect">
+            <a:avLst>
+              <a:gd name="adj" fmla="val 4438"/>
+            </a:avLst>
+          </a:prstGeom>
+          <a:solidFill>
+            <a:srgbClr val="F8FAFC"/>
+          </a:solidFill>
+          <a:ln w="12700">
+            <a:solidFill>
+              <a:srgbClr val="E2E8F0"/>
+            </a:solidFill>
+            <a:prstDash val="solid"/>
+          </a:ln>
+        </p:spPr>
+        <p:txBody>
+          <a:bodyPr/>
+          <a:lstStyle/>
+          <a:p>
+            <a:endParaRPr lang="en-US"/>
+          </a:p>
+        </p:txBody>
+      </p:sp>
+      <p:sp>
+        <p:nvSpPr>
+          <p:cNvPr id="104" name="Text 104"/>
+          <p:cNvSpPr/>
+          <p:nvPr/>
+        </p:nvSpPr>
+        <p:spPr>
+          <a:xfrm>
+            <a:off x="2798521" y="3090672"/>
+            <a:ext cx="1161745" cy="1554480"/>
+          </a:xfrm>
+          <a:prstGeom prst="rect">
+            <a:avLst/>
+          </a:prstGeom>
+          <a:noFill/>
+          <a:ln/>
+        </p:spPr>
+        <p:txBody>
+          <a:bodyPr wrap="square" lIns="0" tIns="0" rIns="0" bIns="0" rtlCol="0" anchor="t"/>
+          <a:lstStyle/>
+          <a:p>
+            <a:pPr marL="0" indent="0">
+              <a:lnSpc>
+                <a:spcPts val="1600"/>
+              </a:lnSpc>
+              <a:buNone/>
+            </a:pPr>
+            <a:r>
+              <a:rPr lang="en-US" sz="1400" b="1" dirty="0">
+                <a:solidFill>
+                  <a:srgbClr val="059669"/>
+                </a:solidFill>
+                <a:latin typeface="Calibri" pitchFamily="34" charset="0"/>
+                <a:ea typeface="Calibri" pitchFamily="34" charset="-122"/>
+                <a:cs typeface="Calibri" pitchFamily="34" charset="-120"/>
+              </a:rPr>
+              <a:t>Triage</a:t>
+            </a:r>
+            <a:endParaRPr lang="en-US" sz="1400" dirty="0"/>
+          </a:p>
+          <a:p>
+            <a:pPr marL="0" indent="0">
+              <a:lnSpc>
+                <a:spcPts val="1600"/>
+              </a:lnSpc>
+              <a:buNone/>
+            </a:pPr>
+            <a:r>
+              <a:rPr lang="en-US" sz="1250" dirty="0">
+                <a:solidFill>
+                  <a:srgbClr val="0F172A"/>
+                </a:solidFill>
+                <a:latin typeface="Calibri" pitchFamily="34" charset="0"/>
+                <a:ea typeface="Calibri" pitchFamily="34" charset="-122"/>
+                <a:cs typeface="Calibri" pitchFamily="34" charset="-120"/>
+              </a:rPr>
+              <a:t>Jasmine decides CMR vs. TRR vs. MRR</a:t>
+            </a:r>
+            <a:endParaRPr lang="en-US" sz="1400" dirty="0"/>
+          </a:p>
+        </p:txBody>
+      </p:sp>
+      <p:sp>
+        <p:nvSpPr>
+          <p:cNvPr id="105" name="Text 105"/>
+          <p:cNvSpPr/>
+          <p:nvPr/>
+        </p:nvSpPr>
+        <p:spPr>
+          <a:xfrm>
+            <a:off x="4124858" y="2926080"/>
+            <a:ext cx="320040" cy="1828800"/>
+          </a:xfrm>
+          <a:prstGeom prst="rect">
+            <a:avLst/>
+          </a:prstGeom>
+          <a:noFill/>
+          <a:ln/>
+        </p:spPr>
+        <p:txBody>
+          <a:bodyPr wrap="square" lIns="0" tIns="0" rIns="0" bIns="0" rtlCol="0" anchor="ctr"/>
+          <a:lstStyle/>
+          <a:p>
+            <a:pPr marL="0" indent="0" algn="ctr">
+              <a:buNone/>
+            </a:pPr>
+            <a:r>
+              <a:rPr lang="en-US" sz="1800" dirty="0">
+                <a:solidFill>
+                  <a:srgbClr val="059669"/>
+                </a:solidFill>
+                <a:latin typeface="Calibri" pitchFamily="34" charset="0"/>
+                <a:ea typeface="Calibri" pitchFamily="34" charset="-122"/>
+                <a:cs typeface="Calibri" pitchFamily="34" charset="-120"/>
+              </a:rPr>
+              <a:t>→</a:t>
+            </a:r>
+            <a:endParaRPr lang="en-US" sz="1800" dirty="0"/>
+          </a:p>
+        </p:txBody>
+      </p:sp>
+      <p:sp>
+        <p:nvSpPr>
+          <p:cNvPr id="106" name="Shape 106"/>
+          <p:cNvSpPr/>
+          <p:nvPr/>
+        </p:nvSpPr>
+        <p:spPr>
+          <a:xfrm>
+            <a:off x="4444898" y="2926080"/>
+            <a:ext cx="1490929" cy="1828800"/>
+          </a:xfrm>
+          <a:prstGeom prst="roundRect">
+            <a:avLst>
+              <a:gd name="adj" fmla="val 4438"/>
+            </a:avLst>
+          </a:prstGeom>
+          <a:solidFill>
+            <a:srgbClr val="F8FAFC"/>
+          </a:solidFill>
+          <a:ln w="12700">
+            <a:solidFill>
+              <a:srgbClr val="E2E8F0"/>
+            </a:solidFill>
+            <a:prstDash val="solid"/>
+          </a:ln>
+        </p:spPr>
+        <p:txBody>
+          <a:bodyPr/>
+          <a:lstStyle/>
+          <a:p>
+            <a:endParaRPr lang="en-US"/>
+          </a:p>
+        </p:txBody>
+      </p:sp>
+      <p:sp>
+        <p:nvSpPr>
+          <p:cNvPr id="107" name="Text 107"/>
+          <p:cNvSpPr/>
+          <p:nvPr/>
+        </p:nvSpPr>
+        <p:spPr>
+          <a:xfrm>
+            <a:off x="4609490" y="3090672"/>
+            <a:ext cx="1161745" cy="1554480"/>
+          </a:xfrm>
+          <a:prstGeom prst="rect">
+            <a:avLst/>
+          </a:prstGeom>
+          <a:noFill/>
+          <a:ln/>
+        </p:spPr>
+        <p:txBody>
+          <a:bodyPr wrap="square" lIns="0" tIns="0" rIns="0" bIns="0" rtlCol="0" anchor="t"/>
+          <a:lstStyle/>
+          <a:p>
+            <a:pPr marL="0" indent="0">
+              <a:lnSpc>
+                <a:spcPts val="1600"/>
+              </a:lnSpc>
+              <a:buNone/>
+            </a:pPr>
+            <a:r>
+              <a:rPr lang="en-US" sz="1400" b="1" dirty="0">
+                <a:solidFill>
+                  <a:srgbClr val="059669"/>
+                </a:solidFill>
+                <a:latin typeface="Calibri" pitchFamily="34" charset="0"/>
+                <a:ea typeface="Calibri" pitchFamily="34" charset="-122"/>
+                <a:cs typeface="Calibri" pitchFamily="34" charset="-120"/>
+              </a:rPr>
+              <a:t>Create Change Request</a:t>
+            </a:r>
+            <a:endParaRPr lang="en-US" sz="1400" dirty="0"/>
+          </a:p>
+          <a:p>
+            <a:pPr marL="0" indent="0">
+              <a:lnSpc>
+                <a:spcPts val="1600"/>
+              </a:lnSpc>
+              <a:buNone/>
+            </a:pPr>
+            <a:r>
+              <a:rPr lang="en-US" sz="1250" dirty="0">
+                <a:solidFill>
+                  <a:srgbClr val="0F172A"/>
+                </a:solidFill>
+                <a:latin typeface="Calibri" pitchFamily="34" charset="0"/>
+                <a:ea typeface="Calibri" pitchFamily="34" charset="-122"/>
+                <a:cs typeface="Calibri" pitchFamily="34" charset="-120"/>
+              </a:rPr>
+              <a:t>Priority, Initial Change, Requested By</a:t>
+            </a:r>
+            <a:endParaRPr lang="en-US" sz="1400" dirty="0"/>
+          </a:p>
+        </p:txBody>
+      </p:sp>
+      <p:sp>
+        <p:nvSpPr>
+          <p:cNvPr id="108" name="Text 108"/>
+          <p:cNvSpPr/>
+          <p:nvPr/>
+        </p:nvSpPr>
+        <p:spPr>
+          <a:xfrm>
+            <a:off x="5935827" y="2926080"/>
+            <a:ext cx="320040" cy="1828800"/>
+          </a:xfrm>
+          <a:prstGeom prst="rect">
+            <a:avLst/>
+          </a:prstGeom>
+          <a:noFill/>
+          <a:ln/>
+        </p:spPr>
+        <p:txBody>
+          <a:bodyPr wrap="square" lIns="0" tIns="0" rIns="0" bIns="0" rtlCol="0" anchor="ctr"/>
+          <a:lstStyle/>
+          <a:p>
+            <a:pPr marL="0" indent="0" algn="ctr">
+              <a:buNone/>
+            </a:pPr>
+            <a:r>
+              <a:rPr lang="en-US" sz="1800" dirty="0">
+                <a:solidFill>
+                  <a:srgbClr val="059669"/>
+                </a:solidFill>
+                <a:latin typeface="Calibri" pitchFamily="34" charset="0"/>
+                <a:ea typeface="Calibri" pitchFamily="34" charset="-122"/>
+                <a:cs typeface="Calibri" pitchFamily="34" charset="-120"/>
+              </a:rPr>
+              <a:t>→</a:t>
+            </a:r>
+            <a:endParaRPr lang="en-US" sz="1800" dirty="0"/>
+          </a:p>
+        </p:txBody>
+      </p:sp>
+      <p:sp>
+        <p:nvSpPr>
+          <p:cNvPr id="109" name="Shape 109"/>
+          <p:cNvSpPr/>
+          <p:nvPr/>
+        </p:nvSpPr>
+        <p:spPr>
+          <a:xfrm>
+            <a:off x="6255867" y="2926080"/>
+            <a:ext cx="1490929" cy="1828800"/>
+          </a:xfrm>
+          <a:prstGeom prst="roundRect">
+            <a:avLst>
+              <a:gd name="adj" fmla="val 4438"/>
+            </a:avLst>
+          </a:prstGeom>
+          <a:solidFill>
+            <a:srgbClr val="F8FAFC"/>
+          </a:solidFill>
+          <a:ln w="12700">
+            <a:solidFill>
+              <a:srgbClr val="E2E8F0"/>
+            </a:solidFill>
+            <a:prstDash val="solid"/>
+          </a:ln>
+        </p:spPr>
+        <p:txBody>
+          <a:bodyPr/>
+          <a:lstStyle/>
+          <a:p>
+            <a:endParaRPr lang="en-US"/>
+          </a:p>
+        </p:txBody>
+      </p:sp>
+      <p:sp>
+        <p:nvSpPr>
+          <p:cNvPr id="110" name="Text 110"/>
+          <p:cNvSpPr/>
+          <p:nvPr/>
+        </p:nvSpPr>
+        <p:spPr>
+          <a:xfrm>
+            <a:off x="6420459" y="3090672"/>
+            <a:ext cx="1161745" cy="1554480"/>
+          </a:xfrm>
+          <a:prstGeom prst="rect">
+            <a:avLst/>
+          </a:prstGeom>
+          <a:noFill/>
+          <a:ln/>
+        </p:spPr>
+        <p:txBody>
+          <a:bodyPr wrap="square" lIns="0" tIns="0" rIns="0" bIns="0" rtlCol="0" anchor="t"/>
+          <a:lstStyle/>
+          <a:p>
+            <a:pPr marL="0" indent="0">
+              <a:lnSpc>
+                <a:spcPts val="1600"/>
+              </a:lnSpc>
+              <a:buNone/>
+            </a:pPr>
+            <a:r>
+              <a:rPr lang="en-US" sz="1400" b="1" dirty="0">
+                <a:solidFill>
+                  <a:srgbClr val="059669"/>
+                </a:solidFill>
+                <a:latin typeface="Calibri" pitchFamily="34" charset="0"/>
+                <a:ea typeface="Calibri" pitchFamily="34" charset="-122"/>
+                <a:cs typeface="Calibri" pitchFamily="34" charset="-120"/>
+              </a:rPr>
+              <a:t>Change Request Mgmt</a:t>
+            </a:r>
+            <a:endParaRPr lang="en-US" sz="1400" dirty="0"/>
+          </a:p>
+          <a:p>
+            <a:pPr marL="0" indent="0">
+              <a:lnSpc>
+                <a:spcPts val="1600"/>
+              </a:lnSpc>
+              <a:buNone/>
+            </a:pPr>
+            <a:r>
+              <a:rPr lang="en-US" sz="1250" dirty="0">
+                <a:solidFill>
+                  <a:srgbClr val="0F172A"/>
+                </a:solidFill>
+                <a:latin typeface="Calibri" pitchFamily="34" charset="0"/>
+                <a:ea typeface="Calibri" pitchFamily="34" charset="-122"/>
+                <a:cs typeface="Calibri" pitchFamily="34" charset="-120"/>
+              </a:rPr>
+              <a:t>Grab the CMR Number</a:t>
+            </a:r>
+            <a:endParaRPr lang="en-US" sz="1400" dirty="0"/>
+          </a:p>
+        </p:txBody>
+      </p:sp>
+      <p:sp>
+        <p:nvSpPr>
+          <p:cNvPr id="111" name="Text 111"/>
+          <p:cNvSpPr/>
+          <p:nvPr/>
+        </p:nvSpPr>
+        <p:spPr>
+          <a:xfrm>
+            <a:off x="7746796" y="2926080"/>
+            <a:ext cx="320040" cy="1828800"/>
+          </a:xfrm>
+          <a:prstGeom prst="rect">
+            <a:avLst/>
+          </a:prstGeom>
+          <a:noFill/>
+          <a:ln/>
+        </p:spPr>
+        <p:txBody>
+          <a:bodyPr wrap="square" lIns="0" tIns="0" rIns="0" bIns="0" rtlCol="0" anchor="ctr"/>
+          <a:lstStyle/>
+          <a:p>
+            <a:pPr marL="0" indent="0" algn="ctr">
+              <a:buNone/>
+            </a:pPr>
+            <a:r>
+              <a:rPr lang="en-US" sz="1800" dirty="0">
+                <a:solidFill>
+                  <a:srgbClr val="059669"/>
+                </a:solidFill>
+                <a:latin typeface="Calibri" pitchFamily="34" charset="0"/>
+                <a:ea typeface="Calibri" pitchFamily="34" charset="-122"/>
+                <a:cs typeface="Calibri" pitchFamily="34" charset="-120"/>
+              </a:rPr>
+              <a:t>→</a:t>
+            </a:r>
+            <a:endParaRPr lang="en-US" sz="1800" dirty="0"/>
+          </a:p>
+        </p:txBody>
+      </p:sp>
+      <p:sp>
+        <p:nvSpPr>
+          <p:cNvPr id="112" name="Shape 112"/>
+          <p:cNvSpPr/>
+          <p:nvPr/>
+        </p:nvSpPr>
+        <p:spPr>
+          <a:xfrm>
+            <a:off x="8066836" y="2926080"/>
+            <a:ext cx="1490929" cy="1828800"/>
+          </a:xfrm>
+          <a:prstGeom prst="roundRect">
+            <a:avLst>
+              <a:gd name="adj" fmla="val 4438"/>
+            </a:avLst>
+          </a:prstGeom>
+          <a:solidFill>
+            <a:srgbClr val="F8FAFC"/>
+          </a:solidFill>
+          <a:ln w="12700">
+            <a:solidFill>
+              <a:srgbClr val="E2E8F0"/>
+            </a:solidFill>
+            <a:prstDash val="solid"/>
+          </a:ln>
+        </p:spPr>
+        <p:txBody>
+          <a:bodyPr/>
+          <a:lstStyle/>
+          <a:p>
+            <a:endParaRPr lang="en-US"/>
+          </a:p>
+        </p:txBody>
+      </p:sp>
+      <p:sp>
+        <p:nvSpPr>
+          <p:cNvPr id="113" name="Text 113"/>
+          <p:cNvSpPr/>
+          <p:nvPr/>
+        </p:nvSpPr>
+        <p:spPr>
+          <a:xfrm>
+            <a:off x="8231428" y="3090672"/>
+            <a:ext cx="1161745" cy="1554480"/>
+          </a:xfrm>
+          <a:prstGeom prst="rect">
+            <a:avLst/>
+          </a:prstGeom>
+          <a:noFill/>
+          <a:ln/>
+        </p:spPr>
+        <p:txBody>
+          <a:bodyPr wrap="square" lIns="0" tIns="0" rIns="0" bIns="0" rtlCol="0" anchor="t"/>
+          <a:lstStyle/>
+          <a:p>
+            <a:pPr marL="0" indent="0">
+              <a:lnSpc>
+                <a:spcPts val="1600"/>
+              </a:lnSpc>
+              <a:buNone/>
+            </a:pPr>
+            <a:r>
+              <a:rPr lang="en-US" sz="1400" b="1" dirty="0">
+                <a:solidFill>
+                  <a:srgbClr val="059669"/>
+                </a:solidFill>
+                <a:latin typeface="Calibri" pitchFamily="34" charset="0"/>
+                <a:ea typeface="Calibri" pitchFamily="34" charset="-122"/>
+                <a:cs typeface="Calibri" pitchFamily="34" charset="-120"/>
+              </a:rPr>
+              <a:t>CMR Form</a:t>
+            </a:r>
+            <a:endParaRPr lang="en-US" sz="1400" dirty="0"/>
+          </a:p>
+          <a:p>
+            <a:pPr marL="0" indent="0">
+              <a:lnSpc>
+                <a:spcPts val="1600"/>
+              </a:lnSpc>
+              <a:buNone/>
+            </a:pPr>
+            <a:r>
+              <a:rPr lang="en-US" sz="1250" dirty="0">
+                <a:solidFill>
+                  <a:srgbClr val="0F172A"/>
+                </a:solidFill>
+                <a:latin typeface="Calibri" pitchFamily="34" charset="0"/>
+                <a:ea typeface="Calibri" pitchFamily="34" charset="-122"/>
+                <a:cs typeface="Calibri" pitchFamily="34" charset="-120"/>
+              </a:rPr>
+              <a:t>Engineering, Item/Revision, On Hold</a:t>
+            </a:r>
+            <a:endParaRPr lang="en-US" sz="1400" dirty="0"/>
+          </a:p>
+        </p:txBody>
+      </p:sp>
+      <p:sp>
+        <p:nvSpPr>
+          <p:cNvPr id="114" name="Text 114"/>
+          <p:cNvSpPr/>
+          <p:nvPr/>
+        </p:nvSpPr>
+        <p:spPr>
+          <a:xfrm>
+            <a:off x="9557765" y="2926080"/>
+            <a:ext cx="320040" cy="1828800"/>
+          </a:xfrm>
+          <a:prstGeom prst="rect">
+            <a:avLst/>
+          </a:prstGeom>
+          <a:noFill/>
+          <a:ln/>
+        </p:spPr>
+        <p:txBody>
+          <a:bodyPr wrap="square" lIns="0" tIns="0" rIns="0" bIns="0" rtlCol="0" anchor="ctr"/>
+          <a:lstStyle/>
+          <a:p>
+            <a:pPr marL="0" indent="0" algn="ctr">
+              <a:buNone/>
+            </a:pPr>
+            <a:r>
+              <a:rPr lang="en-US" sz="1800" dirty="0">
+                <a:solidFill>
+                  <a:srgbClr val="059669"/>
+                </a:solidFill>
+                <a:latin typeface="Calibri" pitchFamily="34" charset="0"/>
+                <a:ea typeface="Calibri" pitchFamily="34" charset="-122"/>
+                <a:cs typeface="Calibri" pitchFamily="34" charset="-120"/>
+              </a:rPr>
+              <a:t>→</a:t>
+            </a:r>
+            <a:endParaRPr lang="en-US" sz="1800" dirty="0"/>
+          </a:p>
+        </p:txBody>
+      </p:sp>
+      <p:sp>
+        <p:nvSpPr>
+          <p:cNvPr id="115" name="Shape 115"/>
+          <p:cNvSpPr/>
+          <p:nvPr/>
+        </p:nvSpPr>
+        <p:spPr>
+          <a:xfrm>
+            <a:off x="9877805" y="2926080"/>
+            <a:ext cx="1490929" cy="1828800"/>
+          </a:xfrm>
+          <a:prstGeom prst="roundRect">
+            <a:avLst>
+              <a:gd name="adj" fmla="val 4438"/>
+            </a:avLst>
+          </a:prstGeom>
+          <a:solidFill>
+            <a:srgbClr val="F8FAFC"/>
+          </a:solidFill>
+          <a:ln w="12700">
+            <a:solidFill>
+              <a:srgbClr val="E2E8F0"/>
+            </a:solidFill>
+            <a:prstDash val="solid"/>
+          </a:ln>
+        </p:spPr>
+        <p:txBody>
+          <a:bodyPr/>
+          <a:lstStyle/>
+          <a:p>
+            <a:endParaRPr lang="en-US"/>
+          </a:p>
+        </p:txBody>
+      </p:sp>
+      <p:sp>
+        <p:nvSpPr>
+          <p:cNvPr id="116" name="Text 116"/>
+          <p:cNvSpPr/>
+          <p:nvPr/>
+        </p:nvSpPr>
+        <p:spPr>
+          <a:xfrm>
+            <a:off x="10042397" y="3090672"/>
+            <a:ext cx="1161745" cy="1554480"/>
+          </a:xfrm>
+          <a:prstGeom prst="rect">
+            <a:avLst/>
+          </a:prstGeom>
+          <a:noFill/>
+          <a:ln/>
+        </p:spPr>
+        <p:txBody>
+          <a:bodyPr wrap="square" lIns="0" tIns="0" rIns="0" bIns="0" rtlCol="0" anchor="t"/>
+          <a:lstStyle/>
+          <a:p>
+            <a:pPr marL="0" indent="0">
+              <a:lnSpc>
+                <a:spcPts val="1600"/>
+              </a:lnSpc>
+              <a:buNone/>
+            </a:pPr>
+            <a:r>
+              <a:rPr lang="en-US" sz="1400" b="1" dirty="0">
+                <a:solidFill>
+                  <a:srgbClr val="059669"/>
+                </a:solidFill>
+                <a:latin typeface="Calibri" pitchFamily="34" charset="0"/>
+                <a:ea typeface="Calibri" pitchFamily="34" charset="-122"/>
+                <a:cs typeface="Calibri" pitchFamily="34" charset="-120"/>
+              </a:rPr>
+              <a:t>Notify &amp; Close</a:t>
+            </a:r>
+            <a:endParaRPr lang="en-US" sz="1400" dirty="0"/>
+          </a:p>
+          <a:p>
+            <a:pPr marL="0" indent="0">
+              <a:lnSpc>
+                <a:spcPts val="1600"/>
+              </a:lnSpc>
+              <a:buNone/>
+            </a:pPr>
+            <a:r>
+              <a:rPr lang="en-US" sz="1250" dirty="0">
+                <a:solidFill>
+                  <a:srgbClr val="0F172A"/>
+                </a:solidFill>
+                <a:latin typeface="Calibri" pitchFamily="34" charset="0"/>
+                <a:ea typeface="Calibri" pitchFamily="34" charset="-122"/>
+                <a:cs typeface="Calibri" pitchFamily="34" charset="-120"/>
+              </a:rPr>
+              <a:t>Save, notify engineering, send CMR #</a:t>
+            </a:r>
+            <a:endParaRPr lang="en-US" sz="1400" dirty="0"/>
           </a:p>
         </p:txBody>
       </p:sp>

</xml_diff>

<commit_message>
Update eCMRs plan deck with latest copy
Co-Authored-By: Claude Sonnet 5 <noreply@anthropic.com>
Claude-Session: https://claude.ai/code/session_01Ar9F593p16uUzvwAJdxbpf
</commit_message>
<xml_diff>
--- a/docs/presentations/eCMRs_plan.pptx
+++ b/docs/presentations/eCMRs_plan.pptx
@@ -5,21 +5,20 @@
     <p:sldMasterId id="2147483648" r:id="rId1"/>
   </p:sldMasterIdLst>
   <p:notesMasterIdLst>
-    <p:notesMasterId r:id="rId12"/>
+    <p:notesMasterId r:id="rId13"/>
   </p:notesMasterIdLst>
   <p:sldIdLst>
     <p:sldId id="256" r:id="rId2"/>
     <p:sldId id="257" r:id="rId3"/>
     <p:sldId id="258" r:id="rId4"/>
-    <p:sldId id="266" r:id="rId17"/>
-    <p:sldId id="267" r:id="rId18"/>
-    <p:sldId id="259" r:id="rId5"/>
-    <p:sldId id="260" r:id="rId6"/>
-    <p:sldId id="261" r:id="rId7"/>
-    <p:sldId id="263" r:id="rId8"/>
-    <p:sldId id="262" r:id="rId9"/>
-    <p:sldId id="264" r:id="rId10"/>
-    <p:sldId id="265" r:id="rId11"/>
+    <p:sldId id="266" r:id="rId5"/>
+    <p:sldId id="259" r:id="rId6"/>
+    <p:sldId id="260" r:id="rId7"/>
+    <p:sldId id="261" r:id="rId8"/>
+    <p:sldId id="263" r:id="rId9"/>
+    <p:sldId id="262" r:id="rId10"/>
+    <p:sldId id="264" r:id="rId11"/>
+    <p:sldId id="265" r:id="rId12"/>
   </p:sldIdLst>
   <p:sldSz cx="12192000" cy="6858000"/>
   <p:notesSz cx="6858000" cy="12192000"/>
@@ -280,7 +279,7 @@
           <a:bodyPr/>
           <a:lstStyle/>
           <a:p>
-            <a:endParaRPr lang="en-US"/>
+            <a:endParaRPr lang="en-US" dirty="0"/>
           </a:p>
         </p:txBody>
       </p:sp>
@@ -322,7 +321,7 @@
               <a:rPr lang="en-US"/>
               <a:t>1</a:t>
             </a:fld>
-            <a:endParaRPr lang="en-US"/>
+            <a:endParaRPr lang="en-US" dirty="0"/>
           </a:p>
         </p:txBody>
       </p:sp>
@@ -411,7 +410,7 @@
           <a:p>
             <a:fld id="{F7021451-1387-4CA6-816F-3879F97B5CBC}" type="slidenum">
               <a:rPr lang="en-US"/>
-              <a:t>10</a:t>
+              <a:t>11</a:t>
             </a:fld>
             <a:endParaRPr lang="en-US"/>
           </a:p>
@@ -462,7 +461,7 @@
           <a:bodyPr/>
           <a:lstStyle/>
           <a:p>
-            <a:endParaRPr lang="en-US"/>
+            <a:endParaRPr lang="en-US" dirty="0"/>
           </a:p>
         </p:txBody>
       </p:sp>
@@ -504,7 +503,7 @@
               <a:rPr lang="en-US"/>
               <a:t>2</a:t>
             </a:fld>
-            <a:endParaRPr lang="en-US"/>
+            <a:endParaRPr lang="en-US" dirty="0"/>
           </a:p>
         </p:txBody>
       </p:sp>
@@ -553,7 +552,7 @@
           <a:bodyPr/>
           <a:lstStyle/>
           <a:p>
-            <a:endParaRPr lang="en-US"/>
+            <a:endParaRPr lang="en-US" dirty="0"/>
           </a:p>
         </p:txBody>
       </p:sp>
@@ -595,7 +594,7 @@
               <a:rPr lang="en-US"/>
               <a:t>3</a:t>
             </a:fld>
-            <a:endParaRPr lang="en-US"/>
+            <a:endParaRPr lang="en-US" dirty="0"/>
           </a:p>
         </p:txBody>
       </p:sp>
@@ -644,7 +643,7 @@
           <a:bodyPr/>
           <a:lstStyle/>
           <a:p>
-            <a:endParaRPr lang="en-US"/>
+            <a:endParaRPr lang="en-US" dirty="0"/>
           </a:p>
         </p:txBody>
       </p:sp>
@@ -684,9 +683,9 @@
           <a:p>
             <a:fld id="{F7021451-1387-4CA6-816F-3879F97B5CBC}" type="slidenum">
               <a:rPr lang="en-US"/>
-              <a:t>4</a:t>
+              <a:t>5</a:t>
             </a:fld>
-            <a:endParaRPr lang="en-US"/>
+            <a:endParaRPr lang="en-US" dirty="0"/>
           </a:p>
         </p:txBody>
       </p:sp>
@@ -775,7 +774,7 @@
           <a:p>
             <a:fld id="{F7021451-1387-4CA6-816F-3879F97B5CBC}" type="slidenum">
               <a:rPr lang="en-US"/>
-              <a:t>5</a:t>
+              <a:t>6</a:t>
             </a:fld>
             <a:endParaRPr lang="en-US"/>
           </a:p>
@@ -826,7 +825,7 @@
           <a:bodyPr/>
           <a:lstStyle/>
           <a:p>
-            <a:endParaRPr lang="en-US"/>
+            <a:endParaRPr lang="en-US" dirty="0"/>
           </a:p>
         </p:txBody>
       </p:sp>
@@ -866,9 +865,9 @@
           <a:p>
             <a:fld id="{F7021451-1387-4CA6-816F-3879F97B5CBC}" type="slidenum">
               <a:rPr lang="en-US"/>
-              <a:t>6</a:t>
+              <a:t>7</a:t>
             </a:fld>
-            <a:endParaRPr lang="en-US"/>
+            <a:endParaRPr lang="en-US" dirty="0"/>
           </a:p>
         </p:txBody>
       </p:sp>
@@ -917,7 +916,7 @@
           <a:bodyPr/>
           <a:lstStyle/>
           <a:p>
-            <a:endParaRPr lang="en-US"/>
+            <a:endParaRPr lang="en-US" dirty="0"/>
           </a:p>
         </p:txBody>
       </p:sp>
@@ -957,9 +956,9 @@
           <a:p>
             <a:fld id="{F7021451-1387-4CA6-816F-3879F97B5CBC}" type="slidenum">
               <a:rPr lang="en-US"/>
-              <a:t>7</a:t>
+              <a:t>8</a:t>
             </a:fld>
-            <a:endParaRPr lang="en-US"/>
+            <a:endParaRPr lang="en-US" dirty="0"/>
           </a:p>
         </p:txBody>
       </p:sp>
@@ -1048,7 +1047,7 @@
           <a:p>
             <a:fld id="{F7021451-1387-4CA6-816F-3879F97B5CBC}" type="slidenum">
               <a:rPr lang="en-US"/>
-              <a:t>8</a:t>
+              <a:t>9</a:t>
             </a:fld>
             <a:endParaRPr lang="en-US"/>
           </a:p>
@@ -1139,7 +1138,7 @@
           <a:p>
             <a:fld id="{F7021451-1387-4CA6-816F-3879F97B5CBC}" type="slidenum">
               <a:rPr lang="en-US"/>
-              <a:t>9</a:t>
+              <a:t>10</a:t>
             </a:fld>
             <a:endParaRPr lang="en-US"/>
           </a:p>
@@ -1518,7 +1517,7 @@
           <a:bodyPr/>
           <a:lstStyle/>
           <a:p>
-            <a:endParaRPr lang="en-US"/>
+            <a:endParaRPr lang="en-US" dirty="0"/>
           </a:p>
         </p:txBody>
       </p:sp>
@@ -1552,7 +1551,7 @@
           <a:bodyPr/>
           <a:lstStyle/>
           <a:p>
-            <a:endParaRPr lang="en-US"/>
+            <a:endParaRPr lang="en-US" dirty="0"/>
           </a:p>
         </p:txBody>
       </p:sp>
@@ -1706,6 +1705,382 @@
 </file>
 
 <file path=ppt/slides/slide10.xml><?xml version="1.0" encoding="utf-8"?>
+<p:sld xmlns:a="http://schemas.openxmlformats.org/drawingml/2006/main" xmlns:r="http://schemas.openxmlformats.org/officeDocument/2006/relationships" xmlns:p="http://schemas.openxmlformats.org/presentationml/2006/main">
+  <p:cSld name="Slide 9">
+    <p:bg>
+      <p:bgPr>
+        <a:solidFill>
+          <a:srgbClr val="F8FAFC"/>
+        </a:solidFill>
+        <a:effectLst/>
+      </p:bgPr>
+    </p:bg>
+    <p:spTree>
+      <p:nvGrpSpPr>
+        <p:cNvPr id="1" name=""/>
+        <p:cNvGrpSpPr/>
+        <p:nvPr/>
+      </p:nvGrpSpPr>
+      <p:grpSpPr>
+        <a:xfrm>
+          <a:off x="0" y="0"/>
+          <a:ext cx="0" cy="0"/>
+          <a:chOff x="0" y="0"/>
+          <a:chExt cx="0" cy="0"/>
+        </a:xfrm>
+      </p:grpSpPr>
+      <p:sp>
+        <p:nvSpPr>
+          <p:cNvPr id="2" name="Text 0"/>
+          <p:cNvSpPr/>
+          <p:nvPr/>
+        </p:nvSpPr>
+        <p:spPr>
+          <a:xfrm>
+            <a:off x="457200" y="502920"/>
+            <a:ext cx="9539935" cy="685800"/>
+          </a:xfrm>
+          <a:prstGeom prst="rect">
+            <a:avLst/>
+          </a:prstGeom>
+          <a:noFill/>
+          <a:ln/>
+        </p:spPr>
+        <p:txBody>
+          <a:bodyPr wrap="square" lIns="0" tIns="0" rIns="0" bIns="0" rtlCol="0" anchor="t"/>
+          <a:lstStyle/>
+          <a:p>
+            <a:pPr marL="0" indent="0" algn="l">
+              <a:buNone/>
+            </a:pPr>
+            <a:r>
+              <a:rPr lang="en-US" sz="3400" b="1" dirty="0">
+                <a:solidFill>
+                  <a:srgbClr val="0F172A"/>
+                </a:solidFill>
+                <a:latin typeface="Cambria" pitchFamily="34" charset="0"/>
+                <a:ea typeface="Cambria" pitchFamily="34" charset="-122"/>
+                <a:cs typeface="Cambria" pitchFamily="34" charset="-120"/>
+              </a:rPr>
+              <a:t>Test</a:t>
+            </a:r>
+            <a:endParaRPr lang="en-US" sz="3400" dirty="0"/>
+          </a:p>
+        </p:txBody>
+      </p:sp>
+      <p:sp>
+        <p:nvSpPr>
+          <p:cNvPr id="3" name="Text 1"/>
+          <p:cNvSpPr/>
+          <p:nvPr/>
+        </p:nvSpPr>
+        <p:spPr>
+          <a:xfrm>
+            <a:off x="457200" y="1216152"/>
+            <a:ext cx="9539935" cy="640080"/>
+          </a:xfrm>
+          <a:prstGeom prst="rect">
+            <a:avLst/>
+          </a:prstGeom>
+          <a:noFill/>
+          <a:ln/>
+        </p:spPr>
+        <p:txBody>
+          <a:bodyPr wrap="square" lIns="0" tIns="0" rIns="0" bIns="0" rtlCol="0" anchor="t"/>
+          <a:lstStyle/>
+          <a:p>
+            <a:pPr marL="0" indent="0" algn="l">
+              <a:buNone/>
+            </a:pPr>
+            <a:r>
+              <a:rPr lang="en-US" sz="1600" dirty="0">
+                <a:solidFill>
+                  <a:srgbClr val="64748B"/>
+                </a:solidFill>
+                <a:latin typeface="Calibri" pitchFamily="34" charset="0"/>
+                <a:ea typeface="Calibri" pitchFamily="34" charset="-122"/>
+                <a:cs typeface="Calibri" pitchFamily="34" charset="-120"/>
+              </a:rPr>
+              <a:t>Run tests to make sure everything looks good.</a:t>
+            </a:r>
+            <a:endParaRPr lang="en-US" sz="1600" dirty="0"/>
+          </a:p>
+        </p:txBody>
+      </p:sp>
+      <p:sp>
+        <p:nvSpPr>
+          <p:cNvPr id="4" name="Shape 2"/>
+          <p:cNvSpPr/>
+          <p:nvPr/>
+        </p:nvSpPr>
+        <p:spPr>
+          <a:xfrm>
+            <a:off x="10362895" y="502920"/>
+            <a:ext cx="1371600" cy="1371600"/>
+          </a:xfrm>
+          <a:prstGeom prst="roundRect">
+            <a:avLst>
+              <a:gd name="adj" fmla="val 8000"/>
+            </a:avLst>
+          </a:prstGeom>
+          <a:solidFill>
+            <a:srgbClr val="ECFDF5"/>
+          </a:solidFill>
+          <a:ln w="12700">
+            <a:solidFill>
+              <a:srgbClr val="E2E8F0"/>
+            </a:solidFill>
+            <a:prstDash val="solid"/>
+          </a:ln>
+        </p:spPr>
+        <p:txBody>
+          <a:bodyPr/>
+          <a:lstStyle/>
+          <a:p>
+            <a:endParaRPr lang="en-US"/>
+          </a:p>
+        </p:txBody>
+      </p:sp>
+      <p:pic>
+        <p:nvPicPr>
+          <p:cNvPr id="5" name="Image 0" descr="icons/search.png"/>
+          <p:cNvPicPr>
+            <a:picLocks noChangeAspect="1"/>
+          </p:cNvPicPr>
+          <p:nvPr/>
+        </p:nvPicPr>
+        <p:blipFill>
+          <a:blip r:embed="rId3"/>
+          <a:stretch>
+            <a:fillRect/>
+          </a:stretch>
+        </p:blipFill>
+        <p:spPr>
+          <a:xfrm>
+            <a:off x="10705795" y="845820"/>
+            <a:ext cx="685800" cy="685800"/>
+          </a:xfrm>
+          <a:prstGeom prst="rect">
+            <a:avLst/>
+          </a:prstGeom>
+        </p:spPr>
+      </p:pic>
+      <p:sp>
+        <p:nvSpPr>
+          <p:cNvPr id="6" name="Shape 3"/>
+          <p:cNvSpPr/>
+          <p:nvPr/>
+        </p:nvSpPr>
+        <p:spPr>
+          <a:xfrm>
+            <a:off x="457199" y="2148840"/>
+            <a:ext cx="11277295" cy="4251960"/>
+          </a:xfrm>
+          <a:prstGeom prst="roundRect">
+            <a:avLst>
+              <a:gd name="adj" fmla="val 2581"/>
+            </a:avLst>
+          </a:prstGeom>
+          <a:solidFill>
+            <a:srgbClr val="FFFFFF"/>
+          </a:solidFill>
+          <a:ln w="12700">
+            <a:solidFill>
+              <a:srgbClr val="E2E8F0"/>
+            </a:solidFill>
+            <a:prstDash val="solid"/>
+          </a:ln>
+          <a:effectLst>
+            <a:outerShdw blurRad="152400" dist="38100" dir="5400000" algn="bl" rotWithShape="0">
+              <a:srgbClr val="1E293B">
+                <a:alpha val="8000"/>
+              </a:srgbClr>
+            </a:outerShdw>
+          </a:effectLst>
+        </p:spPr>
+        <p:txBody>
+          <a:bodyPr/>
+          <a:lstStyle/>
+          <a:p>
+            <a:endParaRPr lang="en-US"/>
+          </a:p>
+        </p:txBody>
+      </p:sp>
+      <p:sp>
+        <p:nvSpPr>
+          <p:cNvPr id="7" name="Text 4"/>
+          <p:cNvSpPr/>
+          <p:nvPr/>
+        </p:nvSpPr>
+        <p:spPr>
+          <a:xfrm>
+            <a:off x="822960" y="2514600"/>
+            <a:ext cx="9144000" cy="365760"/>
+          </a:xfrm>
+          <a:prstGeom prst="rect">
+            <a:avLst/>
+          </a:prstGeom>
+          <a:noFill/>
+          <a:ln/>
+        </p:spPr>
+        <p:txBody>
+          <a:bodyPr wrap="square" lIns="0" tIns="0" rIns="0" bIns="0" rtlCol="0" anchor="t"/>
+          <a:lstStyle/>
+          <a:p>
+            <a:pPr marL="0" indent="0" algn="l">
+              <a:buNone/>
+            </a:pPr>
+            <a:r>
+              <a:rPr lang="en-US" sz="1500" b="1" dirty="0">
+                <a:solidFill>
+                  <a:srgbClr val="059669"/>
+                </a:solidFill>
+                <a:latin typeface="Calibri" pitchFamily="34" charset="0"/>
+                <a:ea typeface="Calibri" pitchFamily="34" charset="-122"/>
+                <a:cs typeface="Calibri" pitchFamily="34" charset="-120"/>
+              </a:rPr>
+              <a:t>Actual Phase C test list</a:t>
+            </a:r>
+            <a:endParaRPr lang="en-US" sz="1500" dirty="0"/>
+          </a:p>
+        </p:txBody>
+      </p:sp>
+      <p:sp>
+        <p:nvSpPr>
+          <p:cNvPr id="8" name="Text 5"/>
+          <p:cNvSpPr/>
+          <p:nvPr/>
+        </p:nvSpPr>
+        <p:spPr>
+          <a:xfrm>
+            <a:off x="822960" y="2926080"/>
+            <a:ext cx="10545775" cy="2743200"/>
+          </a:xfrm>
+          <a:prstGeom prst="rect">
+            <a:avLst/>
+          </a:prstGeom>
+          <a:noFill/>
+          <a:ln/>
+        </p:spPr>
+        <p:txBody>
+          <a:bodyPr wrap="square" lIns="0" tIns="0" rIns="0" bIns="0" rtlCol="0" anchor="t"/>
+          <a:lstStyle/>
+          <a:p>
+            <a:pPr marL="228600" indent="-228600">
+              <a:spcAft>
+                <a:spcPts val="1600"/>
+              </a:spcAft>
+              <a:buSzPct val="100000"/>
+              <a:buChar char="■"/>
+            </a:pPr>
+            <a:r>
+              <a:rPr lang="en-US" sz="1500" dirty="0">
+                <a:solidFill>
+                  <a:srgbClr val="0F172A"/>
+                </a:solidFill>
+                <a:latin typeface="Calibri" pitchFamily="34" charset="0"/>
+                <a:ea typeface="Calibri" pitchFamily="34" charset="-122"/>
+                <a:cs typeface="Calibri" pitchFamily="34" charset="-120"/>
+              </a:rPr>
+              <a:t>Create a new CMR end-to-end</a:t>
+            </a:r>
+            <a:endParaRPr lang="en-US" sz="1500" dirty="0"/>
+          </a:p>
+          <a:p>
+            <a:pPr marL="228600" indent="-228600">
+              <a:spcAft>
+                <a:spcPts val="1600"/>
+              </a:spcAft>
+              <a:buSzPct val="100000"/>
+              <a:buChar char="■"/>
+            </a:pPr>
+            <a:r>
+              <a:rPr lang="en-US" sz="1500" dirty="0">
+                <a:solidFill>
+                  <a:srgbClr val="0F172A"/>
+                </a:solidFill>
+                <a:latin typeface="Calibri" pitchFamily="34" charset="0"/>
+                <a:ea typeface="Calibri" pitchFamily="34" charset="-122"/>
+                <a:cs typeface="Calibri" pitchFamily="34" charset="-120"/>
+              </a:rPr>
+              <a:t>Save and reopen</a:t>
+            </a:r>
+            <a:endParaRPr lang="en-US" sz="1500" dirty="0"/>
+          </a:p>
+          <a:p>
+            <a:pPr marL="228600" indent="-228600">
+              <a:spcAft>
+                <a:spcPts val="1600"/>
+              </a:spcAft>
+              <a:buSzPct val="100000"/>
+              <a:buChar char="■"/>
+            </a:pPr>
+            <a:r>
+              <a:rPr lang="en-US" sz="1500" dirty="0">
+                <a:solidFill>
+                  <a:srgbClr val="0F172A"/>
+                </a:solidFill>
+                <a:latin typeface="Calibri" pitchFamily="34" charset="0"/>
+                <a:ea typeface="Calibri" pitchFamily="34" charset="-122"/>
+                <a:cs typeface="Calibri" pitchFamily="34" charset="-120"/>
+              </a:rPr>
+              <a:t>Confirm numbering has no race condition</a:t>
+            </a:r>
+            <a:endParaRPr lang="en-US" sz="1500" dirty="0"/>
+          </a:p>
+          <a:p>
+            <a:pPr marL="228600" indent="-228600">
+              <a:spcAft>
+                <a:spcPts val="1600"/>
+              </a:spcAft>
+              <a:buSzPct val="100000"/>
+              <a:buChar char="■"/>
+            </a:pPr>
+            <a:r>
+              <a:rPr lang="en-US" sz="1500" dirty="0">
+                <a:solidFill>
+                  <a:srgbClr val="0F172A"/>
+                </a:solidFill>
+                <a:latin typeface="Calibri" pitchFamily="34" charset="0"/>
+                <a:ea typeface="Calibri" pitchFamily="34" charset="-122"/>
+                <a:cs typeface="Calibri" pitchFamily="34" charset="-120"/>
+              </a:rPr>
+              <a:t>Confirm the flow meets requirements</a:t>
+            </a:r>
+            <a:endParaRPr lang="en-US" sz="1500" dirty="0"/>
+          </a:p>
+          <a:p>
+            <a:pPr marL="228600" indent="-228600">
+              <a:spcAft>
+                <a:spcPts val="1600"/>
+              </a:spcAft>
+              <a:buSzPct val="100000"/>
+              <a:buChar char="■"/>
+            </a:pPr>
+            <a:r>
+              <a:rPr lang="en-US" sz="1500" dirty="0">
+                <a:solidFill>
+                  <a:srgbClr val="0F172A"/>
+                </a:solidFill>
+                <a:latin typeface="Calibri" pitchFamily="34" charset="0"/>
+                <a:ea typeface="Calibri" pitchFamily="34" charset="-122"/>
+                <a:cs typeface="Calibri" pitchFamily="34" charset="-120"/>
+              </a:rPr>
+              <a:t>Confirm all fields + lookup fields work</a:t>
+            </a:r>
+            <a:endParaRPr lang="en-US" sz="1500" dirty="0"/>
+          </a:p>
+        </p:txBody>
+      </p:sp>
+    </p:spTree>
+  </p:cSld>
+  <p:clrMapOvr>
+    <a:masterClrMapping/>
+  </p:clrMapOvr>
+</p:sld>
+</file>
+
+<file path=ppt/slides/slide11.xml><?xml version="1.0" encoding="utf-8"?>
 <p:sld xmlns:a="http://schemas.openxmlformats.org/drawingml/2006/main" xmlns:r="http://schemas.openxmlformats.org/officeDocument/2006/relationships" xmlns:p="http://schemas.openxmlformats.org/presentationml/2006/main">
   <p:cSld name="Slide 10">
     <p:bg>
@@ -2064,1543 +2439,9 @@
                 <a:ea typeface="Calibri" pitchFamily="34" charset="-122"/>
                 <a:cs typeface="Calibri" pitchFamily="34" charset="-120"/>
               </a:rPr>
-              <a:t>Work on procedure documentation changes </a:t>
-            </a:r>
-          </a:p>
-          <a:p>
-            <a:pPr marL="228600" indent="-228600">
-              <a:buSzPct val="100000"/>
-              <a:buChar char="■"/>
-            </a:pPr>
-            <a:r>
-              <a:rPr lang="en-US" sz="1500" dirty="0">
-                <a:solidFill>
-                  <a:srgbClr val="FFFFFF"/>
-                </a:solidFill>
-                <a:latin typeface="Calibri" pitchFamily="34" charset="0"/>
-                <a:ea typeface="Calibri" pitchFamily="34" charset="-122"/>
-                <a:cs typeface="Calibri" pitchFamily="34" charset="-120"/>
-              </a:rPr>
               <a:t>Submit procedures for manager approval</a:t>
             </a:r>
             <a:endParaRPr lang="en-US" sz="1500" dirty="0"/>
-          </a:p>
-        </p:txBody>
-      </p:sp>
-    </p:spTree>
-  </p:cSld>
-  <p:clrMapOvr>
-    <a:masterClrMapping/>
-  </p:clrMapOvr>
-</p:sld>
-</file>
-
-<file path=ppt/slides/slide11.xml><?xml version="1.0" encoding="utf-8"?>
-<p:sld xmlns:a="http://schemas.openxmlformats.org/drawingml/2006/main" xmlns:r="http://schemas.openxmlformats.org/officeDocument/2006/relationships" xmlns:p="http://schemas.openxmlformats.org/presentationml/2006/main">
-  <p:cSld name="Slide 5">
-    <p:bg>
-      <p:bgPr>
-        <a:solidFill>
-          <a:srgbClr val="F8FAFC"/>
-        </a:solidFill>
-        <a:effectLst/>
-      </p:bgPr>
-    </p:bg>
-    <p:spTree>
-      <p:nvGrpSpPr>
-        <p:cNvPr id="1" name=""/>
-        <p:cNvGrpSpPr/>
-        <p:nvPr/>
-      </p:nvGrpSpPr>
-      <p:grpSpPr>
-        <a:xfrm>
-          <a:off x="0" y="0"/>
-          <a:ext cx="0" cy="0"/>
-          <a:chOff x="0" y="0"/>
-          <a:chExt cx="0" cy="0"/>
-        </a:xfrm>
-      </p:grpSpPr>
-      <p:sp>
-        <p:nvSpPr>
-          <p:cNvPr id="2" name="Shape 0"/>
-          <p:cNvSpPr/>
-          <p:nvPr/>
-        </p:nvSpPr>
-        <p:spPr>
-          <a:xfrm>
-            <a:off x="457200" y="502920"/>
-            <a:ext cx="1371600" cy="1371600"/>
-          </a:xfrm>
-          <a:prstGeom prst="roundRect">
-            <a:avLst>
-              <a:gd name="adj" fmla="val 8000"/>
-            </a:avLst>
-          </a:prstGeom>
-          <a:solidFill>
-            <a:srgbClr val="ECFDF5"/>
-          </a:solidFill>
-          <a:ln w="12700">
-            <a:solidFill>
-              <a:srgbClr val="E2E8F0"/>
-            </a:solidFill>
-            <a:prstDash val="solid"/>
-          </a:ln>
-        </p:spPr>
-        <p:txBody>
-          <a:bodyPr/>
-          <a:lstStyle/>
-          <a:p>
-            <a:endParaRPr lang="en-US"/>
-          </a:p>
-        </p:txBody>
-      </p:sp>
-      <p:pic>
-        <p:nvPicPr>
-          <p:cNvPr id="3" name="Image 0" descr="icons/tag.png"/>
-          <p:cNvPicPr>
-            <a:picLocks noChangeAspect="1"/>
-          </p:cNvPicPr>
-          <p:nvPr/>
-        </p:nvPicPr>
-        <p:blipFill>
-          <a:blip r:embed="rId4"/>
-          <a:stretch>
-            <a:fillRect/>
-          </a:stretch>
-        </p:blipFill>
-        <p:spPr>
-          <a:xfrm>
-            <a:off x="800100" y="845820"/>
-            <a:ext cx="685800" cy="685800"/>
-          </a:xfrm>
-          <a:prstGeom prst="rect">
-            <a:avLst/>
-          </a:prstGeom>
-        </p:spPr>
-      </p:pic>
-      <p:sp>
-        <p:nvSpPr>
-          <p:cNvPr id="4" name="Text 1"/>
-          <p:cNvSpPr/>
-          <p:nvPr/>
-        </p:nvSpPr>
-        <p:spPr>
-          <a:xfrm>
-            <a:off x="2194560" y="502920"/>
-            <a:ext cx="9539935" cy="685800"/>
-          </a:xfrm>
-          <a:prstGeom prst="rect">
-            <a:avLst/>
-          </a:prstGeom>
-          <a:noFill/>
-          <a:ln/>
-        </p:spPr>
-        <p:txBody>
-          <a:bodyPr wrap="square" lIns="0" tIns="0" rIns="0" bIns="0" rtlCol="0" anchor="t"/>
-          <a:lstStyle/>
-          <a:p>
-            <a:pPr marL="0" indent="0" algn="l">
-              <a:buNone/>
-            </a:pPr>
-            <a:r>
-              <a:rPr lang="en-US" sz="3400" b="1" dirty="0">
-                <a:solidFill>
-                  <a:srgbClr val="0F172A"/>
-                </a:solidFill>
-                <a:latin typeface="Cambria" pitchFamily="34" charset="0"/>
-                <a:ea typeface="Cambria" pitchFamily="34" charset="-122"/>
-                <a:cs typeface="Cambria" pitchFamily="34" charset="-120"/>
-              </a:rPr>
-              <a:t>The current CMR process</a:t>
-            </a:r>
-            <a:endParaRPr lang="en-US" sz="3400" dirty="0"/>
-          </a:p>
-        </p:txBody>
-      </p:sp>
-      <p:sp>
-        <p:nvSpPr>
-          <p:cNvPr id="5" name="Text 2"/>
-          <p:cNvSpPr/>
-          <p:nvPr/>
-        </p:nvSpPr>
-        <p:spPr>
-          <a:xfrm>
-            <a:off x="2194560" y="1216152"/>
-            <a:ext cx="9539935" cy="640080"/>
-          </a:xfrm>
-          <a:prstGeom prst="rect">
-            <a:avLst/>
-          </a:prstGeom>
-          <a:noFill/>
-          <a:ln/>
-        </p:spPr>
-        <p:txBody>
-          <a:bodyPr wrap="square" lIns="0" tIns="0" rIns="0" bIns="0" rtlCol="0" anchor="t"/>
-          <a:lstStyle/>
-          <a:p>
-            <a:pPr marL="0" indent="0" algn="l">
-              <a:buNone/>
-            </a:pPr>
-            <a:r>
-              <a:rPr lang="en-US" sz="1600" dirty="0">
-                <a:solidFill>
-                  <a:srgbClr val="64748B"/>
-                </a:solidFill>
-                <a:latin typeface="Calibri" pitchFamily="34" charset="0"/>
-                <a:ea typeface="Calibri" pitchFamily="34" charset="-122"/>
-                <a:cs typeface="Calibri" pitchFamily="34" charset="-120"/>
-              </a:rPr>
-              <a:t>Create Change Request → Change Request Management → CMR — the three-form workflow today.</a:t>
-            </a:r>
-            <a:endParaRPr lang="en-US" sz="1600" dirty="0"/>
-          </a:p>
-        </p:txBody>
-      </p:sp>
-      <p:sp>
-        <p:nvSpPr>
-          <p:cNvPr id="6" name="Shape 3"/>
-          <p:cNvSpPr/>
-          <p:nvPr/>
-        </p:nvSpPr>
-        <p:spPr>
-          <a:xfrm>
-            <a:off x="457200" y="2148840"/>
-            <a:ext cx="11277295" cy="4251960"/>
-          </a:xfrm>
-          <a:prstGeom prst="roundRect">
-            <a:avLst>
-              <a:gd name="adj" fmla="val 2581"/>
-            </a:avLst>
-          </a:prstGeom>
-          <a:solidFill>
-            <a:srgbClr val="FFFFFF"/>
-          </a:solidFill>
-          <a:ln w="12700">
-            <a:solidFill>
-              <a:srgbClr val="E2E8F0"/>
-            </a:solidFill>
-            <a:prstDash val="solid"/>
-          </a:ln>
-          <a:effectLst>
-            <a:outerShdw blurRad="152400" dist="38100" dir="5400000" algn="bl" rotWithShape="0">
-              <a:srgbClr val="1E293B">
-                <a:alpha val="8000"/>
-              </a:srgbClr>
-            </a:outerShdw>
-          </a:effectLst>
-        </p:spPr>
-        <p:txBody>
-          <a:bodyPr/>
-          <a:lstStyle/>
-          <a:p>
-            <a:endParaRPr lang="en-US"/>
-          </a:p>
-        </p:txBody>
-      </p:sp>
-      <p:sp>
-        <p:nvSpPr>
-          <p:cNvPr id="7" name="Text 4"/>
-          <p:cNvSpPr/>
-          <p:nvPr/>
-        </p:nvSpPr>
-        <p:spPr>
-          <a:xfrm>
-            <a:off x="822960" y="2514600"/>
-            <a:ext cx="9144000" cy="365760"/>
-          </a:xfrm>
-          <a:prstGeom prst="rect">
-            <a:avLst/>
-          </a:prstGeom>
-          <a:noFill/>
-          <a:ln/>
-        </p:spPr>
-        <p:txBody>
-          <a:bodyPr wrap="square" lIns="0" tIns="0" rIns="0" bIns="0" rtlCol="0" anchor="t"/>
-          <a:lstStyle/>
-          <a:p>
-            <a:pPr marL="0" indent="0" algn="l">
-              <a:buNone/>
-            </a:pPr>
-            <a:r>
-              <a:rPr lang="en-US" sz="1500" b="1" dirty="0">
-                <a:solidFill>
-                  <a:srgbClr val="059669"/>
-                </a:solidFill>
-                <a:latin typeface="Calibri" pitchFamily="34" charset="0"/>
-                <a:ea typeface="Calibri" pitchFamily="34" charset="-122"/>
-                <a:cs typeface="Calibri" pitchFamily="34" charset="-120"/>
-              </a:rPr>
-              <a:t>Actual current process</a:t>
-            </a:r>
-            <a:endParaRPr lang="en-US" sz="1500" dirty="0"/>
-          </a:p>
-        </p:txBody>
-      </p:sp>
-      <p:sp>
-        <p:nvSpPr>
-          <p:cNvPr id="8" name="Text 5"/>
-          <p:cNvSpPr/>
-          <p:nvPr/>
-        </p:nvSpPr>
-        <p:spPr>
-          <a:xfrm>
-            <a:off x="822960" y="2926080"/>
-            <a:ext cx="10545775" cy="3343200"/>
-          </a:xfrm>
-          <a:prstGeom prst="rect">
-            <a:avLst/>
-          </a:prstGeom>
-          <a:noFill/>
-          <a:ln/>
-        </p:spPr>
-        <p:txBody>
-          <a:bodyPr wrap="square" lIns="0" tIns="0" rIns="0" bIns="0" rtlCol="0" anchor="t"/>
-          <a:lstStyle/>
-          <a:p>
-            <a:pPr marL="228600" indent="-228600">
-              <a:spcAft>
-                <a:spcPts val="1400"/>
-              </a:spcAft>
-              <a:buSzPct val="100000"/>
-              <a:buChar char="■"/>
-            </a:pPr>
-            <a:r>
-              <a:rPr lang="en-US" sz="1500" dirty="0">
-                <a:solidFill>
-                  <a:srgbClr val="0F172A"/>
-                </a:solidFill>
-                <a:latin typeface="Calibri" pitchFamily="34" charset="0"/>
-                <a:ea typeface="Calibri" pitchFamily="34" charset="-122"/>
-                <a:cs typeface="Calibri" pitchFamily="34" charset="-120"/>
-              </a:rPr>
-              <a:t>Production emails a PIR (Job, Serial #, Top Level PN, Sub Assembly PN, Part, Issue); Jasmine decides </a:t>
-            </a:r>
-            <a:r>
-              <a:rPr lang="en-US" sz="1500" b="1" dirty="0">
-                <a:solidFill>
-                  <a:srgbClr val="0F172A"/>
-                </a:solidFill>
-                <a:latin typeface="Calibri" pitchFamily="34" charset="0"/>
-                <a:ea typeface="Calibri" pitchFamily="34" charset="-122"/>
-                <a:cs typeface="Calibri" pitchFamily="34" charset="-120"/>
-              </a:rPr>
-              <a:t>CMR</a:t>
-            </a:r>
-            <a:r>
-              <a:rPr lang="en-US" sz="1500" dirty="0">
-                <a:solidFill>
-                  <a:srgbClr val="0F172A"/>
-                </a:solidFill>
-                <a:latin typeface="Calibri" pitchFamily="34" charset="0"/>
-                <a:ea typeface="Calibri" pitchFamily="34" charset="-122"/>
-                <a:cs typeface="Calibri" pitchFamily="34" charset="-120"/>
-              </a:rPr>
-              <a:t> vs. </a:t>
-            </a:r>
-            <a:r>
-              <a:rPr lang="en-US" sz="1500" b="1" dirty="0">
-                <a:solidFill>
-                  <a:srgbClr val="0F172A"/>
-                </a:solidFill>
-                <a:latin typeface="Calibri" pitchFamily="34" charset="0"/>
-                <a:ea typeface="Calibri" pitchFamily="34" charset="-122"/>
-                <a:cs typeface="Calibri" pitchFamily="34" charset="-120"/>
-              </a:rPr>
-              <a:t>TRR</a:t>
-            </a:r>
-            <a:r>
-              <a:rPr lang="en-US" sz="1500" dirty="0">
-                <a:solidFill>
-                  <a:srgbClr val="0F172A"/>
-                </a:solidFill>
-                <a:latin typeface="Calibri" pitchFamily="34" charset="0"/>
-                <a:ea typeface="Calibri" pitchFamily="34" charset="-122"/>
-                <a:cs typeface="Calibri" pitchFamily="34" charset="-120"/>
-              </a:rPr>
-              <a:t> vs. </a:t>
-            </a:r>
-            <a:r>
-              <a:rPr lang="en-US" sz="1500" b="1" dirty="0">
-                <a:solidFill>
-                  <a:srgbClr val="0F172A"/>
-                </a:solidFill>
-                <a:latin typeface="Calibri" pitchFamily="34" charset="0"/>
-                <a:ea typeface="Calibri" pitchFamily="34" charset="-122"/>
-                <a:cs typeface="Calibri" pitchFamily="34" charset="-120"/>
-              </a:rPr>
-              <a:t>MRR</a:t>
-            </a:r>
-            <a:r>
-              <a:rPr lang="en-US" sz="1500" dirty="0">
-                <a:solidFill>
-                  <a:srgbClr val="0F172A"/>
-                </a:solidFill>
-                <a:latin typeface="Calibri" pitchFamily="34" charset="0"/>
-                <a:ea typeface="Calibri" pitchFamily="34" charset="-122"/>
-                <a:cs typeface="Calibri" pitchFamily="34" charset="-120"/>
-              </a:rPr>
-              <a:t> based on the issue.</a:t>
-            </a:r>
-            <a:endParaRPr lang="en-US" sz="1500" dirty="0"/>
-          </a:p>
-          <a:p>
-            <a:pPr marL="228600" indent="-228600">
-              <a:spcAft>
-                <a:spcPts val="1400"/>
-              </a:spcAft>
-              <a:buSzPct val="100000"/>
-              <a:buChar char="■"/>
-            </a:pPr>
-            <a:r>
-              <a:rPr lang="en-US" sz="1500" b="1" dirty="0">
-                <a:solidFill>
-                  <a:srgbClr val="0F172A"/>
-                </a:solidFill>
-                <a:latin typeface="Calibri" pitchFamily="34" charset="0"/>
-                <a:ea typeface="Calibri" pitchFamily="34" charset="-122"/>
-                <a:cs typeface="Calibri" pitchFamily="34" charset="-120"/>
-              </a:rPr>
-              <a:t>Create Change Request</a:t>
-            </a:r>
-            <a:r>
-              <a:rPr lang="en-US" sz="1500" dirty="0">
-                <a:solidFill>
-                  <a:srgbClr val="0F172A"/>
-                </a:solidFill>
-                <a:latin typeface="Calibri" pitchFamily="34" charset="0"/>
-                <a:ea typeface="Calibri" pitchFamily="34" charset="-122"/>
-                <a:cs typeface="Calibri" pitchFamily="34" charset="-120"/>
-              </a:rPr>
-              <a:t>: Priority, Initial Change, Requested By.</a:t>
-            </a:r>
-            <a:endParaRPr lang="en-US" sz="1500" dirty="0"/>
-          </a:p>
-          <a:p>
-            <a:pPr marL="228600" indent="-228600">
-              <a:spcAft>
-                <a:spcPts val="1400"/>
-              </a:spcAft>
-              <a:buSzPct val="100000"/>
-              <a:buChar char="■"/>
-            </a:pPr>
-            <a:r>
-              <a:rPr lang="en-US" sz="1500" b="1" dirty="0">
-                <a:solidFill>
-                  <a:srgbClr val="0F172A"/>
-                </a:solidFill>
-                <a:latin typeface="Calibri" pitchFamily="34" charset="0"/>
-                <a:ea typeface="Calibri" pitchFamily="34" charset="-122"/>
-                <a:cs typeface="Calibri" pitchFamily="34" charset="-120"/>
-              </a:rPr>
-              <a:t>Change Request Management</a:t>
-            </a:r>
-            <a:r>
-              <a:rPr lang="en-US" sz="1500" dirty="0">
-                <a:solidFill>
-                  <a:srgbClr val="0F172A"/>
-                </a:solidFill>
-                <a:latin typeface="Calibri" pitchFamily="34" charset="0"/>
-                <a:ea typeface="Calibri" pitchFamily="34" charset="-122"/>
-                <a:cs typeface="Calibri" pitchFamily="34" charset="-120"/>
-              </a:rPr>
-              <a:t>: everything’s already filled in — she just grabs the CMR Number it generated.</a:t>
-            </a:r>
-            <a:endParaRPr lang="en-US" sz="1500" dirty="0"/>
-          </a:p>
-          <a:p>
-            <a:pPr marL="228600" indent="-228600">
-              <a:spcAft>
-                <a:spcPts val="1400"/>
-              </a:spcAft>
-              <a:buSzPct val="100000"/>
-              <a:buChar char="■"/>
-            </a:pPr>
-            <a:r>
-              <a:rPr lang="en-US" sz="1500" b="1" dirty="0">
-                <a:solidFill>
-                  <a:srgbClr val="0F172A"/>
-                </a:solidFill>
-                <a:latin typeface="Calibri" pitchFamily="34" charset="0"/>
-                <a:ea typeface="Calibri" pitchFamily="34" charset="-122"/>
-                <a:cs typeface="Calibri" pitchFamily="34" charset="-120"/>
-              </a:rPr>
-              <a:t>CMR Form</a:t>
-            </a:r>
-            <a:r>
-              <a:rPr lang="en-US" sz="1500" dirty="0">
-                <a:solidFill>
-                  <a:srgbClr val="0F172A"/>
-                </a:solidFill>
-                <a:latin typeface="Calibri" pitchFamily="34" charset="0"/>
-                <a:ea typeface="Calibri" pitchFamily="34" charset="-122"/>
-                <a:cs typeface="Calibri" pitchFamily="34" charset="-120"/>
-              </a:rPr>
-              <a:t>: assign engineering, pull Item/Revision from the drawing books, Disposition starts </a:t>
-            </a:r>
-            <a:r>
-              <a:rPr lang="en-US" sz="1500" b="1" dirty="0">
-                <a:solidFill>
-                  <a:srgbClr val="0F172A"/>
-                </a:solidFill>
-                <a:latin typeface="Calibri" pitchFamily="34" charset="0"/>
-                <a:ea typeface="Calibri" pitchFamily="34" charset="-122"/>
-                <a:cs typeface="Calibri" pitchFamily="34" charset="-120"/>
-              </a:rPr>
-              <a:t>On Hold</a:t>
-            </a:r>
-            <a:r>
-              <a:rPr lang="en-US" sz="1500" dirty="0">
-                <a:solidFill>
-                  <a:srgbClr val="0F172A"/>
-                </a:solidFill>
-                <a:latin typeface="Calibri" pitchFamily="34" charset="0"/>
-                <a:ea typeface="Calibri" pitchFamily="34" charset="-122"/>
-                <a:cs typeface="Calibri" pitchFamily="34" charset="-120"/>
-              </a:rPr>
-              <a:t>, RCA notes copied from the intake email (Serial #/LOT # currently get copied into the Notes here too).</a:t>
-            </a:r>
-            <a:endParaRPr lang="en-US" sz="1500" dirty="0"/>
-          </a:p>
-          <a:p>
-            <a:pPr marL="228600" indent="-228600">
-              <a:spcAft>
-                <a:spcPts val="1400"/>
-              </a:spcAft>
-              <a:buSzPct val="100000"/>
-              <a:buChar char="■"/>
-            </a:pPr>
-            <a:r>
-              <a:rPr lang="en-US" sz="1500" dirty="0">
-                <a:solidFill>
-                  <a:srgbClr val="0F172A"/>
-                </a:solidFill>
-                <a:latin typeface="Calibri" pitchFamily="34" charset="0"/>
-                <a:ea typeface="Calibri" pitchFamily="34" charset="-122"/>
-                <a:cs typeface="Calibri" pitchFamily="34" charset="-120"/>
-              </a:rPr>
-              <a:t>Save, notify engineering (follow up after 24 hrs), then send the CMR Number back to the requester.</a:t>
-            </a:r>
-            <a:endParaRPr lang="en-US" sz="1500" dirty="0"/>
-          </a:p>
-        </p:txBody>
-      </p:sp>
-    </p:spTree>
-  </p:cSld>
-  <p:clrMapOvr>
-    <a:masterClrMapping/>
-  </p:clrMapOvr>
-</p:sld>
-</file>
-
-<file path=ppt/slides/slide12.xml><?xml version="1.0" encoding="utf-8"?>
-<p:sld xmlns:a="http://schemas.openxmlformats.org/drawingml/2006/main" xmlns:r="http://schemas.openxmlformats.org/officeDocument/2006/relationships" xmlns:p="http://schemas.openxmlformats.org/presentationml/2006/main">
-  <p:cSld name="Slide 3">
-    <p:bg>
-      <p:bgPr>
-        <a:solidFill>
-          <a:srgbClr val="F8FAFC"/>
-        </a:solidFill>
-        <a:effectLst/>
-      </p:bgPr>
-    </p:bg>
-    <p:spTree>
-      <p:nvGrpSpPr>
-        <p:cNvPr id="1" name=""/>
-        <p:cNvGrpSpPr/>
-        <p:nvPr/>
-      </p:nvGrpSpPr>
-      <p:grpSpPr>
-        <a:xfrm>
-          <a:off x="0" y="0"/>
-          <a:ext cx="0" cy="0"/>
-          <a:chOff x="0" y="0"/>
-          <a:chExt cx="0" cy="0"/>
-        </a:xfrm>
-      </p:grpSpPr>
-      <p:sp>
-        <p:nvSpPr>
-          <p:cNvPr id="2" name="Shape 0"/>
-          <p:cNvSpPr/>
-          <p:nvPr/>
-        </p:nvSpPr>
-        <p:spPr>
-          <a:xfrm>
-            <a:off x="457200" y="502920"/>
-            <a:ext cx="1371600" cy="1371600"/>
-          </a:xfrm>
-          <a:prstGeom prst="roundRect">
-            <a:avLst>
-              <a:gd name="adj" fmla="val 8000"/>
-            </a:avLst>
-          </a:prstGeom>
-          <a:solidFill>
-            <a:srgbClr val="ECFDF5"/>
-          </a:solidFill>
-          <a:ln w="12700">
-            <a:solidFill>
-              <a:srgbClr val="E2E8F0"/>
-            </a:solidFill>
-            <a:prstDash val="solid"/>
-          </a:ln>
-        </p:spPr>
-        <p:txBody>
-          <a:bodyPr/>
-          <a:lstStyle/>
-          <a:p>
-            <a:endParaRPr lang="en-US"/>
-          </a:p>
-        </p:txBody>
-      </p:sp>
-      <p:pic>
-        <p:nvPicPr>
-          <p:cNvPr id="3" name="Image 0" descr="icons/flow.png"/>
-          <p:cNvPicPr>
-            <a:picLocks noChangeAspect="1"/>
-          </p:cNvPicPr>
-          <p:nvPr/>
-        </p:nvPicPr>
-        <p:blipFill>
-          <a:blip r:embed="rId4"/>
-          <a:stretch>
-            <a:fillRect/>
-          </a:stretch>
-        </p:blipFill>
-        <p:spPr>
-          <a:xfrm>
-            <a:off x="800100" y="845820"/>
-            <a:ext cx="685800" cy="685800"/>
-          </a:xfrm>
-          <a:prstGeom prst="rect">
-            <a:avLst/>
-          </a:prstGeom>
-        </p:spPr>
-      </p:pic>
-      <p:sp>
-        <p:nvSpPr>
-          <p:cNvPr id="4" name="Text 1"/>
-          <p:cNvSpPr/>
-          <p:nvPr/>
-        </p:nvSpPr>
-        <p:spPr>
-          <a:xfrm>
-            <a:off x="2194560" y="502920"/>
-            <a:ext cx="9539935" cy="685800"/>
-          </a:xfrm>
-          <a:prstGeom prst="rect">
-            <a:avLst/>
-          </a:prstGeom>
-          <a:noFill/>
-          <a:ln/>
-        </p:spPr>
-        <p:txBody>
-          <a:bodyPr wrap="square" lIns="0" tIns="0" rIns="0" bIns="0" rtlCol="0" anchor="t"/>
-          <a:lstStyle/>
-          <a:p>
-            <a:pPr marL="0" indent="0" algn="l">
-              <a:buNone/>
-            </a:pPr>
-            <a:r>
-              <a:rPr lang="en-US" sz="3400" b="1" dirty="0">
-                <a:solidFill>
-                  <a:srgbClr val="0F172A"/>
-                </a:solidFill>
-                <a:latin typeface="Cambria" pitchFamily="34" charset="0"/>
-                <a:ea typeface="Cambria" pitchFamily="34" charset="-122"/>
-                <a:cs typeface="Cambria" pitchFamily="34" charset="-120"/>
-              </a:rPr>
-              <a:t>Today’s process flow</a:t>
-            </a:r>
-            <a:endParaRPr lang="en-US" sz="3400" dirty="0"/>
-          </a:p>
-        </p:txBody>
-      </p:sp>
-      <p:sp>
-        <p:nvSpPr>
-          <p:cNvPr id="5" name="Text 2"/>
-          <p:cNvSpPr/>
-          <p:nvPr/>
-        </p:nvSpPr>
-        <p:spPr>
-          <a:xfrm>
-            <a:off x="2194560" y="1216152"/>
-            <a:ext cx="9539935" cy="640080"/>
-          </a:xfrm>
-          <a:prstGeom prst="rect">
-            <a:avLst/>
-          </a:prstGeom>
-          <a:noFill/>
-          <a:ln/>
-        </p:spPr>
-        <p:txBody>
-          <a:bodyPr wrap="square" lIns="0" tIns="0" rIns="0" bIns="0" rtlCol="0" anchor="t"/>
-          <a:lstStyle/>
-          <a:p>
-            <a:pPr marL="0" indent="0" algn="l">
-              <a:buNone/>
-            </a:pPr>
-            <a:r>
-              <a:rPr lang="en-US" sz="1600" dirty="0">
-                <a:solidFill>
-                  <a:srgbClr val="64748B"/>
-                </a:solidFill>
-                <a:latin typeface="Calibri" pitchFamily="34" charset="0"/>
-                <a:ea typeface="Calibri" pitchFamily="34" charset="-122"/>
-                <a:cs typeface="Calibri" pitchFamily="34" charset="-120"/>
-              </a:rPr>
-              <a:t>How a CMR moves through the current three-form process, start to finish.</a:t>
-            </a:r>
-            <a:endParaRPr lang="en-US" sz="1600" dirty="0"/>
-          </a:p>
-        </p:txBody>
-      </p:sp>
-      <p:sp>
-        <p:nvSpPr>
-          <p:cNvPr id="6" name="Shape 3"/>
-          <p:cNvSpPr/>
-          <p:nvPr/>
-        </p:nvSpPr>
-        <p:spPr>
-          <a:xfrm>
-            <a:off x="457200" y="2148840"/>
-            <a:ext cx="11277295" cy="4251960"/>
-          </a:xfrm>
-          <a:prstGeom prst="roundRect">
-            <a:avLst>
-              <a:gd name="adj" fmla="val 2581"/>
-            </a:avLst>
-          </a:prstGeom>
-          <a:solidFill>
-            <a:srgbClr val="FFFFFF"/>
-          </a:solidFill>
-          <a:ln w="12700">
-            <a:solidFill>
-              <a:srgbClr val="E2E8F0"/>
-            </a:solidFill>
-            <a:prstDash val="solid"/>
-          </a:ln>
-          <a:effectLst>
-            <a:outerShdw blurRad="152400" dist="38100" dir="5400000" algn="bl" rotWithShape="0">
-              <a:srgbClr val="1E293B">
-                <a:alpha val="8000"/>
-              </a:srgbClr>
-            </a:outerShdw>
-          </a:effectLst>
-        </p:spPr>
-        <p:txBody>
-          <a:bodyPr/>
-          <a:lstStyle/>
-          <a:p>
-            <a:endParaRPr lang="en-US"/>
-          </a:p>
-        </p:txBody>
-      </p:sp>
-      <p:sp>
-        <p:nvSpPr>
-          <p:cNvPr id="7" name="Text 4"/>
-          <p:cNvSpPr/>
-          <p:nvPr/>
-        </p:nvSpPr>
-        <p:spPr>
-          <a:xfrm>
-            <a:off x="822960" y="2514600"/>
-            <a:ext cx="9144000" cy="365760"/>
-          </a:xfrm>
-          <a:prstGeom prst="rect">
-            <a:avLst/>
-          </a:prstGeom>
-          <a:noFill/>
-          <a:ln/>
-        </p:spPr>
-        <p:txBody>
-          <a:bodyPr wrap="square" lIns="0" tIns="0" rIns="0" bIns="0" rtlCol="0" anchor="t"/>
-          <a:lstStyle/>
-          <a:p>
-            <a:pPr marL="0" indent="0" algn="l">
-              <a:buNone/>
-            </a:pPr>
-            <a:r>
-              <a:rPr lang="en-US" sz="1500" b="1" dirty="0">
-                <a:solidFill>
-                  <a:srgbClr val="059669"/>
-                </a:solidFill>
-                <a:latin typeface="Calibri" pitchFamily="34" charset="0"/>
-                <a:ea typeface="Calibri" pitchFamily="34" charset="-122"/>
-                <a:cs typeface="Calibri" pitchFamily="34" charset="-120"/>
-              </a:rPr>
-              <a:t>Actual process flow</a:t>
-            </a:r>
-            <a:endParaRPr lang="en-US" sz="1500" dirty="0"/>
-          </a:p>
-        </p:txBody>
-      </p:sp>
-      <p:sp>
-        <p:nvSpPr>
-          <p:cNvPr id="100" name="Shape 100"/>
-          <p:cNvSpPr/>
-          <p:nvPr/>
-        </p:nvSpPr>
-        <p:spPr>
-          <a:xfrm>
-            <a:off x="822960" y="2926080"/>
-            <a:ext cx="1490929" cy="1828800"/>
-          </a:xfrm>
-          <a:prstGeom prst="roundRect">
-            <a:avLst>
-              <a:gd name="adj" fmla="val 4438"/>
-            </a:avLst>
-          </a:prstGeom>
-          <a:solidFill>
-            <a:srgbClr val="F8FAFC"/>
-          </a:solidFill>
-          <a:ln w="12700">
-            <a:solidFill>
-              <a:srgbClr val="E2E8F0"/>
-            </a:solidFill>
-            <a:prstDash val="solid"/>
-          </a:ln>
-        </p:spPr>
-        <p:txBody>
-          <a:bodyPr/>
-          <a:lstStyle/>
-          <a:p>
-            <a:endParaRPr lang="en-US"/>
-          </a:p>
-        </p:txBody>
-      </p:sp>
-      <p:sp>
-        <p:nvSpPr>
-          <p:cNvPr id="101" name="Text 101"/>
-          <p:cNvSpPr/>
-          <p:nvPr/>
-        </p:nvSpPr>
-        <p:spPr>
-          <a:xfrm>
-            <a:off x="987552" y="3090672"/>
-            <a:ext cx="1161745" cy="1554480"/>
-          </a:xfrm>
-          <a:prstGeom prst="rect">
-            <a:avLst/>
-          </a:prstGeom>
-          <a:noFill/>
-          <a:ln/>
-        </p:spPr>
-        <p:txBody>
-          <a:bodyPr wrap="square" lIns="0" tIns="0" rIns="0" bIns="0" rtlCol="0" anchor="t"/>
-          <a:lstStyle/>
-          <a:p>
-            <a:pPr marL="0" indent="0">
-              <a:lnSpc>
-                <a:spcPts val="1600"/>
-              </a:lnSpc>
-              <a:buNone/>
-            </a:pPr>
-            <a:r>
-              <a:rPr lang="en-US" sz="1400" b="1" dirty="0">
-                <a:solidFill>
-                  <a:srgbClr val="059669"/>
-                </a:solidFill>
-                <a:latin typeface="Calibri" pitchFamily="34" charset="0"/>
-                <a:ea typeface="Calibri" pitchFamily="34" charset="-122"/>
-                <a:cs typeface="Calibri" pitchFamily="34" charset="-120"/>
-              </a:rPr>
-              <a:t>PIR Email</a:t>
-            </a:r>
-            <a:endParaRPr lang="en-US" sz="1400" dirty="0"/>
-          </a:p>
-          <a:p>
-            <a:pPr marL="0" indent="0">
-              <a:lnSpc>
-                <a:spcPts val="1600"/>
-              </a:lnSpc>
-              <a:buNone/>
-            </a:pPr>
-            <a:r>
-              <a:rPr lang="en-US" sz="1250" dirty="0">
-                <a:solidFill>
-                  <a:srgbClr val="0F172A"/>
-                </a:solidFill>
-                <a:latin typeface="Calibri" pitchFamily="34" charset="0"/>
-                <a:ea typeface="Calibri" pitchFamily="34" charset="-122"/>
-                <a:cs typeface="Calibri" pitchFamily="34" charset="-120"/>
-              </a:rPr>
-              <a:t>Job, Serial #, PN, Part, Issue from Production</a:t>
-            </a:r>
-            <a:endParaRPr lang="en-US" sz="1400" dirty="0"/>
-          </a:p>
-        </p:txBody>
-      </p:sp>
-      <p:sp>
-        <p:nvSpPr>
-          <p:cNvPr id="102" name="Text 102"/>
-          <p:cNvSpPr/>
-          <p:nvPr/>
-        </p:nvSpPr>
-        <p:spPr>
-          <a:xfrm>
-            <a:off x="2313889" y="2926080"/>
-            <a:ext cx="320040" cy="1828800"/>
-          </a:xfrm>
-          <a:prstGeom prst="rect">
-            <a:avLst/>
-          </a:prstGeom>
-          <a:noFill/>
-          <a:ln/>
-        </p:spPr>
-        <p:txBody>
-          <a:bodyPr wrap="square" lIns="0" tIns="0" rIns="0" bIns="0" rtlCol="0" anchor="ctr"/>
-          <a:lstStyle/>
-          <a:p>
-            <a:pPr marL="0" indent="0" algn="ctr">
-              <a:buNone/>
-            </a:pPr>
-            <a:r>
-              <a:rPr lang="en-US" sz="1800" dirty="0">
-                <a:solidFill>
-                  <a:srgbClr val="059669"/>
-                </a:solidFill>
-                <a:latin typeface="Calibri" pitchFamily="34" charset="0"/>
-                <a:ea typeface="Calibri" pitchFamily="34" charset="-122"/>
-                <a:cs typeface="Calibri" pitchFamily="34" charset="-120"/>
-              </a:rPr>
-              <a:t>→</a:t>
-            </a:r>
-            <a:endParaRPr lang="en-US" sz="1800" dirty="0"/>
-          </a:p>
-        </p:txBody>
-      </p:sp>
-      <p:sp>
-        <p:nvSpPr>
-          <p:cNvPr id="103" name="Shape 103"/>
-          <p:cNvSpPr/>
-          <p:nvPr/>
-        </p:nvSpPr>
-        <p:spPr>
-          <a:xfrm>
-            <a:off x="2633929" y="2926080"/>
-            <a:ext cx="1490929" cy="1828800"/>
-          </a:xfrm>
-          <a:prstGeom prst="roundRect">
-            <a:avLst>
-              <a:gd name="adj" fmla="val 4438"/>
-            </a:avLst>
-          </a:prstGeom>
-          <a:solidFill>
-            <a:srgbClr val="F8FAFC"/>
-          </a:solidFill>
-          <a:ln w="12700">
-            <a:solidFill>
-              <a:srgbClr val="E2E8F0"/>
-            </a:solidFill>
-            <a:prstDash val="solid"/>
-          </a:ln>
-        </p:spPr>
-        <p:txBody>
-          <a:bodyPr/>
-          <a:lstStyle/>
-          <a:p>
-            <a:endParaRPr lang="en-US"/>
-          </a:p>
-        </p:txBody>
-      </p:sp>
-      <p:sp>
-        <p:nvSpPr>
-          <p:cNvPr id="104" name="Text 104"/>
-          <p:cNvSpPr/>
-          <p:nvPr/>
-        </p:nvSpPr>
-        <p:spPr>
-          <a:xfrm>
-            <a:off x="2798521" y="3090672"/>
-            <a:ext cx="1161745" cy="1554480"/>
-          </a:xfrm>
-          <a:prstGeom prst="rect">
-            <a:avLst/>
-          </a:prstGeom>
-          <a:noFill/>
-          <a:ln/>
-        </p:spPr>
-        <p:txBody>
-          <a:bodyPr wrap="square" lIns="0" tIns="0" rIns="0" bIns="0" rtlCol="0" anchor="t"/>
-          <a:lstStyle/>
-          <a:p>
-            <a:pPr marL="0" indent="0">
-              <a:lnSpc>
-                <a:spcPts val="1600"/>
-              </a:lnSpc>
-              <a:buNone/>
-            </a:pPr>
-            <a:r>
-              <a:rPr lang="en-US" sz="1400" b="1" dirty="0">
-                <a:solidFill>
-                  <a:srgbClr val="059669"/>
-                </a:solidFill>
-                <a:latin typeface="Calibri" pitchFamily="34" charset="0"/>
-                <a:ea typeface="Calibri" pitchFamily="34" charset="-122"/>
-                <a:cs typeface="Calibri" pitchFamily="34" charset="-120"/>
-              </a:rPr>
-              <a:t>Triage</a:t>
-            </a:r>
-            <a:endParaRPr lang="en-US" sz="1400" dirty="0"/>
-          </a:p>
-          <a:p>
-            <a:pPr marL="0" indent="0">
-              <a:lnSpc>
-                <a:spcPts val="1600"/>
-              </a:lnSpc>
-              <a:buNone/>
-            </a:pPr>
-            <a:r>
-              <a:rPr lang="en-US" sz="1250" dirty="0">
-                <a:solidFill>
-                  <a:srgbClr val="0F172A"/>
-                </a:solidFill>
-                <a:latin typeface="Calibri" pitchFamily="34" charset="0"/>
-                <a:ea typeface="Calibri" pitchFamily="34" charset="-122"/>
-                <a:cs typeface="Calibri" pitchFamily="34" charset="-120"/>
-              </a:rPr>
-              <a:t>Jasmine decides CMR vs. TRR vs. MRR</a:t>
-            </a:r>
-            <a:endParaRPr lang="en-US" sz="1400" dirty="0"/>
-          </a:p>
-        </p:txBody>
-      </p:sp>
-      <p:sp>
-        <p:nvSpPr>
-          <p:cNvPr id="105" name="Text 105"/>
-          <p:cNvSpPr/>
-          <p:nvPr/>
-        </p:nvSpPr>
-        <p:spPr>
-          <a:xfrm>
-            <a:off x="4124858" y="2926080"/>
-            <a:ext cx="320040" cy="1828800"/>
-          </a:xfrm>
-          <a:prstGeom prst="rect">
-            <a:avLst/>
-          </a:prstGeom>
-          <a:noFill/>
-          <a:ln/>
-        </p:spPr>
-        <p:txBody>
-          <a:bodyPr wrap="square" lIns="0" tIns="0" rIns="0" bIns="0" rtlCol="0" anchor="ctr"/>
-          <a:lstStyle/>
-          <a:p>
-            <a:pPr marL="0" indent="0" algn="ctr">
-              <a:buNone/>
-            </a:pPr>
-            <a:r>
-              <a:rPr lang="en-US" sz="1800" dirty="0">
-                <a:solidFill>
-                  <a:srgbClr val="059669"/>
-                </a:solidFill>
-                <a:latin typeface="Calibri" pitchFamily="34" charset="0"/>
-                <a:ea typeface="Calibri" pitchFamily="34" charset="-122"/>
-                <a:cs typeface="Calibri" pitchFamily="34" charset="-120"/>
-              </a:rPr>
-              <a:t>→</a:t>
-            </a:r>
-            <a:endParaRPr lang="en-US" sz="1800" dirty="0"/>
-          </a:p>
-        </p:txBody>
-      </p:sp>
-      <p:sp>
-        <p:nvSpPr>
-          <p:cNvPr id="106" name="Shape 106"/>
-          <p:cNvSpPr/>
-          <p:nvPr/>
-        </p:nvSpPr>
-        <p:spPr>
-          <a:xfrm>
-            <a:off x="4444898" y="2926080"/>
-            <a:ext cx="1490929" cy="1828800"/>
-          </a:xfrm>
-          <a:prstGeom prst="roundRect">
-            <a:avLst>
-              <a:gd name="adj" fmla="val 4438"/>
-            </a:avLst>
-          </a:prstGeom>
-          <a:solidFill>
-            <a:srgbClr val="F8FAFC"/>
-          </a:solidFill>
-          <a:ln w="12700">
-            <a:solidFill>
-              <a:srgbClr val="E2E8F0"/>
-            </a:solidFill>
-            <a:prstDash val="solid"/>
-          </a:ln>
-        </p:spPr>
-        <p:txBody>
-          <a:bodyPr/>
-          <a:lstStyle/>
-          <a:p>
-            <a:endParaRPr lang="en-US"/>
-          </a:p>
-        </p:txBody>
-      </p:sp>
-      <p:sp>
-        <p:nvSpPr>
-          <p:cNvPr id="107" name="Text 107"/>
-          <p:cNvSpPr/>
-          <p:nvPr/>
-        </p:nvSpPr>
-        <p:spPr>
-          <a:xfrm>
-            <a:off x="4609490" y="3090672"/>
-            <a:ext cx="1161745" cy="1554480"/>
-          </a:xfrm>
-          <a:prstGeom prst="rect">
-            <a:avLst/>
-          </a:prstGeom>
-          <a:noFill/>
-          <a:ln/>
-        </p:spPr>
-        <p:txBody>
-          <a:bodyPr wrap="square" lIns="0" tIns="0" rIns="0" bIns="0" rtlCol="0" anchor="t"/>
-          <a:lstStyle/>
-          <a:p>
-            <a:pPr marL="0" indent="0">
-              <a:lnSpc>
-                <a:spcPts val="1600"/>
-              </a:lnSpc>
-              <a:buNone/>
-            </a:pPr>
-            <a:r>
-              <a:rPr lang="en-US" sz="1400" b="1" dirty="0">
-                <a:solidFill>
-                  <a:srgbClr val="059669"/>
-                </a:solidFill>
-                <a:latin typeface="Calibri" pitchFamily="34" charset="0"/>
-                <a:ea typeface="Calibri" pitchFamily="34" charset="-122"/>
-                <a:cs typeface="Calibri" pitchFamily="34" charset="-120"/>
-              </a:rPr>
-              <a:t>Create Change Request</a:t>
-            </a:r>
-            <a:endParaRPr lang="en-US" sz="1400" dirty="0"/>
-          </a:p>
-          <a:p>
-            <a:pPr marL="0" indent="0">
-              <a:lnSpc>
-                <a:spcPts val="1600"/>
-              </a:lnSpc>
-              <a:buNone/>
-            </a:pPr>
-            <a:r>
-              <a:rPr lang="en-US" sz="1250" dirty="0">
-                <a:solidFill>
-                  <a:srgbClr val="0F172A"/>
-                </a:solidFill>
-                <a:latin typeface="Calibri" pitchFamily="34" charset="0"/>
-                <a:ea typeface="Calibri" pitchFamily="34" charset="-122"/>
-                <a:cs typeface="Calibri" pitchFamily="34" charset="-120"/>
-              </a:rPr>
-              <a:t>Priority, Initial Change, Requested By</a:t>
-            </a:r>
-            <a:endParaRPr lang="en-US" sz="1400" dirty="0"/>
-          </a:p>
-        </p:txBody>
-      </p:sp>
-      <p:sp>
-        <p:nvSpPr>
-          <p:cNvPr id="108" name="Text 108"/>
-          <p:cNvSpPr/>
-          <p:nvPr/>
-        </p:nvSpPr>
-        <p:spPr>
-          <a:xfrm>
-            <a:off x="5935827" y="2926080"/>
-            <a:ext cx="320040" cy="1828800"/>
-          </a:xfrm>
-          <a:prstGeom prst="rect">
-            <a:avLst/>
-          </a:prstGeom>
-          <a:noFill/>
-          <a:ln/>
-        </p:spPr>
-        <p:txBody>
-          <a:bodyPr wrap="square" lIns="0" tIns="0" rIns="0" bIns="0" rtlCol="0" anchor="ctr"/>
-          <a:lstStyle/>
-          <a:p>
-            <a:pPr marL="0" indent="0" algn="ctr">
-              <a:buNone/>
-            </a:pPr>
-            <a:r>
-              <a:rPr lang="en-US" sz="1800" dirty="0">
-                <a:solidFill>
-                  <a:srgbClr val="059669"/>
-                </a:solidFill>
-                <a:latin typeface="Calibri" pitchFamily="34" charset="0"/>
-                <a:ea typeface="Calibri" pitchFamily="34" charset="-122"/>
-                <a:cs typeface="Calibri" pitchFamily="34" charset="-120"/>
-              </a:rPr>
-              <a:t>→</a:t>
-            </a:r>
-            <a:endParaRPr lang="en-US" sz="1800" dirty="0"/>
-          </a:p>
-        </p:txBody>
-      </p:sp>
-      <p:sp>
-        <p:nvSpPr>
-          <p:cNvPr id="109" name="Shape 109"/>
-          <p:cNvSpPr/>
-          <p:nvPr/>
-        </p:nvSpPr>
-        <p:spPr>
-          <a:xfrm>
-            <a:off x="6255867" y="2926080"/>
-            <a:ext cx="1490929" cy="1828800"/>
-          </a:xfrm>
-          <a:prstGeom prst="roundRect">
-            <a:avLst>
-              <a:gd name="adj" fmla="val 4438"/>
-            </a:avLst>
-          </a:prstGeom>
-          <a:solidFill>
-            <a:srgbClr val="F8FAFC"/>
-          </a:solidFill>
-          <a:ln w="12700">
-            <a:solidFill>
-              <a:srgbClr val="E2E8F0"/>
-            </a:solidFill>
-            <a:prstDash val="solid"/>
-          </a:ln>
-        </p:spPr>
-        <p:txBody>
-          <a:bodyPr/>
-          <a:lstStyle/>
-          <a:p>
-            <a:endParaRPr lang="en-US"/>
-          </a:p>
-        </p:txBody>
-      </p:sp>
-      <p:sp>
-        <p:nvSpPr>
-          <p:cNvPr id="110" name="Text 110"/>
-          <p:cNvSpPr/>
-          <p:nvPr/>
-        </p:nvSpPr>
-        <p:spPr>
-          <a:xfrm>
-            <a:off x="6420459" y="3090672"/>
-            <a:ext cx="1161745" cy="1554480"/>
-          </a:xfrm>
-          <a:prstGeom prst="rect">
-            <a:avLst/>
-          </a:prstGeom>
-          <a:noFill/>
-          <a:ln/>
-        </p:spPr>
-        <p:txBody>
-          <a:bodyPr wrap="square" lIns="0" tIns="0" rIns="0" bIns="0" rtlCol="0" anchor="t"/>
-          <a:lstStyle/>
-          <a:p>
-            <a:pPr marL="0" indent="0">
-              <a:lnSpc>
-                <a:spcPts val="1600"/>
-              </a:lnSpc>
-              <a:buNone/>
-            </a:pPr>
-            <a:r>
-              <a:rPr lang="en-US" sz="1400" b="1" dirty="0">
-                <a:solidFill>
-                  <a:srgbClr val="059669"/>
-                </a:solidFill>
-                <a:latin typeface="Calibri" pitchFamily="34" charset="0"/>
-                <a:ea typeface="Calibri" pitchFamily="34" charset="-122"/>
-                <a:cs typeface="Calibri" pitchFamily="34" charset="-120"/>
-              </a:rPr>
-              <a:t>Change Request Mgmt</a:t>
-            </a:r>
-            <a:endParaRPr lang="en-US" sz="1400" dirty="0"/>
-          </a:p>
-          <a:p>
-            <a:pPr marL="0" indent="0">
-              <a:lnSpc>
-                <a:spcPts val="1600"/>
-              </a:lnSpc>
-              <a:buNone/>
-            </a:pPr>
-            <a:r>
-              <a:rPr lang="en-US" sz="1250" dirty="0">
-                <a:solidFill>
-                  <a:srgbClr val="0F172A"/>
-                </a:solidFill>
-                <a:latin typeface="Calibri" pitchFamily="34" charset="0"/>
-                <a:ea typeface="Calibri" pitchFamily="34" charset="-122"/>
-                <a:cs typeface="Calibri" pitchFamily="34" charset="-120"/>
-              </a:rPr>
-              <a:t>Grab the CMR Number</a:t>
-            </a:r>
-            <a:endParaRPr lang="en-US" sz="1400" dirty="0"/>
-          </a:p>
-        </p:txBody>
-      </p:sp>
-      <p:sp>
-        <p:nvSpPr>
-          <p:cNvPr id="111" name="Text 111"/>
-          <p:cNvSpPr/>
-          <p:nvPr/>
-        </p:nvSpPr>
-        <p:spPr>
-          <a:xfrm>
-            <a:off x="7746796" y="2926080"/>
-            <a:ext cx="320040" cy="1828800"/>
-          </a:xfrm>
-          <a:prstGeom prst="rect">
-            <a:avLst/>
-          </a:prstGeom>
-          <a:noFill/>
-          <a:ln/>
-        </p:spPr>
-        <p:txBody>
-          <a:bodyPr wrap="square" lIns="0" tIns="0" rIns="0" bIns="0" rtlCol="0" anchor="ctr"/>
-          <a:lstStyle/>
-          <a:p>
-            <a:pPr marL="0" indent="0" algn="ctr">
-              <a:buNone/>
-            </a:pPr>
-            <a:r>
-              <a:rPr lang="en-US" sz="1800" dirty="0">
-                <a:solidFill>
-                  <a:srgbClr val="059669"/>
-                </a:solidFill>
-                <a:latin typeface="Calibri" pitchFamily="34" charset="0"/>
-                <a:ea typeface="Calibri" pitchFamily="34" charset="-122"/>
-                <a:cs typeface="Calibri" pitchFamily="34" charset="-120"/>
-              </a:rPr>
-              <a:t>→</a:t>
-            </a:r>
-            <a:endParaRPr lang="en-US" sz="1800" dirty="0"/>
-          </a:p>
-        </p:txBody>
-      </p:sp>
-      <p:sp>
-        <p:nvSpPr>
-          <p:cNvPr id="112" name="Shape 112"/>
-          <p:cNvSpPr/>
-          <p:nvPr/>
-        </p:nvSpPr>
-        <p:spPr>
-          <a:xfrm>
-            <a:off x="8066836" y="2926080"/>
-            <a:ext cx="1490929" cy="1828800"/>
-          </a:xfrm>
-          <a:prstGeom prst="roundRect">
-            <a:avLst>
-              <a:gd name="adj" fmla="val 4438"/>
-            </a:avLst>
-          </a:prstGeom>
-          <a:solidFill>
-            <a:srgbClr val="F8FAFC"/>
-          </a:solidFill>
-          <a:ln w="12700">
-            <a:solidFill>
-              <a:srgbClr val="E2E8F0"/>
-            </a:solidFill>
-            <a:prstDash val="solid"/>
-          </a:ln>
-        </p:spPr>
-        <p:txBody>
-          <a:bodyPr/>
-          <a:lstStyle/>
-          <a:p>
-            <a:endParaRPr lang="en-US"/>
-          </a:p>
-        </p:txBody>
-      </p:sp>
-      <p:sp>
-        <p:nvSpPr>
-          <p:cNvPr id="113" name="Text 113"/>
-          <p:cNvSpPr/>
-          <p:nvPr/>
-        </p:nvSpPr>
-        <p:spPr>
-          <a:xfrm>
-            <a:off x="8231428" y="3090672"/>
-            <a:ext cx="1161745" cy="1554480"/>
-          </a:xfrm>
-          <a:prstGeom prst="rect">
-            <a:avLst/>
-          </a:prstGeom>
-          <a:noFill/>
-          <a:ln/>
-        </p:spPr>
-        <p:txBody>
-          <a:bodyPr wrap="square" lIns="0" tIns="0" rIns="0" bIns="0" rtlCol="0" anchor="t"/>
-          <a:lstStyle/>
-          <a:p>
-            <a:pPr marL="0" indent="0">
-              <a:lnSpc>
-                <a:spcPts val="1600"/>
-              </a:lnSpc>
-              <a:buNone/>
-            </a:pPr>
-            <a:r>
-              <a:rPr lang="en-US" sz="1400" b="1" dirty="0">
-                <a:solidFill>
-                  <a:srgbClr val="059669"/>
-                </a:solidFill>
-                <a:latin typeface="Calibri" pitchFamily="34" charset="0"/>
-                <a:ea typeface="Calibri" pitchFamily="34" charset="-122"/>
-                <a:cs typeface="Calibri" pitchFamily="34" charset="-120"/>
-              </a:rPr>
-              <a:t>CMR Form</a:t>
-            </a:r>
-            <a:endParaRPr lang="en-US" sz="1400" dirty="0"/>
-          </a:p>
-          <a:p>
-            <a:pPr marL="0" indent="0">
-              <a:lnSpc>
-                <a:spcPts val="1600"/>
-              </a:lnSpc>
-              <a:buNone/>
-            </a:pPr>
-            <a:r>
-              <a:rPr lang="en-US" sz="1250" dirty="0">
-                <a:solidFill>
-                  <a:srgbClr val="0F172A"/>
-                </a:solidFill>
-                <a:latin typeface="Calibri" pitchFamily="34" charset="0"/>
-                <a:ea typeface="Calibri" pitchFamily="34" charset="-122"/>
-                <a:cs typeface="Calibri" pitchFamily="34" charset="-120"/>
-              </a:rPr>
-              <a:t>Engineering, Item/Revision, On Hold</a:t>
-            </a:r>
-            <a:endParaRPr lang="en-US" sz="1400" dirty="0"/>
-          </a:p>
-        </p:txBody>
-      </p:sp>
-      <p:sp>
-        <p:nvSpPr>
-          <p:cNvPr id="114" name="Text 114"/>
-          <p:cNvSpPr/>
-          <p:nvPr/>
-        </p:nvSpPr>
-        <p:spPr>
-          <a:xfrm>
-            <a:off x="9557765" y="2926080"/>
-            <a:ext cx="320040" cy="1828800"/>
-          </a:xfrm>
-          <a:prstGeom prst="rect">
-            <a:avLst/>
-          </a:prstGeom>
-          <a:noFill/>
-          <a:ln/>
-        </p:spPr>
-        <p:txBody>
-          <a:bodyPr wrap="square" lIns="0" tIns="0" rIns="0" bIns="0" rtlCol="0" anchor="ctr"/>
-          <a:lstStyle/>
-          <a:p>
-            <a:pPr marL="0" indent="0" algn="ctr">
-              <a:buNone/>
-            </a:pPr>
-            <a:r>
-              <a:rPr lang="en-US" sz="1800" dirty="0">
-                <a:solidFill>
-                  <a:srgbClr val="059669"/>
-                </a:solidFill>
-                <a:latin typeface="Calibri" pitchFamily="34" charset="0"/>
-                <a:ea typeface="Calibri" pitchFamily="34" charset="-122"/>
-                <a:cs typeface="Calibri" pitchFamily="34" charset="-120"/>
-              </a:rPr>
-              <a:t>→</a:t>
-            </a:r>
-            <a:endParaRPr lang="en-US" sz="1800" dirty="0"/>
-          </a:p>
-        </p:txBody>
-      </p:sp>
-      <p:sp>
-        <p:nvSpPr>
-          <p:cNvPr id="115" name="Shape 115"/>
-          <p:cNvSpPr/>
-          <p:nvPr/>
-        </p:nvSpPr>
-        <p:spPr>
-          <a:xfrm>
-            <a:off x="9877805" y="2926080"/>
-            <a:ext cx="1490929" cy="1828800"/>
-          </a:xfrm>
-          <a:prstGeom prst="roundRect">
-            <a:avLst>
-              <a:gd name="adj" fmla="val 4438"/>
-            </a:avLst>
-          </a:prstGeom>
-          <a:solidFill>
-            <a:srgbClr val="F8FAFC"/>
-          </a:solidFill>
-          <a:ln w="12700">
-            <a:solidFill>
-              <a:srgbClr val="E2E8F0"/>
-            </a:solidFill>
-            <a:prstDash val="solid"/>
-          </a:ln>
-        </p:spPr>
-        <p:txBody>
-          <a:bodyPr/>
-          <a:lstStyle/>
-          <a:p>
-            <a:endParaRPr lang="en-US"/>
-          </a:p>
-        </p:txBody>
-      </p:sp>
-      <p:sp>
-        <p:nvSpPr>
-          <p:cNvPr id="116" name="Text 116"/>
-          <p:cNvSpPr/>
-          <p:nvPr/>
-        </p:nvSpPr>
-        <p:spPr>
-          <a:xfrm>
-            <a:off x="10042397" y="3090672"/>
-            <a:ext cx="1161745" cy="1554480"/>
-          </a:xfrm>
-          <a:prstGeom prst="rect">
-            <a:avLst/>
-          </a:prstGeom>
-          <a:noFill/>
-          <a:ln/>
-        </p:spPr>
-        <p:txBody>
-          <a:bodyPr wrap="square" lIns="0" tIns="0" rIns="0" bIns="0" rtlCol="0" anchor="t"/>
-          <a:lstStyle/>
-          <a:p>
-            <a:pPr marL="0" indent="0">
-              <a:lnSpc>
-                <a:spcPts val="1600"/>
-              </a:lnSpc>
-              <a:buNone/>
-            </a:pPr>
-            <a:r>
-              <a:rPr lang="en-US" sz="1400" b="1" dirty="0">
-                <a:solidFill>
-                  <a:srgbClr val="059669"/>
-                </a:solidFill>
-                <a:latin typeface="Calibri" pitchFamily="34" charset="0"/>
-                <a:ea typeface="Calibri" pitchFamily="34" charset="-122"/>
-                <a:cs typeface="Calibri" pitchFamily="34" charset="-120"/>
-              </a:rPr>
-              <a:t>Notify &amp; Close</a:t>
-            </a:r>
-            <a:endParaRPr lang="en-US" sz="1400" dirty="0"/>
-          </a:p>
-          <a:p>
-            <a:pPr marL="0" indent="0">
-              <a:lnSpc>
-                <a:spcPts val="1600"/>
-              </a:lnSpc>
-              <a:buNone/>
-            </a:pPr>
-            <a:r>
-              <a:rPr lang="en-US" sz="1250" dirty="0">
-                <a:solidFill>
-                  <a:srgbClr val="0F172A"/>
-                </a:solidFill>
-                <a:latin typeface="Calibri" pitchFamily="34" charset="0"/>
-                <a:ea typeface="Calibri" pitchFamily="34" charset="-122"/>
-                <a:cs typeface="Calibri" pitchFamily="34" charset="-120"/>
-              </a:rPr>
-              <a:t>Save, notify engineering, send CMR #</a:t>
-            </a:r>
-            <a:endParaRPr lang="en-US" sz="1400" dirty="0"/>
           </a:p>
         </p:txBody>
       </p:sp>
@@ -3674,7 +2515,7 @@
           <a:bodyPr/>
           <a:lstStyle/>
           <a:p>
-            <a:endParaRPr lang="en-US"/>
+            <a:endParaRPr lang="en-US" dirty="0"/>
           </a:p>
         </p:txBody>
       </p:sp>
@@ -3782,7 +2623,7 @@
           <a:bodyPr/>
           <a:lstStyle/>
           <a:p>
-            <a:endParaRPr lang="en-US"/>
+            <a:endParaRPr lang="en-US" dirty="0"/>
           </a:p>
         </p:txBody>
       </p:sp>
@@ -3809,7 +2650,7 @@
           <a:bodyPr/>
           <a:lstStyle/>
           <a:p>
-            <a:endParaRPr lang="en-US"/>
+            <a:endParaRPr lang="en-US" dirty="0"/>
           </a:p>
         </p:txBody>
       </p:sp>
@@ -3937,7 +2778,7 @@
           <a:bodyPr/>
           <a:lstStyle/>
           <a:p>
-            <a:endParaRPr lang="en-US"/>
+            <a:endParaRPr lang="en-US" dirty="0"/>
           </a:p>
         </p:txBody>
       </p:sp>
@@ -4065,7 +2906,7 @@
           <a:bodyPr/>
           <a:lstStyle/>
           <a:p>
-            <a:endParaRPr lang="en-US"/>
+            <a:endParaRPr lang="en-US" dirty="0"/>
           </a:p>
         </p:txBody>
       </p:sp>
@@ -4193,7 +3034,7 @@
           <a:bodyPr/>
           <a:lstStyle/>
           <a:p>
-            <a:endParaRPr lang="en-US"/>
+            <a:endParaRPr lang="en-US" dirty="0"/>
           </a:p>
         </p:txBody>
       </p:sp>
@@ -4321,7 +3162,7 @@
           <a:bodyPr/>
           <a:lstStyle/>
           <a:p>
-            <a:endParaRPr lang="en-US"/>
+            <a:endParaRPr lang="en-US" dirty="0"/>
           </a:p>
         </p:txBody>
       </p:sp>
@@ -4449,7 +3290,7 @@
           <a:bodyPr/>
           <a:lstStyle/>
           <a:p>
-            <a:endParaRPr lang="en-US"/>
+            <a:endParaRPr lang="en-US" dirty="0"/>
           </a:p>
         </p:txBody>
       </p:sp>
@@ -4577,7 +3418,7 @@
           <a:bodyPr/>
           <a:lstStyle/>
           <a:p>
-            <a:endParaRPr lang="en-US"/>
+            <a:endParaRPr lang="en-US" dirty="0"/>
           </a:p>
         </p:txBody>
       </p:sp>
@@ -4745,7 +3586,7 @@
           <a:bodyPr/>
           <a:lstStyle/>
           <a:p>
-            <a:endParaRPr lang="en-US"/>
+            <a:endParaRPr lang="en-US" dirty="0"/>
           </a:p>
         </p:txBody>
       </p:sp>
@@ -4859,7 +3700,7 @@
         </p:nvSpPr>
         <p:spPr>
           <a:xfrm>
-            <a:off x="457200" y="2148840"/>
+            <a:off x="457352" y="2139215"/>
             <a:ext cx="11277295" cy="4251960"/>
           </a:xfrm>
           <a:prstGeom prst="roundRect">
@@ -4888,7 +3729,7 @@
           <a:bodyPr/>
           <a:lstStyle/>
           <a:p>
-            <a:endParaRPr lang="en-US"/>
+            <a:endParaRPr lang="en-US" dirty="0"/>
           </a:p>
         </p:txBody>
       </p:sp>
@@ -4961,7 +3802,7 @@
           <a:bodyPr/>
           <a:lstStyle/>
           <a:p>
-            <a:endParaRPr lang="en-US"/>
+            <a:endParaRPr lang="en-US" dirty="0"/>
           </a:p>
         </p:txBody>
       </p:sp>
@@ -5021,7 +3862,7 @@
                 <a:ea typeface="Calibri" pitchFamily="34" charset="-122"/>
                 <a:cs typeface="Calibri" pitchFamily="34" charset="-120"/>
               </a:rPr>
-              <a:t>Carry over confirmed requirements from cmr-project</a:t>
+              <a:t>Work on confirmed requirements</a:t>
             </a:r>
             <a:endParaRPr lang="en-US" sz="1400" dirty="0"/>
           </a:p>
@@ -5096,7 +3937,7 @@
           <a:bodyPr/>
           <a:lstStyle/>
           <a:p>
-            <a:endParaRPr lang="en-US"/>
+            <a:endParaRPr lang="en-US" dirty="0"/>
           </a:p>
         </p:txBody>
       </p:sp>
@@ -5231,7 +4072,7 @@
           <a:bodyPr/>
           <a:lstStyle/>
           <a:p>
-            <a:endParaRPr lang="en-US"/>
+            <a:endParaRPr lang="en-US" dirty="0"/>
           </a:p>
         </p:txBody>
       </p:sp>
@@ -5366,7 +4207,7 @@
           <a:bodyPr/>
           <a:lstStyle/>
           <a:p>
-            <a:endParaRPr lang="en-US"/>
+            <a:endParaRPr lang="en-US" dirty="0"/>
           </a:p>
         </p:txBody>
       </p:sp>
@@ -5501,7 +4342,7 @@
           <a:bodyPr/>
           <a:lstStyle/>
           <a:p>
-            <a:endParaRPr lang="en-US"/>
+            <a:endParaRPr lang="en-US" dirty="0"/>
           </a:p>
         </p:txBody>
       </p:sp>
@@ -5576,6 +4417,496 @@
 </file>
 
 <file path=ppt/slides/slide4.xml><?xml version="1.0" encoding="utf-8"?>
+<p:sld xmlns:a="http://schemas.openxmlformats.org/drawingml/2006/main" xmlns:r="http://schemas.openxmlformats.org/officeDocument/2006/relationships" xmlns:p="http://schemas.openxmlformats.org/presentationml/2006/main">
+  <p:cSld name="Slide 5">
+    <p:bg>
+      <p:bgPr>
+        <a:solidFill>
+          <a:srgbClr val="F8FAFC"/>
+        </a:solidFill>
+        <a:effectLst/>
+      </p:bgPr>
+    </p:bg>
+    <p:spTree>
+      <p:nvGrpSpPr>
+        <p:cNvPr id="1" name=""/>
+        <p:cNvGrpSpPr/>
+        <p:nvPr/>
+      </p:nvGrpSpPr>
+      <p:grpSpPr>
+        <a:xfrm>
+          <a:off x="0" y="0"/>
+          <a:ext cx="0" cy="0"/>
+          <a:chOff x="0" y="0"/>
+          <a:chExt cx="0" cy="0"/>
+        </a:xfrm>
+      </p:grpSpPr>
+      <p:sp>
+        <p:nvSpPr>
+          <p:cNvPr id="2" name="Shape 0"/>
+          <p:cNvSpPr/>
+          <p:nvPr/>
+        </p:nvSpPr>
+        <p:spPr>
+          <a:xfrm>
+            <a:off x="457200" y="502920"/>
+            <a:ext cx="1371600" cy="1371600"/>
+          </a:xfrm>
+          <a:prstGeom prst="roundRect">
+            <a:avLst>
+              <a:gd name="adj" fmla="val 8000"/>
+            </a:avLst>
+          </a:prstGeom>
+          <a:solidFill>
+            <a:srgbClr val="ECFDF5"/>
+          </a:solidFill>
+          <a:ln w="12700">
+            <a:solidFill>
+              <a:srgbClr val="E2E8F0"/>
+            </a:solidFill>
+            <a:prstDash val="solid"/>
+          </a:ln>
+        </p:spPr>
+        <p:txBody>
+          <a:bodyPr/>
+          <a:lstStyle/>
+          <a:p>
+            <a:endParaRPr lang="en-US" dirty="0"/>
+          </a:p>
+        </p:txBody>
+      </p:sp>
+      <p:pic>
+        <p:nvPicPr>
+          <p:cNvPr id="3" name="Image 0" descr="icons/tag.png"/>
+          <p:cNvPicPr>
+            <a:picLocks noChangeAspect="1"/>
+          </p:cNvPicPr>
+          <p:nvPr/>
+        </p:nvPicPr>
+        <p:blipFill>
+          <a:blip r:embed="rId2"/>
+          <a:stretch>
+            <a:fillRect/>
+          </a:stretch>
+        </p:blipFill>
+        <p:spPr>
+          <a:xfrm>
+            <a:off x="800100" y="845820"/>
+            <a:ext cx="685800" cy="685800"/>
+          </a:xfrm>
+          <a:prstGeom prst="rect">
+            <a:avLst/>
+          </a:prstGeom>
+        </p:spPr>
+      </p:pic>
+      <p:sp>
+        <p:nvSpPr>
+          <p:cNvPr id="4" name="Text 1"/>
+          <p:cNvSpPr/>
+          <p:nvPr/>
+        </p:nvSpPr>
+        <p:spPr>
+          <a:xfrm>
+            <a:off x="2194560" y="502920"/>
+            <a:ext cx="9539935" cy="685800"/>
+          </a:xfrm>
+          <a:prstGeom prst="rect">
+            <a:avLst/>
+          </a:prstGeom>
+          <a:noFill/>
+          <a:ln/>
+        </p:spPr>
+        <p:txBody>
+          <a:bodyPr wrap="square" lIns="0" tIns="0" rIns="0" bIns="0" rtlCol="0" anchor="t"/>
+          <a:lstStyle/>
+          <a:p>
+            <a:pPr marL="0" indent="0" algn="l">
+              <a:buNone/>
+            </a:pPr>
+            <a:r>
+              <a:rPr lang="en-US" sz="3400" b="1" dirty="0">
+                <a:solidFill>
+                  <a:srgbClr val="0F172A"/>
+                </a:solidFill>
+                <a:latin typeface="Cambria" pitchFamily="34" charset="0"/>
+                <a:ea typeface="Cambria" pitchFamily="34" charset="-122"/>
+                <a:cs typeface="Cambria" pitchFamily="34" charset="-120"/>
+              </a:rPr>
+              <a:t>The current CMR process</a:t>
+            </a:r>
+            <a:endParaRPr lang="en-US" sz="3400" dirty="0"/>
+          </a:p>
+        </p:txBody>
+      </p:sp>
+      <p:sp>
+        <p:nvSpPr>
+          <p:cNvPr id="5" name="Text 2"/>
+          <p:cNvSpPr/>
+          <p:nvPr/>
+        </p:nvSpPr>
+        <p:spPr>
+          <a:xfrm>
+            <a:off x="2194560" y="1216152"/>
+            <a:ext cx="9539935" cy="640080"/>
+          </a:xfrm>
+          <a:prstGeom prst="rect">
+            <a:avLst/>
+          </a:prstGeom>
+          <a:noFill/>
+          <a:ln/>
+        </p:spPr>
+        <p:txBody>
+          <a:bodyPr wrap="square" lIns="0" tIns="0" rIns="0" bIns="0" rtlCol="0" anchor="t"/>
+          <a:lstStyle/>
+          <a:p>
+            <a:pPr marL="0" indent="0" algn="l">
+              <a:buNone/>
+            </a:pPr>
+            <a:r>
+              <a:rPr lang="en-US" sz="1600" dirty="0">
+                <a:solidFill>
+                  <a:srgbClr val="64748B"/>
+                </a:solidFill>
+                <a:latin typeface="Calibri" pitchFamily="34" charset="0"/>
+                <a:ea typeface="Calibri" pitchFamily="34" charset="-122"/>
+                <a:cs typeface="Calibri" pitchFamily="34" charset="-120"/>
+              </a:rPr>
+              <a:t>Create Change Request → Change Request Management → CMR — the three-form workflow today.</a:t>
+            </a:r>
+            <a:endParaRPr lang="en-US" sz="1600" dirty="0"/>
+          </a:p>
+        </p:txBody>
+      </p:sp>
+      <p:sp>
+        <p:nvSpPr>
+          <p:cNvPr id="6" name="Shape 3"/>
+          <p:cNvSpPr/>
+          <p:nvPr/>
+        </p:nvSpPr>
+        <p:spPr>
+          <a:xfrm>
+            <a:off x="360946" y="2418347"/>
+            <a:ext cx="7050507" cy="3982453"/>
+          </a:xfrm>
+          <a:prstGeom prst="roundRect">
+            <a:avLst>
+              <a:gd name="adj" fmla="val 2581"/>
+            </a:avLst>
+          </a:prstGeom>
+          <a:solidFill>
+            <a:srgbClr val="FFFFFF"/>
+          </a:solidFill>
+          <a:ln w="12700">
+            <a:solidFill>
+              <a:srgbClr val="E2E8F0"/>
+            </a:solidFill>
+            <a:prstDash val="solid"/>
+          </a:ln>
+          <a:effectLst>
+            <a:outerShdw blurRad="152400" dist="38100" dir="5400000" algn="bl" rotWithShape="0">
+              <a:srgbClr val="1E293B">
+                <a:alpha val="8000"/>
+              </a:srgbClr>
+            </a:outerShdw>
+          </a:effectLst>
+        </p:spPr>
+        <p:txBody>
+          <a:bodyPr/>
+          <a:lstStyle/>
+          <a:p>
+            <a:endParaRPr lang="en-US" dirty="0"/>
+          </a:p>
+        </p:txBody>
+      </p:sp>
+      <p:sp>
+        <p:nvSpPr>
+          <p:cNvPr id="7" name="Text 4"/>
+          <p:cNvSpPr/>
+          <p:nvPr/>
+        </p:nvSpPr>
+        <p:spPr>
+          <a:xfrm>
+            <a:off x="457200" y="2071548"/>
+            <a:ext cx="9144000" cy="365760"/>
+          </a:xfrm>
+          <a:prstGeom prst="rect">
+            <a:avLst/>
+          </a:prstGeom>
+          <a:noFill/>
+          <a:ln/>
+        </p:spPr>
+        <p:txBody>
+          <a:bodyPr wrap="square" lIns="0" tIns="0" rIns="0" bIns="0" rtlCol="0" anchor="t"/>
+          <a:lstStyle/>
+          <a:p>
+            <a:pPr marL="0" indent="0" algn="l">
+              <a:buNone/>
+            </a:pPr>
+            <a:r>
+              <a:rPr lang="en-US" sz="1500" b="1" dirty="0">
+                <a:solidFill>
+                  <a:srgbClr val="059669"/>
+                </a:solidFill>
+                <a:latin typeface="Calibri" pitchFamily="34" charset="0"/>
+                <a:ea typeface="Calibri" pitchFamily="34" charset="-122"/>
+                <a:cs typeface="Calibri" pitchFamily="34" charset="-120"/>
+              </a:rPr>
+              <a:t>Actual current process</a:t>
+            </a:r>
+            <a:endParaRPr lang="en-US" sz="1500" dirty="0"/>
+          </a:p>
+        </p:txBody>
+      </p:sp>
+      <p:sp>
+        <p:nvSpPr>
+          <p:cNvPr id="8" name="Text 5"/>
+          <p:cNvSpPr/>
+          <p:nvPr/>
+        </p:nvSpPr>
+        <p:spPr>
+          <a:xfrm>
+            <a:off x="457199" y="2743200"/>
+            <a:ext cx="6725653" cy="3526080"/>
+          </a:xfrm>
+          <a:prstGeom prst="rect">
+            <a:avLst/>
+          </a:prstGeom>
+          <a:noFill/>
+          <a:ln/>
+        </p:spPr>
+        <p:txBody>
+          <a:bodyPr wrap="square" lIns="0" tIns="0" rIns="0" bIns="0" rtlCol="0" anchor="t"/>
+          <a:lstStyle/>
+          <a:p>
+            <a:pPr marL="228600" indent="-228600">
+              <a:spcAft>
+                <a:spcPts val="1400"/>
+              </a:spcAft>
+              <a:buSzPct val="100000"/>
+              <a:buChar char="■"/>
+            </a:pPr>
+            <a:r>
+              <a:rPr lang="en-US" sz="1500" dirty="0">
+                <a:solidFill>
+                  <a:srgbClr val="0F172A"/>
+                </a:solidFill>
+                <a:latin typeface="Calibri" pitchFamily="34" charset="0"/>
+                <a:ea typeface="Calibri" pitchFamily="34" charset="-122"/>
+                <a:cs typeface="Calibri" pitchFamily="34" charset="-120"/>
+              </a:rPr>
+              <a:t>Production emails a PIR (Job, Serial #, Top Level PN, Sub Assembly PN, Part, Issue); </a:t>
+            </a:r>
+          </a:p>
+          <a:p>
+            <a:pPr marL="228600" indent="-228600">
+              <a:spcAft>
+                <a:spcPts val="1400"/>
+              </a:spcAft>
+              <a:buSzPct val="100000"/>
+              <a:buChar char="■"/>
+            </a:pPr>
+            <a:r>
+              <a:rPr lang="en-US" sz="1500" b="1" dirty="0">
+                <a:solidFill>
+                  <a:srgbClr val="0F172A"/>
+                </a:solidFill>
+                <a:latin typeface="Calibri" pitchFamily="34" charset="0"/>
+                <a:ea typeface="Calibri" pitchFamily="34" charset="-122"/>
+                <a:cs typeface="Calibri" pitchFamily="34" charset="-120"/>
+              </a:rPr>
+              <a:t>Create Change Request</a:t>
+            </a:r>
+            <a:r>
+              <a:rPr lang="en-US" sz="1500" dirty="0">
+                <a:solidFill>
+                  <a:srgbClr val="0F172A"/>
+                </a:solidFill>
+                <a:latin typeface="Calibri" pitchFamily="34" charset="0"/>
+                <a:ea typeface="Calibri" pitchFamily="34" charset="-122"/>
+                <a:cs typeface="Calibri" pitchFamily="34" charset="-120"/>
+              </a:rPr>
+              <a:t>: Priority, Initial Change, Requested By.</a:t>
+            </a:r>
+            <a:endParaRPr lang="en-US" sz="1500" dirty="0"/>
+          </a:p>
+          <a:p>
+            <a:pPr marL="228600" indent="-228600">
+              <a:spcAft>
+                <a:spcPts val="1400"/>
+              </a:spcAft>
+              <a:buSzPct val="100000"/>
+              <a:buChar char="■"/>
+            </a:pPr>
+            <a:r>
+              <a:rPr lang="en-US" sz="1500" b="1" dirty="0">
+                <a:solidFill>
+                  <a:srgbClr val="0F172A"/>
+                </a:solidFill>
+                <a:latin typeface="Calibri" pitchFamily="34" charset="0"/>
+                <a:ea typeface="Calibri" pitchFamily="34" charset="-122"/>
+                <a:cs typeface="Calibri" pitchFamily="34" charset="-120"/>
+              </a:rPr>
+              <a:t>Change Request Management</a:t>
+            </a:r>
+            <a:r>
+              <a:rPr lang="en-US" sz="1500" dirty="0">
+                <a:solidFill>
+                  <a:srgbClr val="0F172A"/>
+                </a:solidFill>
+                <a:latin typeface="Calibri" pitchFamily="34" charset="0"/>
+                <a:ea typeface="Calibri" pitchFamily="34" charset="-122"/>
+                <a:cs typeface="Calibri" pitchFamily="34" charset="-120"/>
+              </a:rPr>
+              <a:t>: everything’s already filled in – they just capture the CMR Number it generated.</a:t>
+            </a:r>
+            <a:endParaRPr lang="en-US" sz="1500" dirty="0"/>
+          </a:p>
+          <a:p>
+            <a:pPr marL="228600" indent="-228600">
+              <a:spcAft>
+                <a:spcPts val="1400"/>
+              </a:spcAft>
+              <a:buSzPct val="100000"/>
+              <a:buChar char="■"/>
+            </a:pPr>
+            <a:r>
+              <a:rPr lang="en-US" sz="1500" b="1" dirty="0">
+                <a:solidFill>
+                  <a:srgbClr val="0F172A"/>
+                </a:solidFill>
+                <a:latin typeface="Calibri" pitchFamily="34" charset="0"/>
+                <a:ea typeface="Calibri" pitchFamily="34" charset="-122"/>
+                <a:cs typeface="Calibri" pitchFamily="34" charset="-120"/>
+              </a:rPr>
+              <a:t>CMR Form</a:t>
+            </a:r>
+            <a:r>
+              <a:rPr lang="en-US" sz="1500" dirty="0">
+                <a:solidFill>
+                  <a:srgbClr val="0F172A"/>
+                </a:solidFill>
+                <a:latin typeface="Calibri" pitchFamily="34" charset="0"/>
+                <a:ea typeface="Calibri" pitchFamily="34" charset="-122"/>
+                <a:cs typeface="Calibri" pitchFamily="34" charset="-120"/>
+              </a:rPr>
+              <a:t>: assign engineering, pull Item/Revision from the drawing books, Disposition starts </a:t>
+            </a:r>
+            <a:r>
+              <a:rPr lang="en-US" sz="1500" b="1" dirty="0">
+                <a:solidFill>
+                  <a:srgbClr val="0F172A"/>
+                </a:solidFill>
+                <a:latin typeface="Calibri" pitchFamily="34" charset="0"/>
+                <a:ea typeface="Calibri" pitchFamily="34" charset="-122"/>
+                <a:cs typeface="Calibri" pitchFamily="34" charset="-120"/>
+              </a:rPr>
+              <a:t>On Hold</a:t>
+            </a:r>
+            <a:r>
+              <a:rPr lang="en-US" sz="1500" dirty="0">
+                <a:solidFill>
+                  <a:srgbClr val="0F172A"/>
+                </a:solidFill>
+                <a:latin typeface="Calibri" pitchFamily="34" charset="0"/>
+                <a:ea typeface="Calibri" pitchFamily="34" charset="-122"/>
+                <a:cs typeface="Calibri" pitchFamily="34" charset="-120"/>
+              </a:rPr>
+              <a:t>, RCA notes copied from the intake email (Serial #/LOT # currently get copied into the Notes here too).</a:t>
+            </a:r>
+            <a:endParaRPr lang="en-US" sz="1500" dirty="0"/>
+          </a:p>
+          <a:p>
+            <a:pPr marL="228600" indent="-228600">
+              <a:spcAft>
+                <a:spcPts val="1400"/>
+              </a:spcAft>
+              <a:buSzPct val="100000"/>
+              <a:buChar char="■"/>
+            </a:pPr>
+            <a:r>
+              <a:rPr lang="en-US" sz="1500" dirty="0">
+                <a:solidFill>
+                  <a:srgbClr val="0F172A"/>
+                </a:solidFill>
+                <a:latin typeface="Calibri" pitchFamily="34" charset="0"/>
+                <a:ea typeface="Calibri" pitchFamily="34" charset="-122"/>
+                <a:cs typeface="Calibri" pitchFamily="34" charset="-120"/>
+              </a:rPr>
+              <a:t>Save, notify engineering (follow up after 24 hrs), then send the CMR Number back to the requester.</a:t>
+            </a:r>
+            <a:endParaRPr lang="en-US" sz="1500" dirty="0"/>
+          </a:p>
+        </p:txBody>
+      </p:sp>
+      <p:pic>
+        <p:nvPicPr>
+          <p:cNvPr id="10" name="Picture 9">
+            <a:extLst>
+              <a:ext uri="{FF2B5EF4-FFF2-40B4-BE49-F238E27FC236}">
+                <a16:creationId xmlns:a16="http://schemas.microsoft.com/office/drawing/2014/main" id="{8CE6A3AA-1751-7994-8D3D-EA16944CF7AD}"/>
+              </a:ext>
+            </a:extLst>
+          </p:cNvPr>
+          <p:cNvPicPr>
+            <a:picLocks noChangeAspect="1"/>
+          </p:cNvPicPr>
+          <p:nvPr/>
+        </p:nvPicPr>
+        <p:blipFill>
+          <a:blip r:embed="rId3"/>
+          <a:stretch>
+            <a:fillRect/>
+          </a:stretch>
+        </p:blipFill>
+        <p:spPr>
+          <a:xfrm>
+            <a:off x="6964527" y="1640425"/>
+            <a:ext cx="5473569" cy="2905367"/>
+          </a:xfrm>
+          <a:prstGeom prst="rect">
+            <a:avLst/>
+          </a:prstGeom>
+        </p:spPr>
+      </p:pic>
+      <p:pic>
+        <p:nvPicPr>
+          <p:cNvPr id="20" name="Picture 19">
+            <a:extLst>
+              <a:ext uri="{FF2B5EF4-FFF2-40B4-BE49-F238E27FC236}">
+                <a16:creationId xmlns:a16="http://schemas.microsoft.com/office/drawing/2014/main" id="{A38A9BE8-2779-A6A5-799C-3F5EA44B6E40}"/>
+              </a:ext>
+            </a:extLst>
+          </p:cNvPr>
+          <p:cNvPicPr>
+            <a:picLocks noChangeAspect="1"/>
+          </p:cNvPicPr>
+          <p:nvPr/>
+        </p:nvPicPr>
+        <p:blipFill>
+          <a:blip r:embed="rId4"/>
+          <a:stretch>
+            <a:fillRect/>
+          </a:stretch>
+        </p:blipFill>
+        <p:spPr>
+          <a:xfrm>
+            <a:off x="8703026" y="2869241"/>
+            <a:ext cx="3683195" cy="3756761"/>
+          </a:xfrm>
+          <a:prstGeom prst="rect">
+            <a:avLst/>
+          </a:prstGeom>
+        </p:spPr>
+      </p:pic>
+    </p:spTree>
+  </p:cSld>
+  <p:clrMapOvr>
+    <a:masterClrMapping/>
+  </p:clrMapOvr>
+</p:sld>
+</file>
+
+<file path=ppt/slides/slide5.xml><?xml version="1.0" encoding="utf-8"?>
 <p:sld xmlns:a="http://schemas.openxmlformats.org/drawingml/2006/main" xmlns:r="http://schemas.openxmlformats.org/officeDocument/2006/relationships" xmlns:p="http://schemas.openxmlformats.org/presentationml/2006/main">
   <p:cSld name="Slide 4">
     <p:bg>
@@ -5708,7 +5039,7 @@
           <a:bodyPr/>
           <a:lstStyle/>
           <a:p>
-            <a:endParaRPr lang="en-US"/>
+            <a:endParaRPr lang="en-US" dirty="0"/>
           </a:p>
         </p:txBody>
       </p:sp>
@@ -5773,7 +5104,7 @@
           <a:bodyPr/>
           <a:lstStyle/>
           <a:p>
-            <a:endParaRPr lang="en-US"/>
+            <a:endParaRPr lang="en-US" dirty="0"/>
           </a:p>
         </p:txBody>
       </p:sp>
@@ -5920,7 +5251,7 @@
           <a:bodyPr/>
           <a:lstStyle/>
           <a:p>
-            <a:endParaRPr lang="en-US"/>
+            <a:endParaRPr lang="en-US" dirty="0"/>
           </a:p>
         </p:txBody>
       </p:sp>
@@ -5947,7 +5278,7 @@
           <a:bodyPr/>
           <a:lstStyle/>
           <a:p>
-            <a:endParaRPr lang="en-US"/>
+            <a:endParaRPr lang="en-US" dirty="0"/>
           </a:p>
         </p:txBody>
       </p:sp>
@@ -6023,7 +5354,7 @@
                 <a:ea typeface="Calibri" pitchFamily="34" charset="-122"/>
                 <a:cs typeface="Calibri" pitchFamily="34" charset="-120"/>
               </a:rPr>
-              <a:t>The key field — auto-number set in the IDO properties, increments every CMR automatically</a:t>
+              <a:t>The key field - auto-number set in the IDO properties, increments every CMR automatically</a:t>
             </a:r>
             <a:endParaRPr lang="en-US" sz="1300" dirty="0"/>
           </a:p>
@@ -6055,7 +5386,7 @@
           <a:bodyPr/>
           <a:lstStyle/>
           <a:p>
-            <a:endParaRPr lang="en-US"/>
+            <a:endParaRPr lang="en-US" dirty="0"/>
           </a:p>
         </p:txBody>
       </p:sp>
@@ -6163,7 +5494,7 @@
           <a:bodyPr/>
           <a:lstStyle/>
           <a:p>
-            <a:endParaRPr lang="en-US"/>
+            <a:endParaRPr lang="en-US" dirty="0"/>
           </a:p>
         </p:txBody>
       </p:sp>
@@ -6271,7 +5602,7 @@
           <a:bodyPr/>
           <a:lstStyle/>
           <a:p>
-            <a:endParaRPr lang="en-US"/>
+            <a:endParaRPr lang="en-US" dirty="0"/>
           </a:p>
         </p:txBody>
       </p:sp>
@@ -6379,7 +5710,7 @@
           <a:bodyPr/>
           <a:lstStyle/>
           <a:p>
-            <a:endParaRPr lang="en-US"/>
+            <a:endParaRPr lang="en-US" dirty="0"/>
           </a:p>
         </p:txBody>
       </p:sp>
@@ -6487,7 +5818,7 @@
           <a:bodyPr/>
           <a:lstStyle/>
           <a:p>
-            <a:endParaRPr lang="en-US"/>
+            <a:endParaRPr lang="en-US" dirty="0"/>
           </a:p>
         </p:txBody>
       </p:sp>
@@ -6595,7 +5926,7 @@
           <a:bodyPr/>
           <a:lstStyle/>
           <a:p>
-            <a:endParaRPr lang="en-US"/>
+            <a:endParaRPr lang="en-US" dirty="0"/>
           </a:p>
         </p:txBody>
       </p:sp>
@@ -6607,7 +5938,7 @@
 </p:sld>
 </file>
 
-<file path=ppt/slides/slide5.xml><?xml version="1.0" encoding="utf-8"?>
+<file path=ppt/slides/slide6.xml><?xml version="1.0" encoding="utf-8"?>
 <p:sld xmlns:a="http://schemas.openxmlformats.org/drawingml/2006/main" xmlns:r="http://schemas.openxmlformats.org/officeDocument/2006/relationships" xmlns:p="http://schemas.openxmlformats.org/presentationml/2006/main">
   <p:cSld name="Slide 5">
     <p:bg>
@@ -6662,7 +5993,7 @@
           <a:bodyPr/>
           <a:lstStyle/>
           <a:p>
-            <a:endParaRPr lang="en-US"/>
+            <a:endParaRPr lang="en-US" dirty="0"/>
           </a:p>
         </p:txBody>
       </p:sp>
@@ -6805,7 +6136,7 @@
           <a:bodyPr/>
           <a:lstStyle/>
           <a:p>
-            <a:endParaRPr lang="en-US"/>
+            <a:endParaRPr lang="en-US" dirty="0"/>
           </a:p>
         </p:txBody>
       </p:sp>
@@ -6925,7 +6256,7 @@
               <a:t>Build the </a:t>
             </a:r>
             <a:r>
-              <a:rPr lang="en-US" sz="1500" b="1" dirty="0" err="1">
+              <a:rPr lang="en-US" sz="1500" b="1" dirty="0">
                 <a:solidFill>
                   <a:srgbClr val="0F172A"/>
                 </a:solidFill>
@@ -7041,7 +6372,6 @@
               </a:rPr>
               <a:t>Import the form XML through Form Sync</a:t>
             </a:r>
-            <a:endParaRPr lang="en-US" sz="1500" dirty="0"/>
           </a:p>
         </p:txBody>
       </p:sp>
@@ -7053,7 +6383,7 @@
 </p:sld>
 </file>
 
-<file path=ppt/slides/slide6.xml><?xml version="1.0" encoding="utf-8"?>
+<file path=ppt/slides/slide7.xml><?xml version="1.0" encoding="utf-8"?>
 <p:sld xmlns:a="http://schemas.openxmlformats.org/drawingml/2006/main" xmlns:r="http://schemas.openxmlformats.org/officeDocument/2006/relationships" xmlns:p="http://schemas.openxmlformats.org/presentationml/2006/main">
   <p:cSld name="Slide 6">
     <p:bg>
@@ -7186,7 +6516,7 @@
           <a:bodyPr/>
           <a:lstStyle/>
           <a:p>
-            <a:endParaRPr lang="en-US"/>
+            <a:endParaRPr lang="en-US" dirty="0"/>
           </a:p>
         </p:txBody>
       </p:sp>
@@ -7222,7 +6552,7 @@
         </p:nvSpPr>
         <p:spPr>
           <a:xfrm>
-            <a:off x="457200" y="2148840"/>
+            <a:off x="501379" y="2200317"/>
             <a:ext cx="11277295" cy="4251960"/>
           </a:xfrm>
           <a:prstGeom prst="roundRect">
@@ -7251,7 +6581,7 @@
           <a:bodyPr/>
           <a:lstStyle/>
           <a:p>
-            <a:endParaRPr lang="en-US"/>
+            <a:endParaRPr lang="en-US" dirty="0"/>
           </a:p>
         </p:txBody>
       </p:sp>
@@ -7601,6 +6931,95 @@
                 <a:cs typeface="Calibri" pitchFamily="34" charset="-120"/>
               </a:rPr>
               <a:t>Run the full TRN test checklist before go-live: create path, persistence round-trip, Requirements checkbox cascade</a:t>
+            </a:r>
+          </a:p>
+        </p:txBody>
+      </p:sp>
+      <p:sp>
+        <p:nvSpPr>
+          <p:cNvPr id="19" name="Text 11">
+            <a:extLst>
+              <a:ext uri="{FF2B5EF4-FFF2-40B4-BE49-F238E27FC236}">
+                <a16:creationId xmlns:a16="http://schemas.microsoft.com/office/drawing/2014/main" id="{E87F5528-7C19-A626-5DA9-34357D16047F}"/>
+              </a:ext>
+            </a:extLst>
+          </p:cNvPr>
+          <p:cNvSpPr/>
+          <p:nvPr/>
+        </p:nvSpPr>
+        <p:spPr>
+          <a:xfrm>
+            <a:off x="822960" y="5559552"/>
+            <a:ext cx="365760" cy="594360"/>
+          </a:xfrm>
+          <a:prstGeom prst="rect">
+            <a:avLst/>
+          </a:prstGeom>
+          <a:noFill/>
+          <a:ln/>
+        </p:spPr>
+        <p:txBody>
+          <a:bodyPr wrap="square" lIns="0" tIns="0" rIns="0" bIns="0" rtlCol="0" anchor="t"/>
+          <a:lstStyle/>
+          <a:p>
+            <a:pPr marL="0" indent="0" algn="l">
+              <a:buNone/>
+            </a:pPr>
+            <a:r>
+              <a:rPr lang="en-US" sz="1500" b="1" dirty="0">
+                <a:solidFill>
+                  <a:srgbClr val="059669"/>
+                </a:solidFill>
+                <a:latin typeface="Calibri" pitchFamily="34" charset="0"/>
+                <a:ea typeface="Calibri" pitchFamily="34" charset="-122"/>
+                <a:cs typeface="Calibri" pitchFamily="34" charset="-120"/>
+              </a:rPr>
+              <a:t>5</a:t>
+            </a:r>
+            <a:endParaRPr lang="en-US" sz="1500" dirty="0"/>
+          </a:p>
+        </p:txBody>
+      </p:sp>
+      <p:sp>
+        <p:nvSpPr>
+          <p:cNvPr id="23" name="Text 12">
+            <a:extLst>
+              <a:ext uri="{FF2B5EF4-FFF2-40B4-BE49-F238E27FC236}">
+                <a16:creationId xmlns:a16="http://schemas.microsoft.com/office/drawing/2014/main" id="{9247ABB6-B95A-4F45-624C-0F3FAF63C6A8}"/>
+              </a:ext>
+            </a:extLst>
+          </p:cNvPr>
+          <p:cNvSpPr/>
+          <p:nvPr/>
+        </p:nvSpPr>
+        <p:spPr>
+          <a:xfrm>
+            <a:off x="1188720" y="5542449"/>
+            <a:ext cx="10134295" cy="594360"/>
+          </a:xfrm>
+          <a:prstGeom prst="rect">
+            <a:avLst/>
+          </a:prstGeom>
+          <a:noFill/>
+          <a:ln/>
+        </p:spPr>
+        <p:txBody>
+          <a:bodyPr wrap="square" lIns="0" tIns="0" rIns="0" bIns="0" rtlCol="0" anchor="t"/>
+          <a:lstStyle/>
+          <a:p>
+            <a:pPr marL="0" indent="0" algn="l">
+              <a:buNone/>
+            </a:pPr>
+            <a:r>
+              <a:rPr lang="en-US" sz="1500" dirty="0">
+                <a:solidFill>
+                  <a:srgbClr val="0F172A"/>
+                </a:solidFill>
+                <a:latin typeface="Calibri" pitchFamily="34" charset="0"/>
+                <a:ea typeface="Calibri" pitchFamily="34" charset="-122"/>
+                <a:cs typeface="Calibri" pitchFamily="34" charset="-120"/>
+              </a:rPr>
+              <a:t>Work on procedure documentation changes</a:t>
             </a:r>
           </a:p>
         </p:txBody>
@@ -7613,7 +7032,7 @@
 </p:sld>
 </file>
 
-<file path=ppt/slides/slide7.xml><?xml version="1.0" encoding="utf-8"?>
+<file path=ppt/slides/slide8.xml><?xml version="1.0" encoding="utf-8"?>
 <p:sld xmlns:a="http://schemas.openxmlformats.org/drawingml/2006/main" xmlns:r="http://schemas.openxmlformats.org/officeDocument/2006/relationships" xmlns:p="http://schemas.openxmlformats.org/presentationml/2006/main">
   <p:cSld name="Slide 8">
     <p:bg>
@@ -7661,7 +7080,7 @@
           <a:bodyPr/>
           <a:lstStyle/>
           <a:p>
-            <a:endParaRPr lang="en-US"/>
+            <a:endParaRPr lang="en-US" dirty="0"/>
           </a:p>
         </p:txBody>
       </p:sp>
@@ -7780,7 +7199,7 @@
           <a:bodyPr/>
           <a:lstStyle/>
           <a:p>
-            <a:endParaRPr lang="en-US"/>
+            <a:endParaRPr lang="en-US" dirty="0"/>
           </a:p>
         </p:txBody>
       </p:sp>
@@ -7946,7 +7365,7 @@
           <a:bodyPr/>
           <a:lstStyle/>
           <a:p>
-            <a:endParaRPr lang="en-US"/>
+            <a:endParaRPr lang="en-US" dirty="0"/>
           </a:p>
         </p:txBody>
       </p:sp>
@@ -8353,7 +7772,7 @@
 </p:sld>
 </file>
 
-<file path=ppt/slides/slide8.xml><?xml version="1.0" encoding="utf-8"?>
+<file path=ppt/slides/slide9.xml><?xml version="1.0" encoding="utf-8"?>
 <p:sld xmlns:a="http://schemas.openxmlformats.org/drawingml/2006/main" xmlns:r="http://schemas.openxmlformats.org/officeDocument/2006/relationships" xmlns:p="http://schemas.openxmlformats.org/presentationml/2006/main">
   <p:cSld name="Slide 7">
     <p:bg>
@@ -8408,7 +7827,7 @@
           <a:bodyPr/>
           <a:lstStyle/>
           <a:p>
-            <a:endParaRPr lang="en-US"/>
+            <a:endParaRPr lang="en-US" dirty="0"/>
           </a:p>
         </p:txBody>
       </p:sp>
@@ -8551,7 +7970,7 @@
           <a:bodyPr/>
           <a:lstStyle/>
           <a:p>
-            <a:endParaRPr lang="en-US"/>
+            <a:endParaRPr lang="en-US" dirty="0"/>
           </a:p>
         </p:txBody>
       </p:sp>
@@ -8666,51 +8085,7 @@
                 <a:ea typeface="Calibri" pitchFamily="34" charset="-122"/>
                 <a:cs typeface="Calibri" pitchFamily="34" charset="-120"/>
               </a:rPr>
-              <a:t>eCMRs replaces </a:t>
-            </a:r>
-            <a:r>
-              <a:rPr lang="en-US" sz="1500" dirty="0" err="1">
-                <a:solidFill>
-                  <a:srgbClr val="0F172A"/>
-                </a:solidFill>
-                <a:latin typeface="Calibri" pitchFamily="34" charset="0"/>
-                <a:ea typeface="Calibri" pitchFamily="34" charset="-122"/>
-                <a:cs typeface="Calibri" pitchFamily="34" charset="-120"/>
-              </a:rPr>
-              <a:t>cmrs</a:t>
-            </a:r>
-            <a:r>
-              <a:rPr lang="en-US" sz="1500" dirty="0">
-                <a:solidFill>
-                  <a:srgbClr val="0F172A"/>
-                </a:solidFill>
-                <a:latin typeface="Calibri" pitchFamily="34" charset="0"/>
-                <a:ea typeface="Calibri" pitchFamily="34" charset="-122"/>
-                <a:cs typeface="Calibri" pitchFamily="34" charset="-120"/>
-              </a:rPr>
-              <a:t> form, create change request and change request management forms, it runs alongside it until the </a:t>
-            </a:r>
-            <a:r>
-              <a:rPr lang="en-US" sz="1500" dirty="0" err="1">
-                <a:solidFill>
-                  <a:srgbClr val="0F172A"/>
-                </a:solidFill>
-                <a:latin typeface="Calibri" pitchFamily="34" charset="0"/>
-                <a:ea typeface="Calibri" pitchFamily="34" charset="-122"/>
-                <a:cs typeface="Calibri" pitchFamily="34" charset="-120"/>
-              </a:rPr>
-              <a:t>cmrproject</a:t>
-            </a:r>
-            <a:r>
-              <a:rPr lang="en-US" sz="1500" dirty="0">
-                <a:solidFill>
-                  <a:srgbClr val="0F172A"/>
-                </a:solidFill>
-                <a:latin typeface="Calibri" pitchFamily="34" charset="0"/>
-                <a:ea typeface="Calibri" pitchFamily="34" charset="-122"/>
-                <a:cs typeface="Calibri" pitchFamily="34" charset="-120"/>
-              </a:rPr>
-              <a:t> is retired once eCMRs is proven</a:t>
+              <a:t>eCMRs replaces CMR form, create change request and change request management forms, it runs alongside it until the CMR form is retired once eCMRs is proven</a:t>
             </a:r>
             <a:endParaRPr lang="en-US" sz="1500" dirty="0"/>
           </a:p>
@@ -8867,382 +8242,6 @@
                 <a:cs typeface="Calibri" pitchFamily="34" charset="-120"/>
               </a:rPr>
               <a:t>Retire Create Change Request, Change Request Management, and CMRs once live</a:t>
-            </a:r>
-            <a:endParaRPr lang="en-US" sz="1500" dirty="0"/>
-          </a:p>
-        </p:txBody>
-      </p:sp>
-    </p:spTree>
-  </p:cSld>
-  <p:clrMapOvr>
-    <a:masterClrMapping/>
-  </p:clrMapOvr>
-</p:sld>
-</file>
-
-<file path=ppt/slides/slide9.xml><?xml version="1.0" encoding="utf-8"?>
-<p:sld xmlns:a="http://schemas.openxmlformats.org/drawingml/2006/main" xmlns:r="http://schemas.openxmlformats.org/officeDocument/2006/relationships" xmlns:p="http://schemas.openxmlformats.org/presentationml/2006/main">
-  <p:cSld name="Slide 9">
-    <p:bg>
-      <p:bgPr>
-        <a:solidFill>
-          <a:srgbClr val="F8FAFC"/>
-        </a:solidFill>
-        <a:effectLst/>
-      </p:bgPr>
-    </p:bg>
-    <p:spTree>
-      <p:nvGrpSpPr>
-        <p:cNvPr id="1" name=""/>
-        <p:cNvGrpSpPr/>
-        <p:nvPr/>
-      </p:nvGrpSpPr>
-      <p:grpSpPr>
-        <a:xfrm>
-          <a:off x="0" y="0"/>
-          <a:ext cx="0" cy="0"/>
-          <a:chOff x="0" y="0"/>
-          <a:chExt cx="0" cy="0"/>
-        </a:xfrm>
-      </p:grpSpPr>
-      <p:sp>
-        <p:nvSpPr>
-          <p:cNvPr id="2" name="Text 0"/>
-          <p:cNvSpPr/>
-          <p:nvPr/>
-        </p:nvSpPr>
-        <p:spPr>
-          <a:xfrm>
-            <a:off x="457200" y="502920"/>
-            <a:ext cx="9539935" cy="685800"/>
-          </a:xfrm>
-          <a:prstGeom prst="rect">
-            <a:avLst/>
-          </a:prstGeom>
-          <a:noFill/>
-          <a:ln/>
-        </p:spPr>
-        <p:txBody>
-          <a:bodyPr wrap="square" lIns="0" tIns="0" rIns="0" bIns="0" rtlCol="0" anchor="t"/>
-          <a:lstStyle/>
-          <a:p>
-            <a:pPr marL="0" indent="0" algn="l">
-              <a:buNone/>
-            </a:pPr>
-            <a:r>
-              <a:rPr lang="en-US" sz="3400" b="1" dirty="0">
-                <a:solidFill>
-                  <a:srgbClr val="0F172A"/>
-                </a:solidFill>
-                <a:latin typeface="Cambria" pitchFamily="34" charset="0"/>
-                <a:ea typeface="Cambria" pitchFamily="34" charset="-122"/>
-                <a:cs typeface="Cambria" pitchFamily="34" charset="-120"/>
-              </a:rPr>
-              <a:t>Test</a:t>
-            </a:r>
-            <a:endParaRPr lang="en-US" sz="3400" dirty="0"/>
-          </a:p>
-        </p:txBody>
-      </p:sp>
-      <p:sp>
-        <p:nvSpPr>
-          <p:cNvPr id="3" name="Text 1"/>
-          <p:cNvSpPr/>
-          <p:nvPr/>
-        </p:nvSpPr>
-        <p:spPr>
-          <a:xfrm>
-            <a:off x="457200" y="1216152"/>
-            <a:ext cx="9539935" cy="640080"/>
-          </a:xfrm>
-          <a:prstGeom prst="rect">
-            <a:avLst/>
-          </a:prstGeom>
-          <a:noFill/>
-          <a:ln/>
-        </p:spPr>
-        <p:txBody>
-          <a:bodyPr wrap="square" lIns="0" tIns="0" rIns="0" bIns="0" rtlCol="0" anchor="t"/>
-          <a:lstStyle/>
-          <a:p>
-            <a:pPr marL="0" indent="0" algn="l">
-              <a:buNone/>
-            </a:pPr>
-            <a:r>
-              <a:rPr lang="en-US" sz="1600" dirty="0">
-                <a:solidFill>
-                  <a:srgbClr val="64748B"/>
-                </a:solidFill>
-                <a:latin typeface="Calibri" pitchFamily="34" charset="0"/>
-                <a:ea typeface="Calibri" pitchFamily="34" charset="-122"/>
-                <a:cs typeface="Calibri" pitchFamily="34" charset="-120"/>
-              </a:rPr>
-              <a:t>Run tests to make sure everything looks good.</a:t>
-            </a:r>
-            <a:endParaRPr lang="en-US" sz="1600" dirty="0"/>
-          </a:p>
-        </p:txBody>
-      </p:sp>
-      <p:sp>
-        <p:nvSpPr>
-          <p:cNvPr id="4" name="Shape 2"/>
-          <p:cNvSpPr/>
-          <p:nvPr/>
-        </p:nvSpPr>
-        <p:spPr>
-          <a:xfrm>
-            <a:off x="10362895" y="502920"/>
-            <a:ext cx="1371600" cy="1371600"/>
-          </a:xfrm>
-          <a:prstGeom prst="roundRect">
-            <a:avLst>
-              <a:gd name="adj" fmla="val 8000"/>
-            </a:avLst>
-          </a:prstGeom>
-          <a:solidFill>
-            <a:srgbClr val="ECFDF5"/>
-          </a:solidFill>
-          <a:ln w="12700">
-            <a:solidFill>
-              <a:srgbClr val="E2E8F0"/>
-            </a:solidFill>
-            <a:prstDash val="solid"/>
-          </a:ln>
-        </p:spPr>
-        <p:txBody>
-          <a:bodyPr/>
-          <a:lstStyle/>
-          <a:p>
-            <a:endParaRPr lang="en-US"/>
-          </a:p>
-        </p:txBody>
-      </p:sp>
-      <p:pic>
-        <p:nvPicPr>
-          <p:cNvPr id="5" name="Image 0" descr="icons/search.png"/>
-          <p:cNvPicPr>
-            <a:picLocks noChangeAspect="1"/>
-          </p:cNvPicPr>
-          <p:nvPr/>
-        </p:nvPicPr>
-        <p:blipFill>
-          <a:blip r:embed="rId3"/>
-          <a:stretch>
-            <a:fillRect/>
-          </a:stretch>
-        </p:blipFill>
-        <p:spPr>
-          <a:xfrm>
-            <a:off x="10705795" y="845820"/>
-            <a:ext cx="685800" cy="685800"/>
-          </a:xfrm>
-          <a:prstGeom prst="rect">
-            <a:avLst/>
-          </a:prstGeom>
-        </p:spPr>
-      </p:pic>
-      <p:sp>
-        <p:nvSpPr>
-          <p:cNvPr id="6" name="Shape 3"/>
-          <p:cNvSpPr/>
-          <p:nvPr/>
-        </p:nvSpPr>
-        <p:spPr>
-          <a:xfrm>
-            <a:off x="457199" y="2148840"/>
-            <a:ext cx="11277295" cy="4251960"/>
-          </a:xfrm>
-          <a:prstGeom prst="roundRect">
-            <a:avLst>
-              <a:gd name="adj" fmla="val 2581"/>
-            </a:avLst>
-          </a:prstGeom>
-          <a:solidFill>
-            <a:srgbClr val="FFFFFF"/>
-          </a:solidFill>
-          <a:ln w="12700">
-            <a:solidFill>
-              <a:srgbClr val="E2E8F0"/>
-            </a:solidFill>
-            <a:prstDash val="solid"/>
-          </a:ln>
-          <a:effectLst>
-            <a:outerShdw blurRad="152400" dist="38100" dir="5400000" algn="bl" rotWithShape="0">
-              <a:srgbClr val="1E293B">
-                <a:alpha val="8000"/>
-              </a:srgbClr>
-            </a:outerShdw>
-          </a:effectLst>
-        </p:spPr>
-        <p:txBody>
-          <a:bodyPr/>
-          <a:lstStyle/>
-          <a:p>
-            <a:endParaRPr lang="en-US"/>
-          </a:p>
-        </p:txBody>
-      </p:sp>
-      <p:sp>
-        <p:nvSpPr>
-          <p:cNvPr id="7" name="Text 4"/>
-          <p:cNvSpPr/>
-          <p:nvPr/>
-        </p:nvSpPr>
-        <p:spPr>
-          <a:xfrm>
-            <a:off x="822960" y="2514600"/>
-            <a:ext cx="9144000" cy="365760"/>
-          </a:xfrm>
-          <a:prstGeom prst="rect">
-            <a:avLst/>
-          </a:prstGeom>
-          <a:noFill/>
-          <a:ln/>
-        </p:spPr>
-        <p:txBody>
-          <a:bodyPr wrap="square" lIns="0" tIns="0" rIns="0" bIns="0" rtlCol="0" anchor="t"/>
-          <a:lstStyle/>
-          <a:p>
-            <a:pPr marL="0" indent="0" algn="l">
-              <a:buNone/>
-            </a:pPr>
-            <a:r>
-              <a:rPr lang="en-US" sz="1500" b="1" dirty="0">
-                <a:solidFill>
-                  <a:srgbClr val="059669"/>
-                </a:solidFill>
-                <a:latin typeface="Calibri" pitchFamily="34" charset="0"/>
-                <a:ea typeface="Calibri" pitchFamily="34" charset="-122"/>
-                <a:cs typeface="Calibri" pitchFamily="34" charset="-120"/>
-              </a:rPr>
-              <a:t>Actual Phase C test list</a:t>
-            </a:r>
-            <a:endParaRPr lang="en-US" sz="1500" dirty="0"/>
-          </a:p>
-        </p:txBody>
-      </p:sp>
-      <p:sp>
-        <p:nvSpPr>
-          <p:cNvPr id="8" name="Text 5"/>
-          <p:cNvSpPr/>
-          <p:nvPr/>
-        </p:nvSpPr>
-        <p:spPr>
-          <a:xfrm>
-            <a:off x="822960" y="2926080"/>
-            <a:ext cx="10545775" cy="2743200"/>
-          </a:xfrm>
-          <a:prstGeom prst="rect">
-            <a:avLst/>
-          </a:prstGeom>
-          <a:noFill/>
-          <a:ln/>
-        </p:spPr>
-        <p:txBody>
-          <a:bodyPr wrap="square" lIns="0" tIns="0" rIns="0" bIns="0" rtlCol="0" anchor="t"/>
-          <a:lstStyle/>
-          <a:p>
-            <a:pPr marL="228600" indent="-228600">
-              <a:spcAft>
-                <a:spcPts val="1600"/>
-              </a:spcAft>
-              <a:buSzPct val="100000"/>
-              <a:buChar char="■"/>
-            </a:pPr>
-            <a:r>
-              <a:rPr lang="en-US" sz="1500" dirty="0">
-                <a:solidFill>
-                  <a:srgbClr val="0F172A"/>
-                </a:solidFill>
-                <a:latin typeface="Calibri" pitchFamily="34" charset="0"/>
-                <a:ea typeface="Calibri" pitchFamily="34" charset="-122"/>
-                <a:cs typeface="Calibri" pitchFamily="34" charset="-120"/>
-              </a:rPr>
-              <a:t>Create a new CMR end-to-end</a:t>
-            </a:r>
-            <a:endParaRPr lang="en-US" sz="1500" dirty="0"/>
-          </a:p>
-          <a:p>
-            <a:pPr marL="228600" indent="-228600">
-              <a:spcAft>
-                <a:spcPts val="1600"/>
-              </a:spcAft>
-              <a:buSzPct val="100000"/>
-              <a:buChar char="■"/>
-            </a:pPr>
-            <a:r>
-              <a:rPr lang="en-US" sz="1500" dirty="0">
-                <a:solidFill>
-                  <a:srgbClr val="0F172A"/>
-                </a:solidFill>
-                <a:latin typeface="Calibri" pitchFamily="34" charset="0"/>
-                <a:ea typeface="Calibri" pitchFamily="34" charset="-122"/>
-                <a:cs typeface="Calibri" pitchFamily="34" charset="-120"/>
-              </a:rPr>
-              <a:t>Save and reopen</a:t>
-            </a:r>
-            <a:endParaRPr lang="en-US" sz="1500" dirty="0"/>
-          </a:p>
-          <a:p>
-            <a:pPr marL="228600" indent="-228600">
-              <a:spcAft>
-                <a:spcPts val="1600"/>
-              </a:spcAft>
-              <a:buSzPct val="100000"/>
-              <a:buChar char="■"/>
-            </a:pPr>
-            <a:r>
-              <a:rPr lang="en-US" sz="1500" dirty="0">
-                <a:solidFill>
-                  <a:srgbClr val="0F172A"/>
-                </a:solidFill>
-                <a:latin typeface="Calibri" pitchFamily="34" charset="0"/>
-                <a:ea typeface="Calibri" pitchFamily="34" charset="-122"/>
-                <a:cs typeface="Calibri" pitchFamily="34" charset="-120"/>
-              </a:rPr>
-              <a:t>Confirm numbering has no race condition</a:t>
-            </a:r>
-            <a:endParaRPr lang="en-US" sz="1500" dirty="0"/>
-          </a:p>
-          <a:p>
-            <a:pPr marL="228600" indent="-228600">
-              <a:spcAft>
-                <a:spcPts val="1600"/>
-              </a:spcAft>
-              <a:buSzPct val="100000"/>
-              <a:buChar char="■"/>
-            </a:pPr>
-            <a:r>
-              <a:rPr lang="en-US" sz="1500" dirty="0">
-                <a:solidFill>
-                  <a:srgbClr val="0F172A"/>
-                </a:solidFill>
-                <a:latin typeface="Calibri" pitchFamily="34" charset="0"/>
-                <a:ea typeface="Calibri" pitchFamily="34" charset="-122"/>
-                <a:cs typeface="Calibri" pitchFamily="34" charset="-120"/>
-              </a:rPr>
-              <a:t>Confirm the flow meets requirements</a:t>
-            </a:r>
-            <a:endParaRPr lang="en-US" sz="1500" dirty="0"/>
-          </a:p>
-          <a:p>
-            <a:pPr marL="228600" indent="-228600">
-              <a:spcAft>
-                <a:spcPts val="1600"/>
-              </a:spcAft>
-              <a:buSzPct val="100000"/>
-              <a:buChar char="■"/>
-            </a:pPr>
-            <a:r>
-              <a:rPr lang="en-US" sz="1500" dirty="0">
-                <a:solidFill>
-                  <a:srgbClr val="0F172A"/>
-                </a:solidFill>
-                <a:latin typeface="Calibri" pitchFamily="34" charset="0"/>
-                <a:ea typeface="Calibri" pitchFamily="34" charset="-122"/>
-                <a:cs typeface="Calibri" pitchFamily="34" charset="-120"/>
-              </a:rPr>
-              <a:t>Confirm all fields + lookup fields work</a:t>
             </a:r>
             <a:endParaRPr lang="en-US" sz="1500" dirty="0"/>
           </a:p>

</xml_diff>

<commit_message>
Add Reason Code/Cause Code to the plan deck's Design slide
New row on slide 5's field-mapping table: reason_code + cause_code,
noting they reference the real QCReasonCode/QCCauseCode system
Property Classes (same as QC_MRRs) rather than a custom list. Existing
rows reflowed to a slightly shorter row height so all 7 fit in the same
card without resizing it.

Co-Authored-By: Claude Sonnet 5 <noreply@anthropic.com>
Claude-Session: https://claude.ai/code/session_01Ar9F593p16uUzvwAJdxbpf
</commit_message>
<xml_diff>
--- a/docs/presentations/eCMRs_plan.pptx
+++ b/docs/presentations/eCMRs_plan.pptx
@@ -5264,7 +5264,7 @@
         <p:spPr>
           <a:xfrm>
             <a:off x="822960" y="3419856"/>
-            <a:ext cx="10545775" cy="472440"/>
+            <a:ext cx="10545775" cy="400000"/>
           </a:xfrm>
           <a:prstGeom prst="rect">
             <a:avLst/>
@@ -5291,7 +5291,7 @@
         <p:spPr>
           <a:xfrm>
             <a:off x="932688" y="3419856"/>
-            <a:ext cx="3054005" cy="472440"/>
+            <a:ext cx="3054005" cy="400000"/>
           </a:xfrm>
           <a:prstGeom prst="rect">
             <a:avLst/>
@@ -5330,7 +5330,7 @@
         <p:spPr>
           <a:xfrm>
             <a:off x="3986693" y="3419856"/>
-            <a:ext cx="7290603" cy="472440"/>
+            <a:ext cx="7290603" cy="400000"/>
           </a:xfrm>
           <a:prstGeom prst="rect">
             <a:avLst/>
@@ -5368,7 +5368,7 @@
         </p:nvSpPr>
         <p:spPr>
           <a:xfrm>
-            <a:off x="822960" y="3892296"/>
+            <a:off x="822960" y="3819856"/>
             <a:ext cx="10545775" cy="0"/>
           </a:xfrm>
           <a:prstGeom prst="line">
@@ -5398,8 +5398,8 @@
         </p:nvSpPr>
         <p:spPr>
           <a:xfrm>
-            <a:off x="932688" y="3892296"/>
-            <a:ext cx="3054005" cy="472440"/>
+            <a:off x="932688" y="3819856"/>
+            <a:ext cx="3054005" cy="400000"/>
           </a:xfrm>
           <a:prstGeom prst="rect">
             <a:avLst/>
@@ -5437,8 +5437,8 @@
         </p:nvSpPr>
         <p:spPr>
           <a:xfrm>
-            <a:off x="3986693" y="3892296"/>
-            <a:ext cx="7290603" cy="472440"/>
+            <a:off x="3986693" y="3819856"/>
+            <a:ext cx="7290603" cy="400000"/>
           </a:xfrm>
           <a:prstGeom prst="rect">
             <a:avLst/>
@@ -5476,7 +5476,7 @@
         </p:nvSpPr>
         <p:spPr>
           <a:xfrm>
-            <a:off x="822960" y="4364736"/>
+            <a:off x="822960" y="4219856"/>
             <a:ext cx="10545775" cy="0"/>
           </a:xfrm>
           <a:prstGeom prst="line">
@@ -5506,8 +5506,8 @@
         </p:nvSpPr>
         <p:spPr>
           <a:xfrm>
-            <a:off x="932688" y="4364736"/>
-            <a:ext cx="3054005" cy="472440"/>
+            <a:off x="932688" y="4219856"/>
+            <a:ext cx="3054005" cy="400000"/>
           </a:xfrm>
           <a:prstGeom prst="rect">
             <a:avLst/>
@@ -5545,8 +5545,8 @@
         </p:nvSpPr>
         <p:spPr>
           <a:xfrm>
-            <a:off x="3986693" y="4364736"/>
-            <a:ext cx="7290603" cy="472440"/>
+            <a:off x="3986693" y="4219856"/>
+            <a:ext cx="7290603" cy="400000"/>
           </a:xfrm>
           <a:prstGeom prst="rect">
             <a:avLst/>
@@ -5584,7 +5584,7 @@
         </p:nvSpPr>
         <p:spPr>
           <a:xfrm>
-            <a:off x="822960" y="4837176"/>
+            <a:off x="822960" y="4619856"/>
             <a:ext cx="10545775" cy="0"/>
           </a:xfrm>
           <a:prstGeom prst="line">
@@ -5614,8 +5614,8 @@
         </p:nvSpPr>
         <p:spPr>
           <a:xfrm>
-            <a:off x="932688" y="4837176"/>
-            <a:ext cx="3054005" cy="472440"/>
+            <a:off x="932688" y="4619856"/>
+            <a:ext cx="3054005" cy="400000"/>
           </a:xfrm>
           <a:prstGeom prst="rect">
             <a:avLst/>
@@ -5653,8 +5653,8 @@
         </p:nvSpPr>
         <p:spPr>
           <a:xfrm>
-            <a:off x="3986693" y="4837176"/>
-            <a:ext cx="7290603" cy="472440"/>
+            <a:off x="3986693" y="4619856"/>
+            <a:ext cx="7290603" cy="400000"/>
           </a:xfrm>
           <a:prstGeom prst="rect">
             <a:avLst/>
@@ -5692,7 +5692,7 @@
         </p:nvSpPr>
         <p:spPr>
           <a:xfrm>
-            <a:off x="822960" y="5309616"/>
+            <a:off x="822960" y="5019856"/>
             <a:ext cx="10545775" cy="0"/>
           </a:xfrm>
           <a:prstGeom prst="line">
@@ -5722,8 +5722,8 @@
         </p:nvSpPr>
         <p:spPr>
           <a:xfrm>
-            <a:off x="932688" y="5309616"/>
-            <a:ext cx="3054005" cy="472440"/>
+            <a:off x="932688" y="5019856"/>
+            <a:ext cx="3054005" cy="400000"/>
           </a:xfrm>
           <a:prstGeom prst="rect">
             <a:avLst/>
@@ -5761,8 +5761,8 @@
         </p:nvSpPr>
         <p:spPr>
           <a:xfrm>
-            <a:off x="3986693" y="5309616"/>
-            <a:ext cx="7290603" cy="472440"/>
+            <a:off x="3986693" y="5019856"/>
+            <a:ext cx="7290603" cy="400000"/>
           </a:xfrm>
           <a:prstGeom prst="rect">
             <a:avLst/>
@@ -5800,7 +5800,7 @@
         </p:nvSpPr>
         <p:spPr>
           <a:xfrm>
-            <a:off x="822960" y="5782056"/>
+            <a:off x="822960" y="5419856"/>
             <a:ext cx="10545775" cy="0"/>
           </a:xfrm>
           <a:prstGeom prst="line">
@@ -5830,8 +5830,8 @@
         </p:nvSpPr>
         <p:spPr>
           <a:xfrm>
-            <a:off x="932688" y="5782056"/>
-            <a:ext cx="3054005" cy="472440"/>
+            <a:off x="932688" y="5419856"/>
+            <a:ext cx="3054005" cy="400000"/>
           </a:xfrm>
           <a:prstGeom prst="rect">
             <a:avLst/>
@@ -5869,8 +5869,8 @@
         </p:nvSpPr>
         <p:spPr>
           <a:xfrm>
-            <a:off x="3986693" y="5782056"/>
-            <a:ext cx="7290603" cy="472440"/>
+            <a:off x="3986693" y="5419856"/>
+            <a:ext cx="7290603" cy="400000"/>
           </a:xfrm>
           <a:prstGeom prst="rect">
             <a:avLst/>
@@ -5902,13 +5902,121 @@
       </p:sp>
       <p:sp>
         <p:nvSpPr>
+          <p:cNvPr id="101" name="Shape 101"/>
+          <p:cNvSpPr/>
+          <p:nvPr/>
+        </p:nvSpPr>
+        <p:spPr>
+          <a:xfrm>
+            <a:off x="822960" y="5819856"/>
+            <a:ext cx="10545775" cy="0"/>
+          </a:xfrm>
+          <a:prstGeom prst="line">
+            <a:avLst/>
+          </a:prstGeom>
+          <a:noFill/>
+          <a:ln w="9525">
+            <a:solidFill>
+              <a:srgbClr val="E2E8F0"/>
+            </a:solidFill>
+            <a:prstDash val="solid"/>
+          </a:ln>
+        </p:spPr>
+        <p:txBody>
+          <a:bodyPr/>
+          <a:lstStyle/>
+          <a:p>
+            <a:endParaRPr lang="en-US" dirty="0"/>
+          </a:p>
+        </p:txBody>
+      </p:sp>
+      <p:sp>
+        <p:nvSpPr>
+          <p:cNvPr id="102" name="Text 102"/>
+          <p:cNvSpPr/>
+          <p:nvPr/>
+        </p:nvSpPr>
+        <p:spPr>
+          <a:xfrm>
+            <a:off x="932688" y="5819856"/>
+            <a:ext cx="3054005" cy="400000"/>
+          </a:xfrm>
+          <a:prstGeom prst="rect">
+            <a:avLst/>
+          </a:prstGeom>
+          <a:noFill/>
+          <a:ln/>
+        </p:spPr>
+        <p:txBody>
+          <a:bodyPr wrap="square" lIns="0" tIns="0" rIns="0" bIns="0" rtlCol="0" anchor="ctr"/>
+          <a:lstStyle/>
+          <a:p>
+            <a:pPr marL="0" indent="0">
+              <a:buNone/>
+            </a:pPr>
+            <a:r>
+              <a:rPr lang="en-US" sz="1300" b="1" dirty="0">
+                <a:solidFill>
+                  <a:srgbClr val="0F172A"/>
+                </a:solidFill>
+                <a:latin typeface="Calibri" pitchFamily="34" charset="0"/>
+                <a:ea typeface="Calibri" pitchFamily="34" charset="-122"/>
+                <a:cs typeface="Calibri" pitchFamily="34" charset="-120"/>
+              </a:rPr>
+              <a:t>reason_code + cause_code</a:t>
+            </a:r>
+            <a:endParaRPr lang="en-US" sz="1300" dirty="0"/>
+          </a:p>
+        </p:txBody>
+      </p:sp>
+      <p:sp>
+        <p:nvSpPr>
+          <p:cNvPr id="103" name="Text 103"/>
+          <p:cNvSpPr/>
+          <p:nvPr/>
+        </p:nvSpPr>
+        <p:spPr>
+          <a:xfrm>
+            <a:off x="3986693" y="5819856"/>
+            <a:ext cx="7290603" cy="400000"/>
+          </a:xfrm>
+          <a:prstGeom prst="rect">
+            <a:avLst/>
+          </a:prstGeom>
+          <a:noFill/>
+          <a:ln/>
+        </p:spPr>
+        <p:txBody>
+          <a:bodyPr wrap="square" lIns="0" tIns="0" rIns="0" bIns="0" rtlCol="0" anchor="ctr"/>
+          <a:lstStyle/>
+          <a:p>
+            <a:pPr marL="0" indent="0">
+              <a:buNone/>
+            </a:pPr>
+            <a:r>
+              <a:rPr lang="en-US" sz="1300" dirty="0">
+                <a:solidFill>
+                  <a:srgbClr val="0F172A"/>
+                </a:solidFill>
+                <a:latin typeface="Calibri" pitchFamily="34" charset="0"/>
+                <a:ea typeface="Calibri" pitchFamily="34" charset="-122"/>
+                <a:cs typeface="Calibri" pitchFamily="34" charset="-120"/>
+              </a:rPr>
+              <a:t>Reason Code + Cause Code combos, Quality section - reference the real QCReasonCode/QCCauseCode system Property Classes (same as QC_MRRs)</a:t>
+            </a:r>
+            <a:endParaRPr lang="en-US" sz="1300" dirty="0"/>
+          </a:p>
+        </p:txBody>
+      </p:sp>
+      <p:sp>
+        <p:nvSpPr>
           <p:cNvPr id="26" name="Shape 23"/>
           <p:cNvSpPr/>
           <p:nvPr/>
         </p:nvSpPr>
         <p:spPr>
           <a:xfrm>
-            <a:off x="822960" y="6254496"/>
+            <a:off x="822960" y="6219856"/>
             <a:ext cx="10545775" cy="0"/>
           </a:xfrm>
           <a:prstGeom prst="line">

</xml_diff>

<commit_message>
Add a BRD slide and promote Migration to a real milestone
New slide 4 (BRD), right after Scope: business requirements pulled
directly from the signed CMR Development SOW (standalone CMR form,
pulling existing CMR data into it, custom Reason/Cause Codes with a
new Ref Type C).

Migration (the existing "Migrating the old CMR data" slide, already
sitting between Staging and Launch) is now a numbered milestone like
the others - milestone overview slide updated from seven to eight
items, all rows reflowed to a slightly tighter spacing so 8 fit the
same card, and the slide itself got the standard icon treatment
(a generated database icon, matching the other milestones' flat-icon
style) plus its title/subtitle shifted over to make room for it.

Co-Authored-By: Claude Sonnet 5 <noreply@anthropic.com>
Claude-Session: https://claude.ai/code/session_01Ar9F593p16uUzvwAJdxbpf
</commit_message>
<xml_diff>
--- a/docs/presentations/eCMRs_plan.pptx
+++ b/docs/presentations/eCMRs_plan.pptx
@@ -11,6 +11,7 @@
     <p:sldId id="256" r:id="rId2"/>
     <p:sldId id="257" r:id="rId3"/>
     <p:sldId id="258" r:id="rId4"/>
+    <p:sldId id="267" r:id="rId18"/>
     <p:sldId id="266" r:id="rId5"/>
     <p:sldId id="259" r:id="rId6"/>
     <p:sldId id="260" r:id="rId7"/>
@@ -2453,6 +2454,406 @@
 </p:sld>
 </file>
 
+<file path=ppt/slides/slide12.xml><?xml version="1.0" encoding="utf-8"?>
+<p:sld xmlns:a="http://schemas.openxmlformats.org/drawingml/2006/main" xmlns:r="http://schemas.openxmlformats.org/officeDocument/2006/relationships" xmlns:p="http://schemas.openxmlformats.org/presentationml/2006/main">
+  <p:cSld name="Slide 5">
+    <p:bg>
+      <p:bgPr>
+        <a:solidFill>
+          <a:srgbClr val="F8FAFC"/>
+        </a:solidFill>
+        <a:effectLst/>
+      </p:bgPr>
+    </p:bg>
+    <p:spTree>
+      <p:nvGrpSpPr>
+        <p:cNvPr id="1" name=""/>
+        <p:cNvGrpSpPr/>
+        <p:nvPr/>
+      </p:nvGrpSpPr>
+      <p:grpSpPr>
+        <a:xfrm>
+          <a:off x="0" y="0"/>
+          <a:ext cx="0" cy="0"/>
+          <a:chOff x="0" y="0"/>
+          <a:chExt cx="0" cy="0"/>
+        </a:xfrm>
+      </p:grpSpPr>
+      <p:sp>
+        <p:nvSpPr>
+          <p:cNvPr id="2" name="Shape 0"/>
+          <p:cNvSpPr/>
+          <p:nvPr/>
+        </p:nvSpPr>
+        <p:spPr>
+          <a:xfrm>
+            <a:off x="457200" y="502920"/>
+            <a:ext cx="1371600" cy="1371600"/>
+          </a:xfrm>
+          <a:prstGeom prst="roundRect">
+            <a:avLst>
+              <a:gd name="adj" fmla="val 8000"/>
+            </a:avLst>
+          </a:prstGeom>
+          <a:solidFill>
+            <a:srgbClr val="ECFDF5"/>
+          </a:solidFill>
+          <a:ln w="12700">
+            <a:solidFill>
+              <a:srgbClr val="E2E8F0"/>
+            </a:solidFill>
+            <a:prstDash val="solid"/>
+          </a:ln>
+        </p:spPr>
+        <p:txBody>
+          <a:bodyPr/>
+          <a:lstStyle/>
+          <a:p>
+            <a:endParaRPr lang="en-US" dirty="0"/>
+          </a:p>
+        </p:txBody>
+      </p:sp>
+      <p:pic>
+        <p:nvPicPr>
+          <p:cNvPr id="3" name="Image 0" descr="icons/clipboard.png"/>
+          <p:cNvPicPr>
+            <a:picLocks noChangeAspect="1"/>
+          </p:cNvPicPr>
+          <p:nvPr/>
+        </p:nvPicPr>
+        <p:blipFill>
+          <a:blip r:embed="rId3"/>
+          <a:stretch>
+            <a:fillRect/>
+          </a:stretch>
+        </p:blipFill>
+        <p:spPr>
+          <a:xfrm>
+            <a:off x="800100" y="845820"/>
+            <a:ext cx="685800" cy="685800"/>
+          </a:xfrm>
+          <a:prstGeom prst="rect">
+            <a:avLst/>
+          </a:prstGeom>
+        </p:spPr>
+      </p:pic>
+      <p:sp>
+        <p:nvSpPr>
+          <p:cNvPr id="4" name="Text 1"/>
+          <p:cNvSpPr/>
+          <p:nvPr/>
+        </p:nvSpPr>
+        <p:spPr>
+          <a:xfrm>
+            <a:off x="2194560" y="502920"/>
+            <a:ext cx="9539935" cy="685800"/>
+          </a:xfrm>
+          <a:prstGeom prst="rect">
+            <a:avLst/>
+          </a:prstGeom>
+          <a:noFill/>
+          <a:ln/>
+        </p:spPr>
+        <p:txBody>
+          <a:bodyPr wrap="square" lIns="0" tIns="0" rIns="0" bIns="0" rtlCol="0" anchor="t"/>
+          <a:lstStyle/>
+          <a:p>
+            <a:pPr marL="0" indent="0" algn="l">
+              <a:buNone/>
+            </a:pPr>
+            <a:r>
+              <a:rPr lang="en-US" sz="3400" b="1" dirty="0">
+                <a:solidFill>
+                  <a:srgbClr val="0F172A"/>
+                </a:solidFill>
+                <a:latin typeface="Cambria" pitchFamily="34" charset="0"/>
+                <a:ea typeface="Cambria" pitchFamily="34" charset="-122"/>
+                <a:cs typeface="Cambria" pitchFamily="34" charset="-120"/>
+              </a:rPr>
+              <a:t>BRD</a:t>
+            </a:r>
+            <a:endParaRPr lang="en-US" sz="3400" dirty="0"/>
+          </a:p>
+        </p:txBody>
+      </p:sp>
+      <p:sp>
+        <p:nvSpPr>
+          <p:cNvPr id="5" name="Text 2"/>
+          <p:cNvSpPr/>
+          <p:nvPr/>
+        </p:nvSpPr>
+        <p:spPr>
+          <a:xfrm>
+            <a:off x="2194560" y="1216152"/>
+            <a:ext cx="9539935" cy="640080"/>
+          </a:xfrm>
+          <a:prstGeom prst="rect">
+            <a:avLst/>
+          </a:prstGeom>
+          <a:noFill/>
+          <a:ln/>
+        </p:spPr>
+        <p:txBody>
+          <a:bodyPr wrap="square" lIns="0" tIns="0" rIns="0" bIns="0" rtlCol="0" anchor="t"/>
+          <a:lstStyle/>
+          <a:p>
+            <a:pPr marL="0" indent="0" algn="l">
+              <a:buNone/>
+            </a:pPr>
+            <a:r>
+              <a:rPr lang="en-US" sz="1600" dirty="0">
+                <a:solidFill>
+                  <a:srgbClr val="64748B"/>
+                </a:solidFill>
+                <a:latin typeface="Calibri" pitchFamily="34" charset="0"/>
+                <a:ea typeface="Calibri" pitchFamily="34" charset="-122"/>
+                <a:cs typeface="Calibri" pitchFamily="34" charset="-120"/>
+              </a:rPr>
+              <a:t>Business requirements, confirmed from the signed CMR Development SOW.</a:t>
+            </a:r>
+            <a:endParaRPr lang="en-US" sz="1600" dirty="0"/>
+          </a:p>
+        </p:txBody>
+      </p:sp>
+      <p:sp>
+        <p:nvSpPr>
+          <p:cNvPr id="6" name="Shape 3"/>
+          <p:cNvSpPr/>
+          <p:nvPr/>
+        </p:nvSpPr>
+        <p:spPr>
+          <a:xfrm>
+            <a:off x="457200" y="2148840"/>
+            <a:ext cx="11277295" cy="4251960"/>
+          </a:xfrm>
+          <a:prstGeom prst="roundRect">
+            <a:avLst>
+              <a:gd name="adj" fmla="val 2581"/>
+            </a:avLst>
+          </a:prstGeom>
+          <a:solidFill>
+            <a:srgbClr val="FFFFFF"/>
+          </a:solidFill>
+          <a:ln w="12700">
+            <a:solidFill>
+              <a:srgbClr val="E2E8F0"/>
+            </a:solidFill>
+            <a:prstDash val="solid"/>
+          </a:ln>
+          <a:effectLst>
+            <a:outerShdw blurRad="152400" dist="38100" dir="5400000" algn="bl" rotWithShape="0">
+              <a:srgbClr val="1E293B">
+                <a:alpha val="8000"/>
+              </a:srgbClr>
+            </a:outerShdw>
+          </a:effectLst>
+        </p:spPr>
+        <p:txBody>
+          <a:bodyPr/>
+          <a:lstStyle/>
+          <a:p>
+            <a:endParaRPr lang="en-US" dirty="0"/>
+          </a:p>
+        </p:txBody>
+      </p:sp>
+      <p:sp>
+        <p:nvSpPr>
+          <p:cNvPr id="7" name="Text 4"/>
+          <p:cNvSpPr/>
+          <p:nvPr/>
+        </p:nvSpPr>
+        <p:spPr>
+          <a:xfrm>
+            <a:off x="822960" y="2514600"/>
+            <a:ext cx="9144000" cy="365760"/>
+          </a:xfrm>
+          <a:prstGeom prst="rect">
+            <a:avLst/>
+          </a:prstGeom>
+          <a:noFill/>
+          <a:ln/>
+        </p:spPr>
+        <p:txBody>
+          <a:bodyPr wrap="square" lIns="0" tIns="0" rIns="0" bIns="0" rtlCol="0" anchor="t"/>
+          <a:lstStyle/>
+          <a:p>
+            <a:pPr marL="0" indent="0" algn="l">
+              <a:buNone/>
+            </a:pPr>
+            <a:r>
+              <a:rPr lang="en-US" sz="1500" b="1" dirty="0">
+                <a:solidFill>
+                  <a:srgbClr val="059669"/>
+                </a:solidFill>
+                <a:latin typeface="Calibri" pitchFamily="34" charset="0"/>
+                <a:ea typeface="Calibri" pitchFamily="34" charset="-122"/>
+                <a:cs typeface="Calibri" pitchFamily="34" charset="-120"/>
+              </a:rPr>
+              <a:t>Business requirements</a:t>
+            </a:r>
+            <a:endParaRPr lang="en-US" sz="1500" dirty="0"/>
+          </a:p>
+        </p:txBody>
+      </p:sp>
+      <p:sp>
+        <p:nvSpPr>
+          <p:cNvPr id="8" name="Text 5"/>
+          <p:cNvSpPr/>
+          <p:nvPr/>
+        </p:nvSpPr>
+        <p:spPr>
+          <a:xfrm>
+            <a:off x="822960" y="2926080"/>
+            <a:ext cx="10545775" cy="2743200"/>
+          </a:xfrm>
+          <a:prstGeom prst="rect">
+            <a:avLst/>
+          </a:prstGeom>
+          <a:noFill/>
+          <a:ln/>
+        </p:spPr>
+        <p:txBody>
+          <a:p>
+            <a:pPr marL="228600" indent="-228600">
+              <a:buSzPct val="100000"/>
+              <a:buChar char="■"/>
+            </a:pPr>
+            <a:r>
+              <a:rPr lang="en-US" sz="1500" dirty="0">
+                <a:solidFill>
+                  <a:srgbClr val="0F172A"/>
+                </a:solidFill>
+                <a:latin typeface="Calibri" pitchFamily="34" charset="0"/>
+                <a:ea typeface="Calibri" pitchFamily="34" charset="-122"/>
+                <a:cs typeface="Calibri" pitchFamily="34" charset="-120"/>
+              </a:rPr>
+              <a:t>Create a </a:t>
+            </a:r>
+            <a:r>
+              <a:rPr lang="en-US" sz="1500" b="1" dirty="0">
+                <a:solidFill>
+                  <a:srgbClr val="0F172A"/>
+                </a:solidFill>
+                <a:latin typeface="Calibri" pitchFamily="34" charset="0"/>
+                <a:ea typeface="Calibri" pitchFamily="34" charset="-122"/>
+                <a:cs typeface="Calibri" pitchFamily="34" charset="-120"/>
+              </a:rPr>
+              <a:t>standalone CMR form</a:t>
+            </a:r>
+            <a:r>
+              <a:rPr lang="en-US" sz="1500" dirty="0">
+                <a:solidFill>
+                  <a:srgbClr val="0F172A"/>
+                </a:solidFill>
+                <a:latin typeface="Calibri" pitchFamily="34" charset="0"/>
+                <a:ea typeface="Calibri" pitchFamily="34" charset="-122"/>
+                <a:cs typeface="Calibri" pitchFamily="34" charset="-120"/>
+              </a:rPr>
+              <a:t> - not dependent on Create Change Request/Change Request Management existing first</a:t>
+            </a:r>
+            <a:endParaRPr lang="en-US" sz="1500" dirty="0"/>
+          </a:p>
+          <a:p>
+            <a:pPr marL="228600" indent="-228600">
+              <a:buSzPct val="100000"/>
+              <a:buChar char="■"/>
+            </a:pPr>
+            <a:r>
+              <a:rPr lang="en-US" sz="1500" dirty="0">
+                <a:solidFill>
+                  <a:srgbClr val="0F172A"/>
+                </a:solidFill>
+                <a:latin typeface="Calibri" pitchFamily="34" charset="0"/>
+                <a:ea typeface="Calibri" pitchFamily="34" charset="-122"/>
+                <a:cs typeface="Calibri" pitchFamily="34" charset="-120"/>
+              </a:rPr>
+              <a:t>Pull data from existing CMR entries</a:t>
+            </a:r>
+            <a:r>
+              <a:rPr lang="en-US" sz="1500" dirty="0">
+                <a:solidFill>
+                  <a:srgbClr val="0F172A"/>
+                </a:solidFill>
+                <a:latin typeface="Calibri" pitchFamily="34" charset="0"/>
+                <a:ea typeface="Calibri" pitchFamily="34" charset="-122"/>
+                <a:cs typeface="Calibri" pitchFamily="34" charset="-120"/>
+              </a:rPr>
+              <a:t> into the new form</a:t>
+            </a:r>
+            <a:endParaRPr lang="en-US" sz="1500" dirty="0"/>
+          </a:p>
+          <a:p>
+            <a:pPr marL="228600" indent="-228600">
+              <a:buSzPct val="100000"/>
+              <a:buChar char="■"/>
+            </a:pPr>
+            <a:r>
+              <a:rPr lang="en-US" sz="1500" dirty="0">
+                <a:solidFill>
+                  <a:srgbClr val="0F172A"/>
+                </a:solidFill>
+                <a:latin typeface="Calibri" pitchFamily="34" charset="0"/>
+                <a:ea typeface="Calibri" pitchFamily="34" charset="-122"/>
+                <a:cs typeface="Calibri" pitchFamily="34" charset="-120"/>
+              </a:rPr>
+              <a:t>Create custom </a:t>
+            </a:r>
+            <a:r>
+              <a:rPr lang="en-US" sz="1500" b="1" dirty="0">
+                <a:solidFill>
+                  <a:srgbClr val="0F172A"/>
+                </a:solidFill>
+                <a:latin typeface="Calibri" pitchFamily="34" charset="0"/>
+                <a:ea typeface="Calibri" pitchFamily="34" charset="-122"/>
+                <a:cs typeface="Calibri" pitchFamily="34" charset="-120"/>
+              </a:rPr>
+              <a:t>Reason and Cause Codes</a:t>
+            </a:r>
+            <a:r>
+              <a:rPr lang="en-US" sz="1500" dirty="0">
+                <a:solidFill>
+                  <a:srgbClr val="0F172A"/>
+                </a:solidFill>
+                <a:latin typeface="Calibri" pitchFamily="34" charset="0"/>
+                <a:ea typeface="Calibri" pitchFamily="34" charset="-122"/>
+                <a:cs typeface="Calibri" pitchFamily="34" charset="-120"/>
+              </a:rPr>
+              <a:t>, with a new Ref Type </a:t>
+            </a:r>
+            <a:r>
+              <a:rPr lang="en-US" sz="1500" b="1" dirty="0">
+                <a:solidFill>
+                  <a:srgbClr val="0F172A"/>
+                </a:solidFill>
+                <a:latin typeface="Calibri" pitchFamily="34" charset="0"/>
+                <a:ea typeface="Calibri" pitchFamily="34" charset="-122"/>
+                <a:cs typeface="Calibri" pitchFamily="34" charset="-120"/>
+              </a:rPr>
+              <a:t>C</a:t>
+            </a:r>
+            <a:r>
+              <a:rPr lang="en-US" sz="1500" dirty="0">
+                <a:solidFill>
+                  <a:srgbClr val="0F172A"/>
+                </a:solidFill>
+                <a:latin typeface="Calibri" pitchFamily="34" charset="0"/>
+                <a:ea typeface="Calibri" pitchFamily="34" charset="-122"/>
+                <a:cs typeface="Calibri" pitchFamily="34" charset="-120"/>
+              </a:rPr>
+              <a:t> used for CMR Reason/Cause selection</a:t>
+            </a:r>
+            <a:endParaRPr lang="en-US" sz="1500" dirty="0"/>
+          </a:p>
+        </p:txBody>
+      </p:sp>
+    </p:spTree>
+  </p:cSld>
+  <p:clrMapOvr>
+    <a:masterClrMapping/>
+  </p:clrMapOvr>
+</p:sld>
+</file>
+
 <file path=ppt/slides/slide2.xml><?xml version="1.0" encoding="utf-8"?>
 <p:sld xmlns:a="http://schemas.openxmlformats.org/drawingml/2006/main" xmlns:r="http://schemas.openxmlformats.org/officeDocument/2006/relationships" xmlns:p="http://schemas.openxmlformats.org/presentationml/2006/main">
   <p:cSld name="Slide 2">
@@ -2487,7 +2888,7 @@
         <p:spPr>
           <a:xfrm>
             <a:off x="457200" y="457200"/>
-            <a:ext cx="11277295" cy="5943600"/>
+            <a:ext cx="11277295" cy="6144216"/>
           </a:xfrm>
           <a:prstGeom prst="roundRect">
             <a:avLst>
@@ -2552,7 +2953,7 @@
                 <a:ea typeface="Cambria" pitchFamily="34" charset="-122"/>
                 <a:cs typeface="Cambria" pitchFamily="34" charset="-120"/>
               </a:rPr>
-              <a:t>Seven milestones to production</a:t>
+              <a:t>Eight milestones to production</a:t>
             </a:r>
             <a:endParaRPr lang="en-US" sz="3800" dirty="0"/>
           </a:p>
@@ -2606,7 +3007,7 @@
         <p:spPr>
           <a:xfrm>
             <a:off x="1060704" y="2340864"/>
-            <a:ext cx="0" cy="3566160"/>
+            <a:ext cx="0" cy="3864000"/>
           </a:xfrm>
           <a:prstGeom prst="line">
             <a:avLst/>
@@ -2702,7 +3103,7 @@
         <p:spPr>
           <a:xfrm>
             <a:off x="1527048" y="2093976"/>
-            <a:ext cx="9144000" cy="594360"/>
+            <a:ext cx="9144000" cy="552000"/>
           </a:xfrm>
           <a:prstGeom prst="rect">
             <a:avLst/>
@@ -2763,7 +3164,7 @@
         </p:nvSpPr>
         <p:spPr>
           <a:xfrm>
-            <a:off x="868680" y="2743200"/>
+            <a:off x="868680" y="2700840"/>
             <a:ext cx="384048" cy="384048"/>
           </a:xfrm>
           <a:prstGeom prst="ellipse">
@@ -2790,7 +3191,7 @@
         </p:nvSpPr>
         <p:spPr>
           <a:xfrm>
-            <a:off x="868680" y="2743200"/>
+            <a:off x="868680" y="2700840"/>
             <a:ext cx="384048" cy="384048"/>
           </a:xfrm>
           <a:prstGeom prst="rect">
@@ -2829,8 +3230,8 @@
         </p:nvSpPr>
         <p:spPr>
           <a:xfrm>
-            <a:off x="1527048" y="2688336"/>
-            <a:ext cx="9144000" cy="594360"/>
+            <a:off x="1527048" y="2645976"/>
+            <a:ext cx="9144000" cy="552000"/>
           </a:xfrm>
           <a:prstGeom prst="rect">
             <a:avLst/>
@@ -2891,7 +3292,7 @@
         </p:nvSpPr>
         <p:spPr>
           <a:xfrm>
-            <a:off x="868680" y="3337560"/>
+            <a:off x="868680" y="3252840"/>
             <a:ext cx="384048" cy="384048"/>
           </a:xfrm>
           <a:prstGeom prst="ellipse">
@@ -2918,7 +3319,7 @@
         </p:nvSpPr>
         <p:spPr>
           <a:xfrm>
-            <a:off x="868680" y="3337560"/>
+            <a:off x="868680" y="3252840"/>
             <a:ext cx="384048" cy="384048"/>
           </a:xfrm>
           <a:prstGeom prst="rect">
@@ -2957,8 +3358,8 @@
         </p:nvSpPr>
         <p:spPr>
           <a:xfrm>
-            <a:off x="1527048" y="3282696"/>
-            <a:ext cx="9144000" cy="594360"/>
+            <a:off x="1527048" y="3197976"/>
+            <a:ext cx="9144000" cy="552000"/>
           </a:xfrm>
           <a:prstGeom prst="rect">
             <a:avLst/>
@@ -3019,7 +3420,7 @@
         </p:nvSpPr>
         <p:spPr>
           <a:xfrm>
-            <a:off x="868680" y="3931920"/>
+            <a:off x="868680" y="3804840"/>
             <a:ext cx="384048" cy="384048"/>
           </a:xfrm>
           <a:prstGeom prst="ellipse">
@@ -3046,7 +3447,7 @@
         </p:nvSpPr>
         <p:spPr>
           <a:xfrm>
-            <a:off x="868680" y="3931920"/>
+            <a:off x="868680" y="3804840"/>
             <a:ext cx="384048" cy="384048"/>
           </a:xfrm>
           <a:prstGeom prst="rect">
@@ -3085,8 +3486,8 @@
         </p:nvSpPr>
         <p:spPr>
           <a:xfrm>
-            <a:off x="1527048" y="3877056"/>
-            <a:ext cx="9144000" cy="594360"/>
+            <a:off x="1527048" y="3749976"/>
+            <a:ext cx="9144000" cy="552000"/>
           </a:xfrm>
           <a:prstGeom prst="rect">
             <a:avLst/>
@@ -3141,13 +3542,13 @@
       </p:sp>
       <p:sp>
         <p:nvSpPr>
-          <p:cNvPr id="18" name="Shape 16"/>
-          <p:cNvSpPr/>
-          <p:nvPr/>
-        </p:nvSpPr>
-        <p:spPr>
-          <a:xfrm>
-            <a:off x="868680" y="4526280"/>
+          <p:cNvPr id="101" name="Shape 101"/>
+          <p:cNvSpPr/>
+          <p:nvPr/>
+        </p:nvSpPr>
+        <p:spPr>
+          <a:xfrm>
+            <a:off x="868680" y="4356840"/>
             <a:ext cx="384048" cy="384048"/>
           </a:xfrm>
           <a:prstGeom prst="ellipse">
@@ -3168,13 +3569,13 @@
       </p:sp>
       <p:sp>
         <p:nvSpPr>
-          <p:cNvPr id="19" name="Text 17"/>
-          <p:cNvSpPr/>
-          <p:nvPr/>
-        </p:nvSpPr>
-        <p:spPr>
-          <a:xfrm>
-            <a:off x="868680" y="4526280"/>
+          <p:cNvPr id="102" name="Text 102"/>
+          <p:cNvSpPr/>
+          <p:nvPr/>
+        </p:nvSpPr>
+        <p:spPr>
+          <a:xfrm>
+            <a:off x="868680" y="4356840"/>
             <a:ext cx="384048" cy="384048"/>
           </a:xfrm>
           <a:prstGeom prst="rect">
@@ -3207,14 +3608,14 @@
       </p:sp>
       <p:sp>
         <p:nvSpPr>
-          <p:cNvPr id="20" name="Text 18"/>
-          <p:cNvSpPr/>
-          <p:nvPr/>
-        </p:nvSpPr>
-        <p:spPr>
-          <a:xfrm>
-            <a:off x="1527048" y="4471416"/>
-            <a:ext cx="9144000" cy="594360"/>
+          <p:cNvPr id="103" name="Text 103"/>
+          <p:cNvSpPr/>
+          <p:nvPr/>
+        </p:nvSpPr>
+        <p:spPr>
+          <a:xfrm>
+            <a:off x="1527048" y="4301976"/>
+            <a:ext cx="9144000" cy="552000"/>
           </a:xfrm>
           <a:prstGeom prst="rect">
             <a:avLst/>
@@ -3241,7 +3642,7 @@
                 <a:ea typeface="Calibri" pitchFamily="34" charset="-122"/>
                 <a:cs typeface="Calibri" pitchFamily="34" charset="-120"/>
               </a:rPr>
-              <a:t>Launch</a:t>
+              <a:t>Migration</a:t>
             </a:r>
             <a:endParaRPr lang="en-US" sz="1700" dirty="0"/>
           </a:p>
@@ -3261,7 +3662,7 @@
                 <a:ea typeface="Calibri" pitchFamily="34" charset="-122"/>
                 <a:cs typeface="Calibri" pitchFamily="34" charset="-120"/>
               </a:rPr>
-              <a:t>Deploy to production.</a:t>
+              <a:t>Bring historical CMR data into the new table, or decide to start fresh.</a:t>
             </a:r>
             <a:endParaRPr lang="en-US" sz="1700" dirty="0"/>
           </a:p>
@@ -3269,13 +3670,13 @@
       </p:sp>
       <p:sp>
         <p:nvSpPr>
-          <p:cNvPr id="21" name="Shape 19"/>
-          <p:cNvSpPr/>
-          <p:nvPr/>
-        </p:nvSpPr>
-        <p:spPr>
-          <a:xfrm>
-            <a:off x="868680" y="5120640"/>
+          <p:cNvPr id="18" name="Shape 16"/>
+          <p:cNvSpPr/>
+          <p:nvPr/>
+        </p:nvSpPr>
+        <p:spPr>
+          <a:xfrm>
+            <a:off x="868680" y="4908840"/>
             <a:ext cx="384048" cy="384048"/>
           </a:xfrm>
           <a:prstGeom prst="ellipse">
@@ -3296,13 +3697,13 @@
       </p:sp>
       <p:sp>
         <p:nvSpPr>
-          <p:cNvPr id="22" name="Text 20"/>
-          <p:cNvSpPr/>
-          <p:nvPr/>
-        </p:nvSpPr>
-        <p:spPr>
-          <a:xfrm>
-            <a:off x="868680" y="5120640"/>
+          <p:cNvPr id="19" name="Text 17"/>
+          <p:cNvSpPr/>
+          <p:nvPr/>
+        </p:nvSpPr>
+        <p:spPr>
+          <a:xfrm>
+            <a:off x="868680" y="4908840"/>
             <a:ext cx="384048" cy="384048"/>
           </a:xfrm>
           <a:prstGeom prst="rect">
@@ -3335,14 +3736,14 @@
       </p:sp>
       <p:sp>
         <p:nvSpPr>
-          <p:cNvPr id="23" name="Text 21"/>
-          <p:cNvSpPr/>
-          <p:nvPr/>
-        </p:nvSpPr>
-        <p:spPr>
-          <a:xfrm>
-            <a:off x="1527048" y="5065776"/>
-            <a:ext cx="9144000" cy="594360"/>
+          <p:cNvPr id="20" name="Text 18"/>
+          <p:cNvSpPr/>
+          <p:nvPr/>
+        </p:nvSpPr>
+        <p:spPr>
+          <a:xfrm>
+            <a:off x="1527048" y="4853976"/>
+            <a:ext cx="9144000" cy="552000"/>
           </a:xfrm>
           <a:prstGeom prst="rect">
             <a:avLst/>
@@ -3369,7 +3770,7 @@
                 <a:ea typeface="Calibri" pitchFamily="34" charset="-122"/>
                 <a:cs typeface="Calibri" pitchFamily="34" charset="-120"/>
               </a:rPr>
-              <a:t>Test</a:t>
+              <a:t>Launch</a:t>
             </a:r>
             <a:endParaRPr lang="en-US" sz="1700" dirty="0"/>
           </a:p>
@@ -3389,7 +3790,7 @@
                 <a:ea typeface="Calibri" pitchFamily="34" charset="-122"/>
                 <a:cs typeface="Calibri" pitchFamily="34" charset="-120"/>
               </a:rPr>
-              <a:t>Run tests to make sure everything looks good.</a:t>
+              <a:t>Deploy to production.</a:t>
             </a:r>
             <a:endParaRPr lang="en-US" sz="1700" dirty="0"/>
           </a:p>
@@ -3397,13 +3798,13 @@
       </p:sp>
       <p:sp>
         <p:nvSpPr>
-          <p:cNvPr id="24" name="Shape 22"/>
-          <p:cNvSpPr/>
-          <p:nvPr/>
-        </p:nvSpPr>
-        <p:spPr>
-          <a:xfrm>
-            <a:off x="868680" y="5715000"/>
+          <p:cNvPr id="21" name="Shape 19"/>
+          <p:cNvSpPr/>
+          <p:nvPr/>
+        </p:nvSpPr>
+        <p:spPr>
+          <a:xfrm>
+            <a:off x="868680" y="5460840"/>
             <a:ext cx="384048" cy="384048"/>
           </a:xfrm>
           <a:prstGeom prst="ellipse">
@@ -3424,13 +3825,141 @@
       </p:sp>
       <p:sp>
         <p:nvSpPr>
+          <p:cNvPr id="22" name="Text 20"/>
+          <p:cNvSpPr/>
+          <p:nvPr/>
+        </p:nvSpPr>
+        <p:spPr>
+          <a:xfrm>
+            <a:off x="868680" y="5460840"/>
+            <a:ext cx="384048" cy="384048"/>
+          </a:xfrm>
+          <a:prstGeom prst="rect">
+            <a:avLst/>
+          </a:prstGeom>
+          <a:noFill/>
+          <a:ln/>
+        </p:spPr>
+        <p:txBody>
+          <a:bodyPr wrap="square" lIns="0" tIns="0" rIns="0" bIns="0" rtlCol="0" anchor="ctr"/>
+          <a:lstStyle/>
+          <a:p>
+            <a:pPr marL="0" indent="0" algn="ctr">
+              <a:buNone/>
+            </a:pPr>
+            <a:r>
+              <a:rPr lang="en-US" sz="1400" b="1" dirty="0">
+                <a:solidFill>
+                  <a:srgbClr val="FFFFFF"/>
+                </a:solidFill>
+                <a:latin typeface="Calibri" pitchFamily="34" charset="0"/>
+                <a:ea typeface="Calibri" pitchFamily="34" charset="-122"/>
+                <a:cs typeface="Calibri" pitchFamily="34" charset="-120"/>
+              </a:rPr>
+              <a:t>7</a:t>
+            </a:r>
+            <a:endParaRPr lang="en-US" sz="1400" dirty="0"/>
+          </a:p>
+        </p:txBody>
+      </p:sp>
+      <p:sp>
+        <p:nvSpPr>
+          <p:cNvPr id="23" name="Text 21"/>
+          <p:cNvSpPr/>
+          <p:nvPr/>
+        </p:nvSpPr>
+        <p:spPr>
+          <a:xfrm>
+            <a:off x="1527048" y="5405976"/>
+            <a:ext cx="9144000" cy="552000"/>
+          </a:xfrm>
+          <a:prstGeom prst="rect">
+            <a:avLst/>
+          </a:prstGeom>
+          <a:noFill/>
+          <a:ln/>
+        </p:spPr>
+        <p:txBody>
+          <a:bodyPr wrap="square" lIns="0" tIns="0" rIns="0" bIns="0" rtlCol="0" anchor="t"/>
+          <a:lstStyle/>
+          <a:p>
+            <a:pPr marL="0" indent="0">
+              <a:lnSpc>
+                <a:spcPts val="1900"/>
+              </a:lnSpc>
+              <a:buNone/>
+            </a:pPr>
+            <a:r>
+              <a:rPr lang="en-US" sz="1700" b="1" dirty="0">
+                <a:solidFill>
+                  <a:srgbClr val="0F172A"/>
+                </a:solidFill>
+                <a:latin typeface="Calibri" pitchFamily="34" charset="0"/>
+                <a:ea typeface="Calibri" pitchFamily="34" charset="-122"/>
+                <a:cs typeface="Calibri" pitchFamily="34" charset="-120"/>
+              </a:rPr>
+              <a:t>Test</a:t>
+            </a:r>
+            <a:endParaRPr lang="en-US" sz="1700" dirty="0"/>
+          </a:p>
+          <a:p>
+            <a:pPr marL="0" indent="0">
+              <a:lnSpc>
+                <a:spcPts val="1900"/>
+              </a:lnSpc>
+              <a:buNone/>
+            </a:pPr>
+            <a:r>
+              <a:rPr lang="en-US" sz="1350" dirty="0">
+                <a:solidFill>
+                  <a:srgbClr val="64748B"/>
+                </a:solidFill>
+                <a:latin typeface="Calibri" pitchFamily="34" charset="0"/>
+                <a:ea typeface="Calibri" pitchFamily="34" charset="-122"/>
+                <a:cs typeface="Calibri" pitchFamily="34" charset="-120"/>
+              </a:rPr>
+              <a:t>Run tests to make sure everything looks good.</a:t>
+            </a:r>
+            <a:endParaRPr lang="en-US" sz="1700" dirty="0"/>
+          </a:p>
+        </p:txBody>
+      </p:sp>
+      <p:sp>
+        <p:nvSpPr>
+          <p:cNvPr id="24" name="Shape 22"/>
+          <p:cNvSpPr/>
+          <p:nvPr/>
+        </p:nvSpPr>
+        <p:spPr>
+          <a:xfrm>
+            <a:off x="868680" y="6012840"/>
+            <a:ext cx="384048" cy="384048"/>
+          </a:xfrm>
+          <a:prstGeom prst="ellipse">
+            <a:avLst/>
+          </a:prstGeom>
+          <a:solidFill>
+            <a:srgbClr val="059669"/>
+          </a:solidFill>
+          <a:ln/>
+        </p:spPr>
+        <p:txBody>
+          <a:bodyPr/>
+          <a:lstStyle/>
+          <a:p>
+            <a:endParaRPr lang="en-US" dirty="0"/>
+          </a:p>
+        </p:txBody>
+      </p:sp>
+      <p:sp>
+        <p:nvSpPr>
           <p:cNvPr id="25" name="Text 23"/>
           <p:cNvSpPr/>
           <p:nvPr/>
         </p:nvSpPr>
         <p:spPr>
           <a:xfrm>
-            <a:off x="868680" y="5715000"/>
+            <a:off x="868680" y="6012840"/>
             <a:ext cx="384048" cy="384048"/>
           </a:xfrm>
           <a:prstGeom prst="rect">
@@ -3455,7 +3984,7 @@
                 <a:ea typeface="Calibri" pitchFamily="34" charset="-122"/>
                 <a:cs typeface="Calibri" pitchFamily="34" charset="-120"/>
               </a:rPr>
-              <a:t>7</a:t>
+              <a:t>8</a:t>
             </a:r>
             <a:endParaRPr lang="en-US" sz="1400" dirty="0"/>
           </a:p>
@@ -3469,8 +3998,8 @@
         </p:nvSpPr>
         <p:spPr>
           <a:xfrm>
-            <a:off x="1527048" y="5660136"/>
-            <a:ext cx="9144000" cy="594360"/>
+            <a:off x="1527048" y="5957976"/>
+            <a:ext cx="9144000" cy="552000"/>
           </a:xfrm>
           <a:prstGeom prst="rect">
             <a:avLst/>
@@ -7174,15 +7703,22 @@
         <p:spPr>
           <a:xfrm>
             <a:off x="457200" y="502920"/>
-            <a:ext cx="457200" cy="45720"/>
-          </a:xfrm>
-          <a:prstGeom prst="rect">
-            <a:avLst/>
+            <a:ext cx="1371600" cy="1371600"/>
+          </a:xfrm>
+          <a:prstGeom prst="roundRect">
+            <a:avLst>
+              <a:gd name="adj" fmla="val 8000"/>
+            </a:avLst>
           </a:prstGeom>
           <a:solidFill>
-            <a:srgbClr val="059669"/>
+            <a:srgbClr val="ECFDF5"/>
           </a:solidFill>
-          <a:ln/>
+          <a:ln w="12700">
+            <a:solidFill>
+              <a:srgbClr val="E2E8F0"/>
+            </a:solidFill>
+            <a:prstDash val="solid"/>
+          </a:ln>
         </p:spPr>
         <p:txBody>
           <a:bodyPr/>
@@ -7192,6 +7728,30 @@
           </a:p>
         </p:txBody>
       </p:sp>
+      <p:pic>
+        <p:nvPicPr>
+          <p:cNvPr id="27" name="Image 0" descr="icons/database.png"/>
+          <p:cNvPicPr>
+            <a:picLocks noChangeAspect="1"/>
+          </p:cNvPicPr>
+          <p:nvPr/>
+        </p:nvPicPr>
+        <p:blipFill>
+          <a:blip r:embed="rId3"/>
+          <a:stretch>
+            <a:fillRect/>
+          </a:stretch>
+        </p:blipFill>
+        <p:spPr>
+          <a:xfrm>
+            <a:off x="800100" y="845820"/>
+            <a:ext cx="685800" cy="685800"/>
+          </a:xfrm>
+          <a:prstGeom prst="rect">
+            <a:avLst/>
+          </a:prstGeom>
+        </p:spPr>
+      </p:pic>
       <p:sp>
         <p:nvSpPr>
           <p:cNvPr id="3" name="Text 1"/>
@@ -7200,8 +7760,8 @@
         </p:nvSpPr>
         <p:spPr>
           <a:xfrm>
-            <a:off x="457200" y="621792"/>
-            <a:ext cx="10058400" cy="777240"/>
+            <a:off x="2194560" y="621792"/>
+            <a:ext cx="8321040" cy="777240"/>
           </a:xfrm>
           <a:prstGeom prst="rect">
             <a:avLst/>
@@ -7239,8 +7799,8 @@
         </p:nvSpPr>
         <p:spPr>
           <a:xfrm>
-            <a:off x="457200" y="1325880"/>
-            <a:ext cx="10058400" cy="457200"/>
+            <a:off x="2194560" y="1325880"/>
+            <a:ext cx="8321040" cy="457200"/>
           </a:xfrm>
           <a:prstGeom prst="rect">
             <a:avLst/>

</xml_diff>

<commit_message>
Add a second Design slide for the BRD's additional fields
The first Design slide is scoped to fields carried over from Create
Change Request. The BRD's "additional fields" (JOB, Serial#, Lot#, Top
Level PN, Sub Assembly, Part) aren't a carryover - they're new fields
the CMR form needs on its own - so they get their own slide right
after the first Design slide, same table style: JOB/Serial#/Lot#/Part
already built, Top Level PN and Sub Assembly flagged as not yet built
(matching task-list.md's note on those two).

Built on top of the user's own manual edits to the deck since the last
push (Current CMR Process, field-mapping table, Staging, Launch, Test,
and Optimize slides all now have their real content filled in).

Co-Authored-By: Claude Sonnet 5 <noreply@anthropic.com>
Claude-Session: https://claude.ai/code/session_01Ar9F593p16uUzvwAJdxbpf
</commit_message>
<xml_diff>
--- a/docs/presentations/eCMRs_plan.pptx
+++ b/docs/presentations/eCMRs_plan.pptx
@@ -14,6 +14,7 @@
     <p:sldId id="267" r:id="rId18"/>
     <p:sldId id="266" r:id="rId5"/>
     <p:sldId id="259" r:id="rId6"/>
+    <p:sldId id="268" r:id="rId19"/>
     <p:sldId id="260" r:id="rId7"/>
     <p:sldId id="261" r:id="rId8"/>
     <p:sldId id="263" r:id="rId9"/>
@@ -2952,6 +2953,1038 @@
               <a:t> that can be used to reference the working CMR</a:t>
             </a:r>
             <a:endParaRPr lang="en-US" sz="1500" dirty="0"/>
+          </a:p>
+        </p:txBody>
+      </p:sp>
+    </p:spTree>
+  </p:cSld>
+  <p:clrMapOvr>
+    <a:masterClrMapping/>
+  </p:clrMapOvr>
+</p:sld>
+</file>
+
+<file path=ppt/slides/slide13.xml><?xml version="1.0" encoding="utf-8"?>
+<p:sld xmlns:a="http://schemas.openxmlformats.org/drawingml/2006/main" xmlns:r="http://schemas.openxmlformats.org/officeDocument/2006/relationships" xmlns:p="http://schemas.openxmlformats.org/presentationml/2006/main">
+  <p:cSld name="Slide 4">
+    <p:bg>
+      <p:bgPr>
+        <a:solidFill>
+          <a:srgbClr val="F8FAFC"/>
+        </a:solidFill>
+        <a:effectLst/>
+      </p:bgPr>
+    </p:bg>
+    <p:spTree>
+      <p:nvGrpSpPr>
+        <p:cNvPr id="1" name=""/>
+        <p:cNvGrpSpPr/>
+        <p:nvPr/>
+      </p:nvGrpSpPr>
+      <p:grpSpPr>
+        <a:xfrm>
+          <a:off x="0" y="0"/>
+          <a:ext cx="0" cy="0"/>
+          <a:chOff x="0" y="0"/>
+          <a:chExt cx="0" cy="0"/>
+        </a:xfrm>
+      </p:grpSpPr>
+      <p:sp>
+        <p:nvSpPr>
+          <p:cNvPr id="2" name="Text 0"/>
+          <p:cNvSpPr/>
+          <p:nvPr/>
+        </p:nvSpPr>
+        <p:spPr>
+          <a:xfrm>
+            <a:off x="457200" y="502920"/>
+            <a:ext cx="9539935" cy="685800"/>
+          </a:xfrm>
+          <a:prstGeom prst="rect">
+            <a:avLst/>
+          </a:prstGeom>
+          <a:noFill/>
+          <a:ln/>
+        </p:spPr>
+        <p:txBody>
+          <a:bodyPr wrap="square" lIns="0" tIns="0" rIns="0" bIns="0" rtlCol="0" anchor="t"/>
+          <a:lstStyle/>
+          <a:p>
+            <a:pPr marL="0" indent="0" algn="l">
+              <a:buNone/>
+            </a:pPr>
+            <a:r>
+              <a:rPr lang="en-US" sz="3400" b="1" dirty="0">
+                <a:solidFill>
+                  <a:srgbClr val="0F172A"/>
+                </a:solidFill>
+                <a:latin typeface="Cambria" pitchFamily="34" charset="0"/>
+                <a:ea typeface="Cambria" pitchFamily="34" charset="-122"/>
+                <a:cs typeface="Cambria" pitchFamily="34" charset="-120"/>
+              </a:rPr>
+              <a:t>Design</a:t>
+            </a:r>
+            <a:endParaRPr lang="en-US" sz="3400" dirty="0"/>
+          </a:p>
+        </p:txBody>
+      </p:sp>
+      <p:sp>
+        <p:nvSpPr>
+          <p:cNvPr id="3" name="Text 1"/>
+          <p:cNvSpPr/>
+          <p:nvPr/>
+        </p:nvSpPr>
+        <p:spPr>
+          <a:xfrm>
+            <a:off x="457200" y="1216152"/>
+            <a:ext cx="9539935" cy="640080"/>
+          </a:xfrm>
+          <a:prstGeom prst="rect">
+            <a:avLst/>
+          </a:prstGeom>
+          <a:noFill/>
+          <a:ln/>
+        </p:spPr>
+        <p:txBody>
+          <a:bodyPr wrap="square" lIns="0" tIns="0" rIns="0" bIns="0" rtlCol="0" anchor="t"/>
+          <a:lstStyle/>
+          <a:p>
+            <a:pPr marL="0" indent="0" algn="l">
+              <a:buNone/>
+            </a:pPr>
+            <a:r>
+              <a:rPr lang="en-US" sz="1600" dirty="0">
+                <a:solidFill>
+                  <a:srgbClr val="64748B"/>
+                </a:solidFill>
+                <a:latin typeface="Calibri" pitchFamily="34" charset="0"/>
+                <a:ea typeface="Calibri" pitchFamily="34" charset="-122"/>
+                <a:cs typeface="Calibri" pitchFamily="34" charset="-120"/>
+              </a:rPr>
+              <a:t>Fields the BRD calls out as needing their own field — not part of the Create Change Request carryover.</a:t>
+            </a:r>
+            <a:endParaRPr lang="en-US" sz="1600" dirty="0"/>
+          </a:p>
+        </p:txBody>
+      </p:sp>
+      <p:sp>
+        <p:nvSpPr>
+          <p:cNvPr id="4" name="Shape 2"/>
+          <p:cNvSpPr/>
+          <p:nvPr/>
+        </p:nvSpPr>
+        <p:spPr>
+          <a:xfrm>
+            <a:off x="10362895" y="502920"/>
+            <a:ext cx="1371600" cy="1371600"/>
+          </a:xfrm>
+          <a:prstGeom prst="roundRect">
+            <a:avLst>
+              <a:gd name="adj" fmla="val 8000"/>
+            </a:avLst>
+          </a:prstGeom>
+          <a:solidFill>
+            <a:srgbClr val="ECFDF5"/>
+          </a:solidFill>
+          <a:ln w="12700">
+            <a:solidFill>
+              <a:srgbClr val="E2E8F0"/>
+            </a:solidFill>
+            <a:prstDash val="solid"/>
+          </a:ln>
+        </p:spPr>
+        <p:txBody>
+          <a:bodyPr/>
+          <a:lstStyle/>
+          <a:p>
+            <a:endParaRPr lang="en-US" dirty="0"/>
+          </a:p>
+        </p:txBody>
+      </p:sp>
+      <p:pic>
+        <p:nvPicPr>
+          <p:cNvPr id="5" name="Image 0" descr="icons/pencil.png"/>
+          <p:cNvPicPr>
+            <a:picLocks noChangeAspect="1"/>
+          </p:cNvPicPr>
+          <p:nvPr/>
+        </p:nvPicPr>
+        <p:blipFill>
+          <a:blip r:embed="rId3"/>
+          <a:stretch>
+            <a:fillRect/>
+          </a:stretch>
+        </p:blipFill>
+        <p:spPr>
+          <a:xfrm>
+            <a:off x="10705795" y="845820"/>
+            <a:ext cx="685800" cy="685800"/>
+          </a:xfrm>
+          <a:prstGeom prst="rect">
+            <a:avLst/>
+          </a:prstGeom>
+        </p:spPr>
+      </p:pic>
+      <p:sp>
+        <p:nvSpPr>
+          <p:cNvPr id="6" name="Shape 3"/>
+          <p:cNvSpPr/>
+          <p:nvPr/>
+        </p:nvSpPr>
+        <p:spPr>
+          <a:xfrm>
+            <a:off x="457200" y="2148840"/>
+            <a:ext cx="11277295" cy="4251960"/>
+          </a:xfrm>
+          <a:prstGeom prst="roundRect">
+            <a:avLst>
+              <a:gd name="adj" fmla="val 2581"/>
+            </a:avLst>
+          </a:prstGeom>
+          <a:solidFill>
+            <a:srgbClr val="FFFFFF"/>
+          </a:solidFill>
+          <a:ln w="12700">
+            <a:solidFill>
+              <a:srgbClr val="E2E8F0"/>
+            </a:solidFill>
+            <a:prstDash val="solid"/>
+          </a:ln>
+          <a:effectLst>
+            <a:outerShdw blurRad="152400" dist="38100" dir="5400000" algn="bl" rotWithShape="0">
+              <a:srgbClr val="1E293B">
+                <a:alpha val="8000"/>
+              </a:srgbClr>
+            </a:outerShdw>
+          </a:effectLst>
+        </p:spPr>
+        <p:txBody>
+          <a:bodyPr/>
+          <a:lstStyle/>
+          <a:p>
+            <a:endParaRPr lang="en-US" dirty="0"/>
+          </a:p>
+        </p:txBody>
+      </p:sp>
+      <p:sp>
+        <p:nvSpPr>
+          <p:cNvPr id="7" name="Text 4"/>
+          <p:cNvSpPr/>
+          <p:nvPr/>
+        </p:nvSpPr>
+        <p:spPr>
+          <a:xfrm>
+            <a:off x="822960" y="2514600"/>
+            <a:ext cx="9144000" cy="365760"/>
+          </a:xfrm>
+          <a:prstGeom prst="rect">
+            <a:avLst/>
+          </a:prstGeom>
+          <a:noFill/>
+          <a:ln/>
+        </p:spPr>
+        <p:txBody>
+          <a:bodyPr wrap="square" lIns="0" tIns="0" rIns="0" bIns="0" rtlCol="0" anchor="t"/>
+          <a:lstStyle/>
+          <a:p>
+            <a:pPr marL="0" indent="0" algn="l">
+              <a:buNone/>
+            </a:pPr>
+            <a:r>
+              <a:rPr lang="en-US" sz="1500" b="1" dirty="0">
+                <a:solidFill>
+                  <a:srgbClr val="059669"/>
+                </a:solidFill>
+                <a:latin typeface="Calibri" pitchFamily="34" charset="0"/>
+                <a:ea typeface="Calibri" pitchFamily="34" charset="-122"/>
+                <a:cs typeface="Calibri" pitchFamily="34" charset="-120"/>
+              </a:rPr>
+              <a:t>Additional fields — new, not carried over from Create Change Request</a:t>
+            </a:r>
+            <a:endParaRPr lang="en-US" sz="1500" dirty="0"/>
+          </a:p>
+        </p:txBody>
+      </p:sp>
+      <p:sp>
+        <p:nvSpPr>
+          <p:cNvPr id="8" name="Text 5"/>
+          <p:cNvSpPr/>
+          <p:nvPr/>
+        </p:nvSpPr>
+        <p:spPr>
+          <a:xfrm>
+            <a:off x="822960" y="2926080"/>
+            <a:ext cx="3163733" cy="347472"/>
+          </a:xfrm>
+          <a:prstGeom prst="rect">
+            <a:avLst/>
+          </a:prstGeom>
+          <a:noFill/>
+          <a:ln/>
+        </p:spPr>
+        <p:txBody>
+          <a:bodyPr wrap="square" lIns="0" tIns="0" rIns="0" bIns="0" rtlCol="0" anchor="ctr"/>
+          <a:lstStyle/>
+          <a:p>
+            <a:pPr marL="0" indent="0">
+              <a:buNone/>
+            </a:pPr>
+            <a:r>
+              <a:rPr lang="en-US" sz="1250" b="1" dirty="0">
+                <a:solidFill>
+                  <a:srgbClr val="64748B"/>
+                </a:solidFill>
+                <a:latin typeface="Calibri" pitchFamily="34" charset="0"/>
+                <a:ea typeface="Calibri" pitchFamily="34" charset="-122"/>
+                <a:cs typeface="Calibri" pitchFamily="34" charset="-120"/>
+              </a:rPr>
+              <a:t>New field</a:t>
+            </a:r>
+            <a:endParaRPr lang="en-US" sz="1250" dirty="0"/>
+          </a:p>
+        </p:txBody>
+      </p:sp>
+      <p:sp>
+        <p:nvSpPr>
+          <p:cNvPr id="9" name="Text 6"/>
+          <p:cNvSpPr/>
+          <p:nvPr/>
+        </p:nvSpPr>
+        <p:spPr>
+          <a:xfrm>
+            <a:off x="3986693" y="2926080"/>
+            <a:ext cx="7382043" cy="347472"/>
+          </a:xfrm>
+          <a:prstGeom prst="rect">
+            <a:avLst/>
+          </a:prstGeom>
+          <a:noFill/>
+          <a:ln/>
+        </p:spPr>
+        <p:txBody>
+          <a:bodyPr wrap="square" lIns="0" tIns="0" rIns="0" bIns="0" rtlCol="0" anchor="ctr"/>
+          <a:lstStyle/>
+          <a:p>
+            <a:pPr marL="0" indent="0">
+              <a:buNone/>
+            </a:pPr>
+            <a:r>
+              <a:rPr lang="en-US" sz="1250" b="1" dirty="0">
+                <a:solidFill>
+                  <a:srgbClr val="64748B"/>
+                </a:solidFill>
+                <a:latin typeface="Calibri" pitchFamily="34" charset="0"/>
+                <a:ea typeface="Calibri" pitchFamily="34" charset="-122"/>
+                <a:cs typeface="Calibri" pitchFamily="34" charset="-120"/>
+              </a:rPr>
+              <a:t>What it is</a:t>
+            </a:r>
+            <a:endParaRPr lang="en-US" sz="1250" dirty="0"/>
+          </a:p>
+        </p:txBody>
+      </p:sp>
+      <p:sp>
+        <p:nvSpPr>
+          <p:cNvPr id="10" name="Shape 7"/>
+          <p:cNvSpPr/>
+          <p:nvPr/>
+        </p:nvSpPr>
+        <p:spPr>
+          <a:xfrm>
+            <a:off x="822960" y="3328416"/>
+            <a:ext cx="10545775" cy="0"/>
+          </a:xfrm>
+          <a:prstGeom prst="line">
+            <a:avLst/>
+          </a:prstGeom>
+          <a:noFill/>
+          <a:ln w="12700">
+            <a:solidFill>
+              <a:srgbClr val="E2E8F0"/>
+            </a:solidFill>
+            <a:prstDash val="solid"/>
+          </a:ln>
+        </p:spPr>
+        <p:txBody>
+          <a:bodyPr/>
+          <a:lstStyle/>
+          <a:p>
+            <a:endParaRPr lang="en-US" dirty="0"/>
+          </a:p>
+        </p:txBody>
+      </p:sp>
+      <p:sp>
+        <p:nvSpPr>
+          <p:cNvPr id="11" name="Shape 8"/>
+          <p:cNvSpPr/>
+          <p:nvPr/>
+        </p:nvSpPr>
+        <p:spPr>
+          <a:xfrm>
+            <a:off x="822960" y="3419856"/>
+            <a:ext cx="10545775" cy="400000"/>
+          </a:xfrm>
+          <a:prstGeom prst="rect">
+            <a:avLst/>
+          </a:prstGeom>
+          <a:solidFill>
+            <a:srgbClr val="ECFDF5"/>
+          </a:solidFill>
+          <a:ln/>
+        </p:spPr>
+        <p:txBody>
+          <a:bodyPr/>
+          <a:lstStyle/>
+          <a:p>
+            <a:endParaRPr lang="en-US" dirty="0"/>
+          </a:p>
+        </p:txBody>
+      </p:sp>
+      <p:sp>
+        <p:nvSpPr>
+          <p:cNvPr id="12" name="Text 9"/>
+          <p:cNvSpPr/>
+          <p:nvPr/>
+        </p:nvSpPr>
+        <p:spPr>
+          <a:xfrm>
+            <a:off x="932688" y="3419856"/>
+            <a:ext cx="3054005" cy="400000"/>
+          </a:xfrm>
+          <a:prstGeom prst="rect">
+            <a:avLst/>
+          </a:prstGeom>
+          <a:noFill/>
+          <a:ln/>
+        </p:spPr>
+        <p:txBody>
+          <a:bodyPr wrap="square" lIns="0" tIns="0" rIns="0" bIns="0" rtlCol="0" anchor="ctr"/>
+          <a:lstStyle/>
+          <a:p>
+            <a:pPr marL="0" indent="0">
+              <a:buNone/>
+            </a:pPr>
+            <a:r>
+              <a:rPr lang="en-US" sz="1300" b="1" dirty="0">
+                <a:solidFill>
+                  <a:srgbClr val="0F172A"/>
+                </a:solidFill>
+                <a:latin typeface="Calibri" pitchFamily="34" charset="0"/>
+                <a:ea typeface="Calibri" pitchFamily="34" charset="-122"/>
+                <a:cs typeface="Calibri" pitchFamily="34" charset="-120"/>
+              </a:rPr>
+              <a:t>JOB (job_num)</a:t>
+            </a:r>
+            <a:endParaRPr lang="en-US" sz="1300" dirty="0"/>
+          </a:p>
+        </p:txBody>
+      </p:sp>
+      <p:sp>
+        <p:nvSpPr>
+          <p:cNvPr id="13" name="Text 10"/>
+          <p:cNvSpPr/>
+          <p:nvPr/>
+        </p:nvSpPr>
+        <p:spPr>
+          <a:xfrm>
+            <a:off x="3986693" y="3419856"/>
+            <a:ext cx="7290603" cy="400000"/>
+          </a:xfrm>
+          <a:prstGeom prst="rect">
+            <a:avLst/>
+          </a:prstGeom>
+          <a:noFill/>
+          <a:ln/>
+        </p:spPr>
+        <p:txBody>
+          <a:bodyPr wrap="square" lIns="0" tIns="0" rIns="0" bIns="0" rtlCol="0" anchor="ctr"/>
+          <a:lstStyle/>
+          <a:p>
+            <a:pPr marL="0" indent="0">
+              <a:buNone/>
+            </a:pPr>
+            <a:r>
+              <a:rPr lang="en-US" sz="1300" dirty="0">
+                <a:solidFill>
+                  <a:srgbClr val="0F172A"/>
+                </a:solidFill>
+                <a:latin typeface="Calibri" pitchFamily="34" charset="0"/>
+                <a:ea typeface="Calibri" pitchFamily="34" charset="-122"/>
+                <a:cs typeface="Calibri" pitchFamily="34" charset="-120"/>
+              </a:rPr>
+              <a:t>Combo lookup (SLMatltrans/RefNum) — already built and on the form.</a:t>
+            </a:r>
+            <a:endParaRPr lang="en-US" sz="1300" dirty="0"/>
+          </a:p>
+        </p:txBody>
+      </p:sp>
+      <p:sp>
+        <p:nvSpPr>
+          <p:cNvPr id="14" name="Shape 11"/>
+          <p:cNvSpPr/>
+          <p:nvPr/>
+        </p:nvSpPr>
+        <p:spPr>
+          <a:xfrm>
+            <a:off x="822960" y="3819856"/>
+            <a:ext cx="10545775" cy="0"/>
+          </a:xfrm>
+          <a:prstGeom prst="line">
+            <a:avLst/>
+          </a:prstGeom>
+          <a:noFill/>
+          <a:ln w="9525">
+            <a:solidFill>
+              <a:srgbClr val="E2E8F0"/>
+            </a:solidFill>
+            <a:prstDash val="solid"/>
+          </a:ln>
+        </p:spPr>
+        <p:txBody>
+          <a:bodyPr/>
+          <a:lstStyle/>
+          <a:p>
+            <a:endParaRPr lang="en-US" dirty="0"/>
+          </a:p>
+        </p:txBody>
+      </p:sp>
+      <p:sp>
+        <p:nvSpPr>
+          <p:cNvPr id="27" name="Text 24"/>
+          <p:cNvSpPr/>
+          <p:nvPr/>
+        </p:nvSpPr>
+        <p:spPr>
+          <a:xfrm>
+            <a:off x="932688" y="3819856"/>
+            <a:ext cx="3054005" cy="400000"/>
+          </a:xfrm>
+          <a:prstGeom prst="rect">
+            <a:avLst/>
+          </a:prstGeom>
+          <a:noFill/>
+          <a:ln/>
+        </p:spPr>
+        <p:txBody>
+          <a:bodyPr wrap="square" lIns="0" tIns="0" rIns="0" bIns="0" rtlCol="0" anchor="ctr"/>
+          <a:lstStyle/>
+          <a:p>
+            <a:pPr marL="0" indent="0">
+              <a:buNone/>
+            </a:pPr>
+            <a:r>
+              <a:rPr lang="en-US" sz="1300" b="1" dirty="0">
+                <a:solidFill>
+                  <a:srgbClr val="0F172A"/>
+                </a:solidFill>
+                <a:latin typeface="Calibri" pitchFamily="34" charset="0"/>
+                <a:ea typeface="Calibri" pitchFamily="34" charset="-122"/>
+                <a:cs typeface="Calibri" pitchFamily="34" charset="-120"/>
+              </a:rPr>
+              <a:t>Serial # (serial_num)</a:t>
+            </a:r>
+            <a:endParaRPr lang="en-US" sz="1300" dirty="0"/>
+          </a:p>
+        </p:txBody>
+      </p:sp>
+      <p:sp>
+        <p:nvSpPr>
+          <p:cNvPr id="28" name="Text 25"/>
+          <p:cNvSpPr/>
+          <p:nvPr/>
+        </p:nvSpPr>
+        <p:spPr>
+          <a:xfrm>
+            <a:off x="3986693" y="3819856"/>
+            <a:ext cx="7290603" cy="400000"/>
+          </a:xfrm>
+          <a:prstGeom prst="rect">
+            <a:avLst/>
+          </a:prstGeom>
+          <a:noFill/>
+          <a:ln/>
+        </p:spPr>
+        <p:txBody>
+          <a:bodyPr wrap="square" lIns="0" tIns="0" rIns="0" bIns="0" rtlCol="0" anchor="ctr"/>
+          <a:lstStyle/>
+          <a:p>
+            <a:pPr marL="0" indent="0">
+              <a:buNone/>
+            </a:pPr>
+            <a:r>
+              <a:rPr lang="en-US" sz="1300" dirty="0">
+                <a:solidFill>
+                  <a:srgbClr val="0F172A"/>
+                </a:solidFill>
+                <a:latin typeface="Calibri" pitchFamily="34" charset="0"/>
+                <a:ea typeface="Calibri" pitchFamily="34" charset="-122"/>
+                <a:cs typeface="Calibri" pitchFamily="34" charset="-120"/>
+              </a:rPr>
+              <a:t>Free-text field (char, 50) — already built; previously just copied into the Notes section on the legacy 3-form process.</a:t>
+            </a:r>
+            <a:endParaRPr lang="en-US" sz="1300" dirty="0"/>
+          </a:p>
+        </p:txBody>
+      </p:sp>
+      <p:sp>
+        <p:nvSpPr>
+          <p:cNvPr id="29" name="Shape 26"/>
+          <p:cNvSpPr/>
+          <p:nvPr/>
+        </p:nvSpPr>
+        <p:spPr>
+          <a:xfrm>
+            <a:off x="822960" y="4219856"/>
+            <a:ext cx="10545775" cy="0"/>
+          </a:xfrm>
+          <a:prstGeom prst="line">
+            <a:avLst/>
+          </a:prstGeom>
+          <a:noFill/>
+          <a:ln w="9525">
+            <a:solidFill>
+              <a:srgbClr val="E2E8F0"/>
+            </a:solidFill>
+            <a:prstDash val="solid"/>
+          </a:ln>
+        </p:spPr>
+        <p:txBody>
+          <a:bodyPr/>
+          <a:lstStyle/>
+          <a:p>
+            <a:endParaRPr lang="en-US" dirty="0"/>
+          </a:p>
+        </p:txBody>
+      </p:sp>
+      <p:sp>
+        <p:nvSpPr>
+          <p:cNvPr id="15" name="Text 12"/>
+          <p:cNvSpPr/>
+          <p:nvPr/>
+        </p:nvSpPr>
+        <p:spPr>
+          <a:xfrm>
+            <a:off x="932688" y="4219856"/>
+            <a:ext cx="3054005" cy="400000"/>
+          </a:xfrm>
+          <a:prstGeom prst="rect">
+            <a:avLst/>
+          </a:prstGeom>
+          <a:noFill/>
+          <a:ln/>
+        </p:spPr>
+        <p:txBody>
+          <a:bodyPr wrap="square" lIns="0" tIns="0" rIns="0" bIns="0" rtlCol="0" anchor="ctr"/>
+          <a:lstStyle/>
+          <a:p>
+            <a:pPr marL="0" indent="0">
+              <a:buNone/>
+            </a:pPr>
+            <a:r>
+              <a:rPr lang="en-US" sz="1300" b="1" dirty="0">
+                <a:solidFill>
+                  <a:srgbClr val="0F172A"/>
+                </a:solidFill>
+                <a:latin typeface="Calibri" pitchFamily="34" charset="0"/>
+                <a:ea typeface="Calibri" pitchFamily="34" charset="-122"/>
+                <a:cs typeface="Calibri" pitchFamily="34" charset="-120"/>
+              </a:rPr>
+              <a:t>Lot # (lot_num)</a:t>
+            </a:r>
+            <a:endParaRPr lang="en-US" sz="1300" dirty="0"/>
+          </a:p>
+        </p:txBody>
+      </p:sp>
+      <p:sp>
+        <p:nvSpPr>
+          <p:cNvPr id="16" name="Text 13"/>
+          <p:cNvSpPr/>
+          <p:nvPr/>
+        </p:nvSpPr>
+        <p:spPr>
+          <a:xfrm>
+            <a:off x="3986693" y="4219856"/>
+            <a:ext cx="7290603" cy="400000"/>
+          </a:xfrm>
+          <a:prstGeom prst="rect">
+            <a:avLst/>
+          </a:prstGeom>
+          <a:noFill/>
+          <a:ln/>
+        </p:spPr>
+        <p:txBody>
+          <a:bodyPr wrap="square" lIns="0" tIns="0" rIns="0" bIns="0" rtlCol="0" anchor="ctr"/>
+          <a:lstStyle/>
+          <a:p>
+            <a:pPr marL="0" indent="0">
+              <a:buNone/>
+            </a:pPr>
+            <a:r>
+              <a:rPr lang="en-US" sz="1300" dirty="0">
+                <a:solidFill>
+                  <a:srgbClr val="0F172A"/>
+                </a:solidFill>
+                <a:latin typeface="Calibri" pitchFamily="34" charset="0"/>
+                <a:ea typeface="Calibri" pitchFamily="34" charset="-122"/>
+                <a:cs typeface="Calibri" pitchFamily="34" charset="-120"/>
+              </a:rPr>
+              <a:t>Free-text field (char, 50) — already built, same as Serial #.</a:t>
+            </a:r>
+            <a:endParaRPr lang="en-US" sz="1300" dirty="0"/>
+          </a:p>
+        </p:txBody>
+      </p:sp>
+      <p:sp>
+        <p:nvSpPr>
+          <p:cNvPr id="17" name="Shape 14"/>
+          <p:cNvSpPr/>
+          <p:nvPr/>
+        </p:nvSpPr>
+        <p:spPr>
+          <a:xfrm>
+            <a:off x="822960" y="4619856"/>
+            <a:ext cx="10545775" cy="0"/>
+          </a:xfrm>
+          <a:prstGeom prst="line">
+            <a:avLst/>
+          </a:prstGeom>
+          <a:noFill/>
+          <a:ln w="9525">
+            <a:solidFill>
+              <a:srgbClr val="E2E8F0"/>
+            </a:solidFill>
+            <a:prstDash val="solid"/>
+          </a:ln>
+        </p:spPr>
+        <p:txBody>
+          <a:bodyPr/>
+          <a:lstStyle/>
+          <a:p>
+            <a:endParaRPr lang="en-US" dirty="0"/>
+          </a:p>
+        </p:txBody>
+      </p:sp>
+      <p:sp>
+        <p:nvSpPr>
+          <p:cNvPr id="18" name="Text 15"/>
+          <p:cNvSpPr/>
+          <p:nvPr/>
+        </p:nvSpPr>
+        <p:spPr>
+          <a:xfrm>
+            <a:off x="932688" y="4619856"/>
+            <a:ext cx="3054005" cy="400000"/>
+          </a:xfrm>
+          <a:prstGeom prst="rect">
+            <a:avLst/>
+          </a:prstGeom>
+          <a:noFill/>
+          <a:ln/>
+        </p:spPr>
+        <p:txBody>
+          <a:bodyPr wrap="square" lIns="0" tIns="0" rIns="0" bIns="0" rtlCol="0" anchor="ctr"/>
+          <a:lstStyle/>
+          <a:p>
+            <a:pPr marL="0" indent="0">
+              <a:buNone/>
+            </a:pPr>
+            <a:r>
+              <a:rPr lang="en-US" sz="1300" b="1" dirty="0">
+                <a:solidFill>
+                  <a:srgbClr val="0F172A"/>
+                </a:solidFill>
+                <a:latin typeface="Calibri" pitchFamily="34" charset="0"/>
+                <a:ea typeface="Calibri" pitchFamily="34" charset="-122"/>
+                <a:cs typeface="Calibri" pitchFamily="34" charset="-120"/>
+              </a:rPr>
+              <a:t>Top Level PN</a:t>
+            </a:r>
+            <a:endParaRPr lang="en-US" sz="1300" dirty="0"/>
+          </a:p>
+        </p:txBody>
+      </p:sp>
+      <p:sp>
+        <p:nvSpPr>
+          <p:cNvPr id="19" name="Text 16"/>
+          <p:cNvSpPr/>
+          <p:nvPr/>
+        </p:nvSpPr>
+        <p:spPr>
+          <a:xfrm>
+            <a:off x="3986693" y="4619856"/>
+            <a:ext cx="7290603" cy="400000"/>
+          </a:xfrm>
+          <a:prstGeom prst="rect">
+            <a:avLst/>
+          </a:prstGeom>
+          <a:noFill/>
+          <a:ln/>
+        </p:spPr>
+        <p:txBody>
+          <a:bodyPr wrap="square" lIns="0" tIns="0" rIns="0" bIns="0" rtlCol="0" anchor="ctr"/>
+          <a:lstStyle/>
+          <a:p>
+            <a:pPr marL="0" indent="0">
+              <a:buNone/>
+            </a:pPr>
+            <a:r>
+              <a:rPr lang="en-US" sz="1300" dirty="0">
+                <a:solidFill>
+                  <a:srgbClr val="0F172A"/>
+                </a:solidFill>
+                <a:latin typeface="Calibri" pitchFamily="34" charset="0"/>
+                <a:ea typeface="Calibri" pitchFamily="34" charset="-122"/>
+                <a:cs typeface="Calibri" pitchFamily="34" charset="-120"/>
+              </a:rPr>
+              <a:t>Not yet built — needs a new column, IDO property, and form control.</a:t>
+            </a:r>
+            <a:endParaRPr lang="en-US" sz="1300" dirty="0"/>
+          </a:p>
+        </p:txBody>
+      </p:sp>
+      <p:sp>
+        <p:nvSpPr>
+          <p:cNvPr id="20" name="Shape 17"/>
+          <p:cNvSpPr/>
+          <p:nvPr/>
+        </p:nvSpPr>
+        <p:spPr>
+          <a:xfrm>
+            <a:off x="822960" y="5019856"/>
+            <a:ext cx="10545775" cy="0"/>
+          </a:xfrm>
+          <a:prstGeom prst="line">
+            <a:avLst/>
+          </a:prstGeom>
+          <a:noFill/>
+          <a:ln w="9525">
+            <a:solidFill>
+              <a:srgbClr val="E2E8F0"/>
+            </a:solidFill>
+            <a:prstDash val="solid"/>
+          </a:ln>
+        </p:spPr>
+        <p:txBody>
+          <a:bodyPr/>
+          <a:lstStyle/>
+          <a:p>
+            <a:endParaRPr lang="en-US" dirty="0"/>
+          </a:p>
+        </p:txBody>
+      </p:sp>
+      <p:sp>
+        <p:nvSpPr>
+          <p:cNvPr id="21" name="Text 18"/>
+          <p:cNvSpPr/>
+          <p:nvPr/>
+        </p:nvSpPr>
+        <p:spPr>
+          <a:xfrm>
+            <a:off x="932688" y="5019856"/>
+            <a:ext cx="3054005" cy="400000"/>
+          </a:xfrm>
+          <a:prstGeom prst="rect">
+            <a:avLst/>
+          </a:prstGeom>
+          <a:noFill/>
+          <a:ln/>
+        </p:spPr>
+        <p:txBody>
+          <a:bodyPr wrap="square" lIns="0" tIns="0" rIns="0" bIns="0" rtlCol="0" anchor="ctr"/>
+          <a:lstStyle/>
+          <a:p>
+            <a:pPr marL="0" indent="0">
+              <a:buNone/>
+            </a:pPr>
+            <a:r>
+              <a:rPr lang="en-US" sz="1300" b="1" dirty="0">
+                <a:solidFill>
+                  <a:srgbClr val="0F172A"/>
+                </a:solidFill>
+                <a:latin typeface="Calibri" pitchFamily="34" charset="0"/>
+                <a:ea typeface="Calibri" pitchFamily="34" charset="-122"/>
+                <a:cs typeface="Calibri" pitchFamily="34" charset="-120"/>
+              </a:rPr>
+              <a:t>Sub Assembly</a:t>
+            </a:r>
+            <a:endParaRPr lang="en-US" sz="1300" dirty="0"/>
+          </a:p>
+        </p:txBody>
+      </p:sp>
+      <p:sp>
+        <p:nvSpPr>
+          <p:cNvPr id="22" name="Text 19"/>
+          <p:cNvSpPr/>
+          <p:nvPr/>
+        </p:nvSpPr>
+        <p:spPr>
+          <a:xfrm>
+            <a:off x="3986693" y="5019856"/>
+            <a:ext cx="7290603" cy="400000"/>
+          </a:xfrm>
+          <a:prstGeom prst="rect">
+            <a:avLst/>
+          </a:prstGeom>
+          <a:noFill/>
+          <a:ln/>
+        </p:spPr>
+        <p:txBody>
+          <a:bodyPr wrap="square" lIns="0" tIns="0" rIns="0" bIns="0" rtlCol="0" anchor="ctr"/>
+          <a:lstStyle/>
+          <a:p>
+            <a:pPr marL="0" indent="0">
+              <a:buNone/>
+            </a:pPr>
+            <a:r>
+              <a:rPr lang="en-US" sz="1300" dirty="0">
+                <a:solidFill>
+                  <a:srgbClr val="0F172A"/>
+                </a:solidFill>
+                <a:latin typeface="Calibri" pitchFamily="34" charset="0"/>
+                <a:ea typeface="Calibri" pitchFamily="34" charset="-122"/>
+                <a:cs typeface="Calibri" pitchFamily="34" charset="-120"/>
+              </a:rPr>
+              <a:t>Not yet built — open question whether this is the same concept as the existing next_assy_item (Next Level Assembly) or a distinct field.</a:t>
+            </a:r>
+            <a:endParaRPr lang="en-US" sz="1300" dirty="0"/>
+          </a:p>
+        </p:txBody>
+      </p:sp>
+      <p:sp>
+        <p:nvSpPr>
+          <p:cNvPr id="23" name="Shape 20"/>
+          <p:cNvSpPr/>
+          <p:nvPr/>
+        </p:nvSpPr>
+        <p:spPr>
+          <a:xfrm>
+            <a:off x="822960" y="5419856"/>
+            <a:ext cx="10545775" cy="0"/>
+          </a:xfrm>
+          <a:prstGeom prst="line">
+            <a:avLst/>
+          </a:prstGeom>
+          <a:noFill/>
+          <a:ln w="9525">
+            <a:solidFill>
+              <a:srgbClr val="E2E8F0"/>
+            </a:solidFill>
+            <a:prstDash val="solid"/>
+          </a:ln>
+        </p:spPr>
+        <p:txBody>
+          <a:bodyPr/>
+          <a:lstStyle/>
+          <a:p>
+            <a:endParaRPr lang="en-US" dirty="0"/>
+          </a:p>
+        </p:txBody>
+      </p:sp>
+      <p:sp>
+        <p:nvSpPr>
+          <p:cNvPr id="24" name="Text 21"/>
+          <p:cNvSpPr/>
+          <p:nvPr/>
+        </p:nvSpPr>
+        <p:spPr>
+          <a:xfrm>
+            <a:off x="932688" y="5419856"/>
+            <a:ext cx="3054005" cy="400000"/>
+          </a:xfrm>
+          <a:prstGeom prst="rect">
+            <a:avLst/>
+          </a:prstGeom>
+          <a:noFill/>
+          <a:ln/>
+        </p:spPr>
+        <p:txBody>
+          <a:bodyPr wrap="square" lIns="0" tIns="0" rIns="0" bIns="0" rtlCol="0" anchor="ctr"/>
+          <a:lstStyle/>
+          <a:p>
+            <a:pPr marL="0" indent="0">
+              <a:buNone/>
+            </a:pPr>
+            <a:r>
+              <a:rPr lang="en-US" sz="1300" b="1" dirty="0">
+                <a:solidFill>
+                  <a:srgbClr val="0F172A"/>
+                </a:solidFill>
+                <a:latin typeface="Calibri" pitchFamily="34" charset="0"/>
+                <a:ea typeface="Calibri" pitchFamily="34" charset="-122"/>
+                <a:cs typeface="Calibri" pitchFamily="34" charset="-120"/>
+              </a:rPr>
+              <a:t>Part (item)</a:t>
+            </a:r>
+            <a:endParaRPr lang="en-US" sz="1300" dirty="0"/>
+          </a:p>
+        </p:txBody>
+      </p:sp>
+      <p:sp>
+        <p:nvSpPr>
+          <p:cNvPr id="25" name="Text 22"/>
+          <p:cNvSpPr/>
+          <p:nvPr/>
+        </p:nvSpPr>
+        <p:spPr>
+          <a:xfrm>
+            <a:off x="3986693" y="5419856"/>
+            <a:ext cx="7290603" cy="400000"/>
+          </a:xfrm>
+          <a:prstGeom prst="rect">
+            <a:avLst/>
+          </a:prstGeom>
+          <a:noFill/>
+          <a:ln/>
+        </p:spPr>
+        <p:txBody>
+          <a:bodyPr wrap="square" lIns="0" tIns="0" rIns="0" bIns="0" rtlCol="0" anchor="ctr"/>
+          <a:lstStyle/>
+          <a:p>
+            <a:pPr marL="0" indent="0">
+              <a:buNone/>
+            </a:pPr>
+            <a:r>
+              <a:rPr lang="en-US" sz="1300" dirty="0">
+                <a:solidFill>
+                  <a:srgbClr val="0F172A"/>
+                </a:solidFill>
+                <a:latin typeface="Calibri" pitchFamily="34" charset="0"/>
+                <a:ea typeface="Calibri" pitchFamily="34" charset="-122"/>
+                <a:cs typeface="Calibri" pitchFamily="34" charset="-120"/>
+              </a:rPr>
+              <a:t>Already built as the Item combo — covered on the previous Design slide.</a:t>
+            </a:r>
+            <a:endParaRPr lang="en-US" sz="1300" dirty="0"/>
+          </a:p>
+        </p:txBody>
+      </p:sp>
+      <p:sp>
+        <p:nvSpPr>
+          <p:cNvPr id="101" name="Shape 101"/>
+          <p:cNvSpPr/>
+          <p:nvPr/>
+        </p:nvSpPr>
+        <p:spPr>
+          <a:xfrm>
+            <a:off x="822960" y="5819856"/>
+            <a:ext cx="10545775" cy="0"/>
+          </a:xfrm>
+          <a:prstGeom prst="line">
+            <a:avLst/>
+          </a:prstGeom>
+          <a:noFill/>
+          <a:ln w="9525">
+            <a:solidFill>
+              <a:srgbClr val="E2E8F0"/>
+            </a:solidFill>
+            <a:prstDash val="solid"/>
+          </a:ln>
+        </p:spPr>
+        <p:txBody>
+          <a:bodyPr/>
+          <a:lstStyle/>
+          <a:p>
+            <a:endParaRPr lang="en-US" dirty="0"/>
           </a:p>
         </p:txBody>
       </p:sp>

</xml_diff>

<commit_message>
Drop JOB and Part from the Additional Fields slide - already on the form
Same reasoning as the last Design slide cleanup: JOB (job_num) and
Part (item) are already on the real form, so they don't belong on a
"still needs work" list. Down to Serial #, Lot #, Top Level PN, and
Sub Assembly - the four that are actually new. Also fixed the Top
Level PN / Sub Assembly descriptions, which still said "Not yet
built" even though both are built and on the form.

Co-Authored-By: Claude Sonnet 5 <noreply@anthropic.com>
Claude-Session: https://claude.ai/code/session_01Ar9F593p16uUzvwAJdxbpf
</commit_message>
<xml_diff>
--- a/docs/presentations/eCMRs_plan.pptx
+++ b/docs/presentations/eCMRs_plan.pptx
@@ -9808,7 +9808,7 @@
       </p:sp>
       <p:sp>
         <p:nvSpPr>
-          <p:cNvPr id="8" name="Text 5"/>
+          <p:cNvPr id="300" name="Header Field"/>
           <p:cNvSpPr/>
           <p:nvPr/>
         </p:nvSpPr>
@@ -9847,7 +9847,7 @@
       </p:sp>
       <p:sp>
         <p:nvSpPr>
-          <p:cNvPr id="9" name="Text 6"/>
+          <p:cNvPr id="301" name="Header What"/>
           <p:cNvSpPr/>
           <p:nvPr/>
         </p:nvSpPr>
@@ -9886,146 +9886,13 @@
       </p:sp>
       <p:sp>
         <p:nvSpPr>
-          <p:cNvPr id="10" name="Shape 7"/>
+          <p:cNvPr id="302" name="HeaderDivider"/>
           <p:cNvSpPr/>
           <p:nvPr/>
         </p:nvSpPr>
         <p:spPr>
           <a:xfrm>
             <a:off x="822960" y="3328416"/>
-            <a:ext cx="10545775" cy="0"/>
-          </a:xfrm>
-          <a:prstGeom prst="line">
-            <a:avLst/>
-          </a:prstGeom>
-          <a:noFill/>
-          <a:ln w="12700">
-            <a:solidFill>
-              <a:srgbClr val="E5E5E5"/>
-            </a:solidFill>
-            <a:prstDash val="solid"/>
-          </a:ln>
-        </p:spPr>
-        <p:txBody>
-          <a:bodyPr/>
-          <a:lstStyle/>
-          <a:p>
-            <a:endParaRPr lang="en-US" dirty="0"/>
-          </a:p>
-        </p:txBody>
-      </p:sp>
-      <p:sp>
-        <p:nvSpPr>
-          <p:cNvPr id="11" name="Shape 8"/>
-          <p:cNvSpPr/>
-          <p:nvPr/>
-        </p:nvSpPr>
-        <p:spPr>
-          <a:xfrm>
-            <a:off x="822960" y="3419856"/>
-            <a:ext cx="10545775" cy="400000"/>
-          </a:xfrm>
-          <a:prstGeom prst="rect">
-            <a:avLst/>
-          </a:prstGeom>
-          <a:noFill/>
-          <a:ln/>
-        </p:spPr>
-        <p:txBody>
-          <a:bodyPr/>
-          <a:lstStyle/>
-          <a:p>
-            <a:endParaRPr lang="en-US" dirty="0"/>
-          </a:p>
-        </p:txBody>
-      </p:sp>
-      <p:sp>
-        <p:nvSpPr>
-          <p:cNvPr id="12" name="Text 9"/>
-          <p:cNvSpPr/>
-          <p:nvPr/>
-        </p:nvSpPr>
-        <p:spPr>
-          <a:xfrm>
-            <a:off x="932688" y="3419856"/>
-            <a:ext cx="3054005" cy="400000"/>
-          </a:xfrm>
-          <a:prstGeom prst="rect">
-            <a:avLst/>
-          </a:prstGeom>
-          <a:noFill/>
-          <a:ln/>
-        </p:spPr>
-        <p:txBody>
-          <a:bodyPr wrap="square" lIns="0" tIns="0" rIns="0" bIns="0" rtlCol="0" anchor="ctr"/>
-          <a:lstStyle/>
-          <a:p>
-            <a:pPr marL="0" indent="0">
-              <a:buNone/>
-            </a:pPr>
-            <a:r>
-              <a:rPr lang="en-US" sz="1300" b="1" dirty="0">
-                <a:solidFill>
-                  <a:srgbClr val="1A1A1A"/>
-                </a:solidFill>
-                <a:latin typeface="Calibri" pitchFamily="34" charset="0"/>
-                <a:ea typeface="Calibri" pitchFamily="34" charset="-122"/>
-                <a:cs typeface="Calibri" pitchFamily="34" charset="-120"/>
-              </a:rPr>
-              <a:t>JOB (job_num)</a:t>
-            </a:r>
-            <a:endParaRPr lang="en-US" sz="1300" dirty="0"/>
-          </a:p>
-        </p:txBody>
-      </p:sp>
-      <p:sp>
-        <p:nvSpPr>
-          <p:cNvPr id="13" name="Text 10"/>
-          <p:cNvSpPr/>
-          <p:nvPr/>
-        </p:nvSpPr>
-        <p:spPr>
-          <a:xfrm>
-            <a:off x="3986693" y="3419856"/>
-            <a:ext cx="7290603" cy="400000"/>
-          </a:xfrm>
-          <a:prstGeom prst="rect">
-            <a:avLst/>
-          </a:prstGeom>
-          <a:noFill/>
-          <a:ln/>
-        </p:spPr>
-        <p:txBody>
-          <a:bodyPr wrap="square" lIns="0" tIns="0" rIns="0" bIns="0" rtlCol="0" anchor="ctr"/>
-          <a:lstStyle/>
-          <a:p>
-            <a:pPr marL="0" indent="0">
-              <a:buNone/>
-            </a:pPr>
-            <a:r>
-              <a:rPr lang="en-US" sz="1300" dirty="0">
-                <a:solidFill>
-                  <a:srgbClr val="1A1A1A"/>
-                </a:solidFill>
-                <a:latin typeface="Calibri" pitchFamily="34" charset="0"/>
-                <a:ea typeface="Calibri" pitchFamily="34" charset="-122"/>
-                <a:cs typeface="Calibri" pitchFamily="34" charset="-120"/>
-              </a:rPr>
-              <a:t>Combo lookup (SLMatltrans/RefNum) — already built and on the form.</a:t>
-            </a:r>
-            <a:endParaRPr lang="en-US" sz="1300" dirty="0"/>
-          </a:p>
-        </p:txBody>
-      </p:sp>
-      <p:sp>
-        <p:nvSpPr>
-          <p:cNvPr id="14" name="Shape 11"/>
-          <p:cNvSpPr/>
-          <p:nvPr/>
-        </p:nvSpPr>
-        <p:spPr>
-          <a:xfrm>
-            <a:off x="822960" y="3819856"/>
             <a:ext cx="10545775" cy="0"/>
           </a:xfrm>
           <a:prstGeom prst="line">
@@ -10049,14 +9916,14 @@
       </p:sp>
       <p:sp>
         <p:nvSpPr>
-          <p:cNvPr id="27" name="Text 24"/>
-          <p:cNvSpPr/>
-          <p:nvPr/>
-        </p:nvSpPr>
-        <p:spPr>
-          <a:xfrm>
-            <a:off x="932688" y="3819856"/>
-            <a:ext cx="3054005" cy="400000"/>
+          <p:cNvPr id="303" name="Field Serial # (serial_num)"/>
+          <p:cNvSpPr/>
+          <p:nvPr/>
+        </p:nvSpPr>
+        <p:spPr>
+          <a:xfrm>
+            <a:off x="822960" y="3419856"/>
+            <a:ext cx="3163733" cy="400000"/>
           </a:xfrm>
           <a:prstGeom prst="rect">
             <a:avLst/>
@@ -10088,14 +9955,14 @@
       </p:sp>
       <p:sp>
         <p:nvSpPr>
-          <p:cNvPr id="28" name="Text 25"/>
-          <p:cNvSpPr/>
-          <p:nvPr/>
-        </p:nvSpPr>
-        <p:spPr>
-          <a:xfrm>
-            <a:off x="3986693" y="3819856"/>
-            <a:ext cx="7290603" cy="400000"/>
+          <p:cNvPr id="304" name="Desc Serial # (serial_num)"/>
+          <p:cNvSpPr/>
+          <p:nvPr/>
+        </p:nvSpPr>
+        <p:spPr>
+          <a:xfrm>
+            <a:off x="3986693" y="3419856"/>
+            <a:ext cx="7382043" cy="400000"/>
           </a:xfrm>
           <a:prstGeom prst="rect">
             <a:avLst/>
@@ -10127,13 +9994,13 @@
       </p:sp>
       <p:sp>
         <p:nvSpPr>
-          <p:cNvPr id="29" name="Shape 26"/>
-          <p:cNvSpPr/>
-          <p:nvPr/>
-        </p:nvSpPr>
-        <p:spPr>
-          <a:xfrm>
-            <a:off x="822960" y="4219856"/>
+          <p:cNvPr id="305" name="Divider Serial # (serial_num)"/>
+          <p:cNvSpPr/>
+          <p:nvPr/>
+        </p:nvSpPr>
+        <p:spPr>
+          <a:xfrm>
+            <a:off x="822960" y="3819856"/>
             <a:ext cx="10545775" cy="0"/>
           </a:xfrm>
           <a:prstGeom prst="line">
@@ -10157,14 +10024,14 @@
       </p:sp>
       <p:sp>
         <p:nvSpPr>
-          <p:cNvPr id="15" name="Text 12"/>
-          <p:cNvSpPr/>
-          <p:nvPr/>
-        </p:nvSpPr>
-        <p:spPr>
-          <a:xfrm>
-            <a:off x="932688" y="4219856"/>
-            <a:ext cx="3054005" cy="400000"/>
+          <p:cNvPr id="306" name="Field Lot # (lot_num)"/>
+          <p:cNvSpPr/>
+          <p:nvPr/>
+        </p:nvSpPr>
+        <p:spPr>
+          <a:xfrm>
+            <a:off x="822960" y="3819856"/>
+            <a:ext cx="3163733" cy="400000"/>
           </a:xfrm>
           <a:prstGeom prst="rect">
             <a:avLst/>
@@ -10196,14 +10063,14 @@
       </p:sp>
       <p:sp>
         <p:nvSpPr>
-          <p:cNvPr id="16" name="Text 13"/>
-          <p:cNvSpPr/>
-          <p:nvPr/>
-        </p:nvSpPr>
-        <p:spPr>
-          <a:xfrm>
-            <a:off x="3986693" y="4219856"/>
-            <a:ext cx="7290603" cy="400000"/>
+          <p:cNvPr id="307" name="Desc Lot # (lot_num)"/>
+          <p:cNvSpPr/>
+          <p:nvPr/>
+        </p:nvSpPr>
+        <p:spPr>
+          <a:xfrm>
+            <a:off x="3986693" y="3819856"/>
+            <a:ext cx="7382043" cy="400000"/>
           </a:xfrm>
           <a:prstGeom prst="rect">
             <a:avLst/>
@@ -10235,13 +10102,13 @@
       </p:sp>
       <p:sp>
         <p:nvSpPr>
-          <p:cNvPr id="17" name="Shape 14"/>
-          <p:cNvSpPr/>
-          <p:nvPr/>
-        </p:nvSpPr>
-        <p:spPr>
-          <a:xfrm>
-            <a:off x="822960" y="4619856"/>
+          <p:cNvPr id="308" name="Divider Lot # (lot_num)"/>
+          <p:cNvSpPr/>
+          <p:nvPr/>
+        </p:nvSpPr>
+        <p:spPr>
+          <a:xfrm>
+            <a:off x="822960" y="4219856"/>
             <a:ext cx="10545775" cy="0"/>
           </a:xfrm>
           <a:prstGeom prst="line">
@@ -10265,14 +10132,14 @@
       </p:sp>
       <p:sp>
         <p:nvSpPr>
-          <p:cNvPr id="18" name="Text 15"/>
-          <p:cNvSpPr/>
-          <p:nvPr/>
-        </p:nvSpPr>
-        <p:spPr>
-          <a:xfrm>
-            <a:off x="932688" y="4619856"/>
-            <a:ext cx="3054005" cy="400000"/>
+          <p:cNvPr id="309" name="Field Top Level PN (top_level_pn)"/>
+          <p:cNvSpPr/>
+          <p:nvPr/>
+        </p:nvSpPr>
+        <p:spPr>
+          <a:xfrm>
+            <a:off x="822960" y="4219856"/>
+            <a:ext cx="3163733" cy="400000"/>
           </a:xfrm>
           <a:prstGeom prst="rect">
             <a:avLst/>
@@ -10296,7 +10163,7 @@
                 <a:ea typeface="Calibri" pitchFamily="34" charset="-122"/>
                 <a:cs typeface="Calibri" pitchFamily="34" charset="-120"/>
               </a:rPr>
-              <a:t>Top Level PN</a:t>
+              <a:t>Top Level PN (top_level_pn)</a:t>
             </a:r>
             <a:endParaRPr lang="en-US" sz="1300" dirty="0"/>
           </a:p>
@@ -10304,14 +10171,14 @@
       </p:sp>
       <p:sp>
         <p:nvSpPr>
-          <p:cNvPr id="19" name="Text 16"/>
-          <p:cNvSpPr/>
-          <p:nvPr/>
-        </p:nvSpPr>
-        <p:spPr>
-          <a:xfrm>
-            <a:off x="3986693" y="4619856"/>
-            <a:ext cx="7290603" cy="400000"/>
+          <p:cNvPr id="310" name="Desc Top Level PN (top_level_pn)"/>
+          <p:cNvSpPr/>
+          <p:nvPr/>
+        </p:nvSpPr>
+        <p:spPr>
+          <a:xfrm>
+            <a:off x="3986693" y="4219856"/>
+            <a:ext cx="7382043" cy="400000"/>
           </a:xfrm>
           <a:prstGeom prst="rect">
             <a:avLst/>
@@ -10335,7 +10202,7 @@
                 <a:ea typeface="Calibri" pitchFamily="34" charset="-122"/>
                 <a:cs typeface="Calibri" pitchFamily="34" charset="-120"/>
               </a:rPr>
-              <a:t>Not yet built — needs a new column, IDO property, and form control.</a:t>
+              <a:t>Free-text field (char, 30) — built, highlighted on the form as a new field.</a:t>
             </a:r>
             <a:endParaRPr lang="en-US" sz="1300" dirty="0"/>
           </a:p>
@@ -10343,13 +10210,13 @@
       </p:sp>
       <p:sp>
         <p:nvSpPr>
-          <p:cNvPr id="20" name="Shape 17"/>
-          <p:cNvSpPr/>
-          <p:nvPr/>
-        </p:nvSpPr>
-        <p:spPr>
-          <a:xfrm>
-            <a:off x="822960" y="5019856"/>
+          <p:cNvPr id="311" name="Divider Top Level PN (top_level_pn)"/>
+          <p:cNvSpPr/>
+          <p:nvPr/>
+        </p:nvSpPr>
+        <p:spPr>
+          <a:xfrm>
+            <a:off x="822960" y="4619856"/>
             <a:ext cx="10545775" cy="0"/>
           </a:xfrm>
           <a:prstGeom prst="line">
@@ -10373,14 +10240,14 @@
       </p:sp>
       <p:sp>
         <p:nvSpPr>
-          <p:cNvPr id="21" name="Text 18"/>
-          <p:cNvSpPr/>
-          <p:nvPr/>
-        </p:nvSpPr>
-        <p:spPr>
-          <a:xfrm>
-            <a:off x="932688" y="5019856"/>
-            <a:ext cx="3054005" cy="400000"/>
+          <p:cNvPr id="312" name="Field Sub Assembly (sub_assembly)"/>
+          <p:cNvSpPr/>
+          <p:nvPr/>
+        </p:nvSpPr>
+        <p:spPr>
+          <a:xfrm>
+            <a:off x="822960" y="4619856"/>
+            <a:ext cx="3163733" cy="400000"/>
           </a:xfrm>
           <a:prstGeom prst="rect">
             <a:avLst/>
@@ -10404,7 +10271,7 @@
                 <a:ea typeface="Calibri" pitchFamily="34" charset="-122"/>
                 <a:cs typeface="Calibri" pitchFamily="34" charset="-120"/>
               </a:rPr>
-              <a:t>Sub Assembly</a:t>
+              <a:t>Sub Assembly (sub_assembly)</a:t>
             </a:r>
             <a:endParaRPr lang="en-US" sz="1300" dirty="0"/>
           </a:p>
@@ -10412,14 +10279,14 @@
       </p:sp>
       <p:sp>
         <p:nvSpPr>
-          <p:cNvPr id="22" name="Text 19"/>
-          <p:cNvSpPr/>
-          <p:nvPr/>
-        </p:nvSpPr>
-        <p:spPr>
-          <a:xfrm>
-            <a:off x="3986693" y="5019856"/>
-            <a:ext cx="7290603" cy="400000"/>
+          <p:cNvPr id="313" name="Desc Sub Assembly (sub_assembly)"/>
+          <p:cNvSpPr/>
+          <p:nvPr/>
+        </p:nvSpPr>
+        <p:spPr>
+          <a:xfrm>
+            <a:off x="3986693" y="4619856"/>
+            <a:ext cx="7382043" cy="400000"/>
           </a:xfrm>
           <a:prstGeom prst="rect">
             <a:avLst/>
@@ -10443,7 +10310,7 @@
                 <a:ea typeface="Calibri" pitchFamily="34" charset="-122"/>
                 <a:cs typeface="Calibri" pitchFamily="34" charset="-120"/>
               </a:rPr>
-              <a:t>Not yet built — open question whether this is the same concept as the existing next_assy_item (Next Level Assembly) or a distinct field.</a:t>
+              <a:t>Free-text field (char, 30), built distinct from Next Lvl Assy — still an open question whether they’re the same concept.</a:t>
             </a:r>
             <a:endParaRPr lang="en-US" sz="1300" dirty="0"/>
           </a:p>
@@ -10451,121 +10318,13 @@
       </p:sp>
       <p:sp>
         <p:nvSpPr>
-          <p:cNvPr id="23" name="Shape 20"/>
-          <p:cNvSpPr/>
-          <p:nvPr/>
-        </p:nvSpPr>
-        <p:spPr>
-          <a:xfrm>
-            <a:off x="822960" y="5419856"/>
-            <a:ext cx="10545775" cy="0"/>
-          </a:xfrm>
-          <a:prstGeom prst="line">
-            <a:avLst/>
-          </a:prstGeom>
-          <a:noFill/>
-          <a:ln w="9525">
-            <a:solidFill>
-              <a:srgbClr val="E5E5E5"/>
-            </a:solidFill>
-            <a:prstDash val="solid"/>
-          </a:ln>
-        </p:spPr>
-        <p:txBody>
-          <a:bodyPr/>
-          <a:lstStyle/>
-          <a:p>
-            <a:endParaRPr lang="en-US" dirty="0"/>
-          </a:p>
-        </p:txBody>
-      </p:sp>
-      <p:sp>
-        <p:nvSpPr>
-          <p:cNvPr id="24" name="Text 21"/>
-          <p:cNvSpPr/>
-          <p:nvPr/>
-        </p:nvSpPr>
-        <p:spPr>
-          <a:xfrm>
-            <a:off x="932688" y="5419856"/>
-            <a:ext cx="3054005" cy="400000"/>
-          </a:xfrm>
-          <a:prstGeom prst="rect">
-            <a:avLst/>
-          </a:prstGeom>
-          <a:noFill/>
-          <a:ln/>
-        </p:spPr>
-        <p:txBody>
-          <a:bodyPr wrap="square" lIns="0" tIns="0" rIns="0" bIns="0" rtlCol="0" anchor="ctr"/>
-          <a:lstStyle/>
-          <a:p>
-            <a:pPr marL="0" indent="0">
-              <a:buNone/>
-            </a:pPr>
-            <a:r>
-              <a:rPr lang="en-US" sz="1300" b="1" dirty="0">
-                <a:solidFill>
-                  <a:srgbClr val="1A1A1A"/>
-                </a:solidFill>
-                <a:latin typeface="Calibri" pitchFamily="34" charset="0"/>
-                <a:ea typeface="Calibri" pitchFamily="34" charset="-122"/>
-                <a:cs typeface="Calibri" pitchFamily="34" charset="-120"/>
-              </a:rPr>
-              <a:t>Part (item)</a:t>
-            </a:r>
-            <a:endParaRPr lang="en-US" sz="1300" dirty="0"/>
-          </a:p>
-        </p:txBody>
-      </p:sp>
-      <p:sp>
-        <p:nvSpPr>
-          <p:cNvPr id="25" name="Text 22"/>
-          <p:cNvSpPr/>
-          <p:nvPr/>
-        </p:nvSpPr>
-        <p:spPr>
-          <a:xfrm>
-            <a:off x="3986693" y="5419856"/>
-            <a:ext cx="7290603" cy="400000"/>
-          </a:xfrm>
-          <a:prstGeom prst="rect">
-            <a:avLst/>
-          </a:prstGeom>
-          <a:noFill/>
-          <a:ln/>
-        </p:spPr>
-        <p:txBody>
-          <a:bodyPr wrap="square" lIns="0" tIns="0" rIns="0" bIns="0" rtlCol="0" anchor="ctr"/>
-          <a:lstStyle/>
-          <a:p>
-            <a:pPr marL="0" indent="0">
-              <a:buNone/>
-            </a:pPr>
-            <a:r>
-              <a:rPr lang="en-US" sz="1300" dirty="0">
-                <a:solidFill>
-                  <a:srgbClr val="1A1A1A"/>
-                </a:solidFill>
-                <a:latin typeface="Calibri" pitchFamily="34" charset="0"/>
-                <a:ea typeface="Calibri" pitchFamily="34" charset="-122"/>
-                <a:cs typeface="Calibri" pitchFamily="34" charset="-120"/>
-              </a:rPr>
-              <a:t>Already built as the Item combo — covered on the previous Design slide.</a:t>
-            </a:r>
-            <a:endParaRPr lang="en-US" sz="1300" dirty="0"/>
-          </a:p>
-        </p:txBody>
-      </p:sp>
-      <p:sp>
-        <p:nvSpPr>
-          <p:cNvPr id="101" name="Shape 101"/>
-          <p:cNvSpPr/>
-          <p:nvPr/>
-        </p:nvSpPr>
-        <p:spPr>
-          <a:xfrm>
-            <a:off x="822960" y="5819856"/>
+          <p:cNvPr id="314" name="Divider Sub Assembly (sub_assembly)"/>
+          <p:cNvSpPr/>
+          <p:nvPr/>
+        </p:nvSpPr>
+        <p:spPr>
+          <a:xfrm>
+            <a:off x="822960" y="5019856"/>
             <a:ext cx="10545775" cy="0"/>
           </a:xfrm>
           <a:prstGeom prst="line">

</xml_diff>